<commit_message>
[codex/senspy-sensometrics-poster · Batch 4/4] Increase poster readability
</commit_message>
<xml_diff>
--- a/poster/print_artifacts/senspy-sensometrics-2026-poster.pptx
+++ b/poster/print_artifacts/senspy-sensometrics-2026-poster.pptx
@@ -3342,8 +3342,8 @@
         </p:nvSpPr>
         <p:spPr>
           <a:xfrm>
-            <a:off x="19659600" y="566928"/>
-            <a:ext cx="4389120" cy="457200"/>
+            <a:off x="19110960" y="566928"/>
+            <a:ext cx="4937760" cy="457200"/>
           </a:xfrm>
           <a:prstGeom prst="rect">
             <a:avLst/>
@@ -3360,7 +3360,7 @@
               <a:spcAft>
                 <a:spcPts val="400"/>
               </a:spcAft>
-              <a:defRPr sz="1150" b="0" i="0">
+              <a:defRPr sz="1550" b="0" i="0">
                 <a:solidFill>
                   <a:srgbClr val="526057"/>
                 </a:solidFill>
@@ -3425,7 +3425,7 @@
         <p:spPr>
           <a:xfrm>
             <a:off x="777240" y="4407408"/>
-            <a:ext cx="11695176" cy="411480"/>
+            <a:ext cx="11695176" cy="502920"/>
           </a:xfrm>
           <a:prstGeom prst="rect">
             <a:avLst/>
@@ -3442,7 +3442,7 @@
               <a:spcAft>
                 <a:spcPts val="400"/>
               </a:spcAft>
-              <a:defRPr sz="2400" b="0" i="0">
+              <a:defRPr sz="2900" b="0" i="0">
                 <a:solidFill>
                   <a:srgbClr val="10231A"/>
                 </a:solidFill>
@@ -3463,7 +3463,7 @@
         </p:nvSpPr>
         <p:spPr>
           <a:xfrm>
-            <a:off x="822960" y="4965192"/>
+            <a:off x="822960" y="5056632"/>
             <a:ext cx="11603736" cy="1051560"/>
           </a:xfrm>
           <a:prstGeom prst="rect">
@@ -3481,7 +3481,7 @@
               <a:spcAft>
                 <a:spcPts val="400"/>
               </a:spcAft>
-              <a:defRPr sz="1800" b="0" i="0">
+              <a:defRPr sz="2100" b="0" i="0">
                 <a:solidFill>
                   <a:srgbClr val="17291F"/>
                 </a:solidFill>
@@ -3502,7 +3502,7 @@
         </p:nvSpPr>
         <p:spPr>
           <a:xfrm>
-            <a:off x="960120" y="6153912"/>
+            <a:off x="960120" y="6382512"/>
             <a:ext cx="5573268" cy="1325880"/>
           </a:xfrm>
           <a:prstGeom prst="roundRect">
@@ -3547,7 +3547,7 @@
         </p:nvSpPr>
         <p:spPr>
           <a:xfrm>
-            <a:off x="1161288" y="6318504"/>
+            <a:off x="1161288" y="6547104"/>
             <a:ext cx="5170931" cy="320040"/>
           </a:xfrm>
           <a:prstGeom prst="rect">
@@ -3565,7 +3565,7 @@
               <a:spcAft>
                 <a:spcPts val="400"/>
               </a:spcAft>
-              <a:defRPr sz="1400" b="1" i="0">
+              <a:defRPr sz="1700" b="1" i="0">
                 <a:solidFill>
                   <a:srgbClr val="C7563F"/>
                 </a:solidFill>
@@ -3586,7 +3586,7 @@
         </p:nvSpPr>
         <p:spPr>
           <a:xfrm>
-            <a:off x="1252728" y="6684264"/>
+            <a:off x="1252728" y="6949440"/>
             <a:ext cx="4988052" cy="667512"/>
           </a:xfrm>
           <a:prstGeom prst="rect">
@@ -3604,7 +3604,7 @@
               <a:spcAft>
                 <a:spcPts val="400"/>
               </a:spcAft>
-              <a:defRPr sz="1400" b="0" i="0">
+              <a:defRPr sz="1630" b="0" i="0">
                 <a:solidFill>
                   <a:srgbClr val="17291F"/>
                 </a:solidFill>
@@ -3612,7 +3612,7 @@
               </a:defRPr>
             </a:pPr>
             <a:r>
-              <a:t>Preserve sensR's numerical contract and protocol vocabulary.</a:t>
+              <a:t>Preserve the sensR numerical contract.</a:t>
             </a:r>
           </a:p>
         </p:txBody>
@@ -3625,7 +3625,7 @@
         </p:nvSpPr>
         <p:spPr>
           <a:xfrm>
-            <a:off x="6716268" y="6153912"/>
+            <a:off x="6716268" y="6382512"/>
             <a:ext cx="5573268" cy="1325880"/>
           </a:xfrm>
           <a:prstGeom prst="roundRect">
@@ -3670,7 +3670,7 @@
         </p:nvSpPr>
         <p:spPr>
           <a:xfrm>
-            <a:off x="6917436" y="6318504"/>
+            <a:off x="6917436" y="6547104"/>
             <a:ext cx="5170931" cy="320040"/>
           </a:xfrm>
           <a:prstGeom prst="rect">
@@ -3688,7 +3688,7 @@
               <a:spcAft>
                 <a:spcPts val="400"/>
               </a:spcAft>
-              <a:defRPr sz="1400" b="1" i="0">
+              <a:defRPr sz="1700" b="1" i="0">
                 <a:solidFill>
                   <a:srgbClr val="C7563F"/>
                 </a:solidFill>
@@ -3709,7 +3709,7 @@
         </p:nvSpPr>
         <p:spPr>
           <a:xfrm>
-            <a:off x="7008876" y="6684264"/>
+            <a:off x="7008876" y="6949440"/>
             <a:ext cx="4988052" cy="667512"/>
           </a:xfrm>
           <a:prstGeom prst="rect">
@@ -3727,7 +3727,7 @@
               <a:spcAft>
                 <a:spcPts val="400"/>
               </a:spcAft>
-              <a:defRPr sz="1400" b="0" i="0">
+              <a:defRPr sz="1630" b="0" i="0">
                 <a:solidFill>
                   <a:srgbClr val="17291F"/>
                 </a:solidFill>
@@ -3735,7 +3735,7 @@
               </a:defRPr>
             </a:pPr>
             <a:r>
-              <a:t>Return typed objects, plots, and planning tools in one ecosystem.</a:t>
+              <a:t>Typed objects, plots, and planning tools.</a:t>
             </a:r>
           </a:p>
         </p:txBody>
@@ -3748,7 +3748,7 @@
         </p:nvSpPr>
         <p:spPr>
           <a:xfrm>
-            <a:off x="914400" y="7772400"/>
+            <a:off x="914400" y="8010144"/>
             <a:ext cx="11420855" cy="731520"/>
           </a:xfrm>
           <a:prstGeom prst="rect">
@@ -3766,7 +3766,7 @@
               <a:spcAft>
                 <a:spcPts val="400"/>
               </a:spcAft>
-              <a:defRPr sz="1650" b="1" i="0">
+              <a:defRPr sz="1900" b="1" i="0">
                 <a:solidFill>
                   <a:srgbClr val="C7563F"/>
                 </a:solidFill>
@@ -3831,7 +3831,7 @@
         <p:spPr>
           <a:xfrm>
             <a:off x="12975336" y="4407408"/>
-            <a:ext cx="11695176" cy="411480"/>
+            <a:ext cx="11695176" cy="502920"/>
           </a:xfrm>
           <a:prstGeom prst="rect">
             <a:avLst/>
@@ -3848,7 +3848,7 @@
               <a:spcAft>
                 <a:spcPts val="400"/>
               </a:spcAft>
-              <a:defRPr sz="2400" b="0" i="0">
+              <a:defRPr sz="2900" b="0" i="0">
                 <a:solidFill>
                   <a:srgbClr val="10231A"/>
                 </a:solidFill>
@@ -3869,8 +3869,8 @@
         </p:nvSpPr>
         <p:spPr>
           <a:xfrm>
-            <a:off x="13021056" y="5010912"/>
-            <a:ext cx="3730751" cy="1234440"/>
+            <a:off x="13021056" y="5102352"/>
+            <a:ext cx="3730751" cy="1325880"/>
           </a:xfrm>
           <a:prstGeom prst="roundRect">
             <a:avLst/>
@@ -3914,8 +3914,8 @@
         </p:nvSpPr>
         <p:spPr>
           <a:xfrm>
-            <a:off x="13075920" y="5102351"/>
-            <a:ext cx="3621023" cy="384048"/>
+            <a:off x="13075920" y="5175504"/>
+            <a:ext cx="3621023" cy="475488"/>
           </a:xfrm>
           <a:prstGeom prst="rect">
             <a:avLst/>
@@ -3932,7 +3932,7 @@
               <a:spcAft>
                 <a:spcPts val="400"/>
               </a:spcAft>
-              <a:defRPr sz="2300" b="1" i="0">
+              <a:defRPr sz="3000" b="1" i="0">
                 <a:solidFill>
                   <a:srgbClr val="C7563F"/>
                 </a:solidFill>
@@ -3953,8 +3953,8 @@
         </p:nvSpPr>
         <p:spPr>
           <a:xfrm>
-            <a:off x="13112496" y="5568696"/>
-            <a:ext cx="3547871" cy="310896"/>
+            <a:off x="13112496" y="5769864"/>
+            <a:ext cx="3547871" cy="365760"/>
           </a:xfrm>
           <a:prstGeom prst="rect">
             <a:avLst/>
@@ -3971,7 +3971,7 @@
               <a:spcAft>
                 <a:spcPts val="400"/>
               </a:spcAft>
-              <a:defRPr sz="1120" b="1" i="0">
+              <a:defRPr sz="1420" b="1" i="0">
                 <a:solidFill>
                   <a:srgbClr val="17291F"/>
                 </a:solidFill>
@@ -3992,8 +3992,8 @@
         </p:nvSpPr>
         <p:spPr>
           <a:xfrm>
-            <a:off x="13130784" y="5907023"/>
-            <a:ext cx="3511295" cy="292608"/>
+            <a:off x="13130784" y="6172200"/>
+            <a:ext cx="3511295" cy="256032"/>
           </a:xfrm>
           <a:prstGeom prst="rect">
             <a:avLst/>
@@ -4010,7 +4010,7 @@
               <a:spcAft>
                 <a:spcPts val="400"/>
               </a:spcAft>
-              <a:defRPr sz="880" b="0" i="0">
+              <a:defRPr sz="1250" b="0" i="0">
                 <a:solidFill>
                   <a:srgbClr val="4D5A52"/>
                 </a:solidFill>
@@ -4031,8 +4031,8 @@
         </p:nvSpPr>
         <p:spPr>
           <a:xfrm>
-            <a:off x="16957548" y="5010912"/>
-            <a:ext cx="3730751" cy="1234440"/>
+            <a:off x="16957548" y="5102352"/>
+            <a:ext cx="3730751" cy="1325880"/>
           </a:xfrm>
           <a:prstGeom prst="roundRect">
             <a:avLst/>
@@ -4076,8 +4076,8 @@
         </p:nvSpPr>
         <p:spPr>
           <a:xfrm>
-            <a:off x="17012411" y="5102351"/>
-            <a:ext cx="3621023" cy="384048"/>
+            <a:off x="17012411" y="5175504"/>
+            <a:ext cx="3621023" cy="475488"/>
           </a:xfrm>
           <a:prstGeom prst="rect">
             <a:avLst/>
@@ -4094,7 +4094,7 @@
               <a:spcAft>
                 <a:spcPts val="400"/>
               </a:spcAft>
-              <a:defRPr sz="2300" b="1" i="0">
+              <a:defRPr sz="3000" b="1" i="0">
                 <a:solidFill>
                   <a:srgbClr val="4C8A61"/>
                 </a:solidFill>
@@ -4115,8 +4115,8 @@
         </p:nvSpPr>
         <p:spPr>
           <a:xfrm>
-            <a:off x="17048988" y="5568696"/>
-            <a:ext cx="3547871" cy="310896"/>
+            <a:off x="17048988" y="5769864"/>
+            <a:ext cx="3547871" cy="365760"/>
           </a:xfrm>
           <a:prstGeom prst="rect">
             <a:avLst/>
@@ -4133,7 +4133,7 @@
               <a:spcAft>
                 <a:spcPts val="400"/>
               </a:spcAft>
-              <a:defRPr sz="1120" b="1" i="0">
+              <a:defRPr sz="1420" b="1" i="0">
                 <a:solidFill>
                   <a:srgbClr val="17291F"/>
                 </a:solidFill>
@@ -4154,8 +4154,8 @@
         </p:nvSpPr>
         <p:spPr>
           <a:xfrm>
-            <a:off x="17067276" y="5907023"/>
-            <a:ext cx="3511295" cy="292608"/>
+            <a:off x="17067276" y="6172200"/>
+            <a:ext cx="3511295" cy="256032"/>
           </a:xfrm>
           <a:prstGeom prst="rect">
             <a:avLst/>
@@ -4172,7 +4172,7 @@
               <a:spcAft>
                 <a:spcPts val="400"/>
               </a:spcAft>
-              <a:defRPr sz="880" b="0" i="0">
+              <a:defRPr sz="1250" b="0" i="0">
                 <a:solidFill>
                   <a:srgbClr val="4D5A52"/>
                 </a:solidFill>
@@ -4193,8 +4193,8 @@
         </p:nvSpPr>
         <p:spPr>
           <a:xfrm>
-            <a:off x="20894039" y="5010912"/>
-            <a:ext cx="3730751" cy="1234440"/>
+            <a:off x="20894039" y="5102352"/>
+            <a:ext cx="3730751" cy="1325880"/>
           </a:xfrm>
           <a:prstGeom prst="roundRect">
             <a:avLst/>
@@ -4238,8 +4238,8 @@
         </p:nvSpPr>
         <p:spPr>
           <a:xfrm>
-            <a:off x="20948903" y="5102351"/>
-            <a:ext cx="3621023" cy="384048"/>
+            <a:off x="20948903" y="5175504"/>
+            <a:ext cx="3621023" cy="475488"/>
           </a:xfrm>
           <a:prstGeom prst="rect">
             <a:avLst/>
@@ -4256,7 +4256,7 @@
               <a:spcAft>
                 <a:spcPts val="400"/>
               </a:spcAft>
-              <a:defRPr sz="2300" b="1" i="0">
+              <a:defRPr sz="3000" b="1" i="0">
                 <a:solidFill>
                   <a:srgbClr val="C7563F"/>
                 </a:solidFill>
@@ -4277,8 +4277,8 @@
         </p:nvSpPr>
         <p:spPr>
           <a:xfrm>
-            <a:off x="20985480" y="5568696"/>
-            <a:ext cx="3547871" cy="310896"/>
+            <a:off x="20985480" y="5769864"/>
+            <a:ext cx="3547871" cy="365760"/>
           </a:xfrm>
           <a:prstGeom prst="rect">
             <a:avLst/>
@@ -4295,7 +4295,7 @@
               <a:spcAft>
                 <a:spcPts val="400"/>
               </a:spcAft>
-              <a:defRPr sz="1120" b="1" i="0">
+              <a:defRPr sz="1420" b="1" i="0">
                 <a:solidFill>
                   <a:srgbClr val="17291F"/>
                 </a:solidFill>
@@ -4316,8 +4316,8 @@
         </p:nvSpPr>
         <p:spPr>
           <a:xfrm>
-            <a:off x="21003768" y="5907023"/>
-            <a:ext cx="3511295" cy="292608"/>
+            <a:off x="21003768" y="6172200"/>
+            <a:ext cx="3511295" cy="256032"/>
           </a:xfrm>
           <a:prstGeom prst="rect">
             <a:avLst/>
@@ -4334,7 +4334,7 @@
               <a:spcAft>
                 <a:spcPts val="400"/>
               </a:spcAft>
-              <a:defRPr sz="880" b="0" i="0">
+              <a:defRPr sz="1250" b="0" i="0">
                 <a:solidFill>
                   <a:srgbClr val="4D5A52"/>
                 </a:solidFill>
@@ -4355,8 +4355,8 @@
         </p:nvSpPr>
         <p:spPr>
           <a:xfrm>
-            <a:off x="13021056" y="6446520"/>
-            <a:ext cx="3730751" cy="1234440"/>
+            <a:off x="13021056" y="6638544"/>
+            <a:ext cx="3730751" cy="1325880"/>
           </a:xfrm>
           <a:prstGeom prst="roundRect">
             <a:avLst/>
@@ -4400,8 +4400,8 @@
         </p:nvSpPr>
         <p:spPr>
           <a:xfrm>
-            <a:off x="13075920" y="6537959"/>
-            <a:ext cx="3621023" cy="384048"/>
+            <a:off x="13075920" y="6711696"/>
+            <a:ext cx="3621023" cy="475488"/>
           </a:xfrm>
           <a:prstGeom prst="rect">
             <a:avLst/>
@@ -4418,7 +4418,7 @@
               <a:spcAft>
                 <a:spcPts val="400"/>
               </a:spcAft>
-              <a:defRPr sz="2300" b="1" i="0">
+              <a:defRPr sz="3000" b="1" i="0">
                 <a:solidFill>
                   <a:srgbClr val="4C8A61"/>
                 </a:solidFill>
@@ -4439,8 +4439,8 @@
         </p:nvSpPr>
         <p:spPr>
           <a:xfrm>
-            <a:off x="13112496" y="7004304"/>
-            <a:ext cx="3547871" cy="310896"/>
+            <a:off x="13112496" y="7306056"/>
+            <a:ext cx="3547871" cy="365760"/>
           </a:xfrm>
           <a:prstGeom prst="rect">
             <a:avLst/>
@@ -4457,7 +4457,7 @@
               <a:spcAft>
                 <a:spcPts val="400"/>
               </a:spcAft>
-              <a:defRPr sz="1120" b="1" i="0">
+              <a:defRPr sz="1420" b="1" i="0">
                 <a:solidFill>
                   <a:srgbClr val="17291F"/>
                 </a:solidFill>
@@ -4478,8 +4478,8 @@
         </p:nvSpPr>
         <p:spPr>
           <a:xfrm>
-            <a:off x="13130784" y="7342631"/>
-            <a:ext cx="3511295" cy="292608"/>
+            <a:off x="13130784" y="7708392"/>
+            <a:ext cx="3511295" cy="256032"/>
           </a:xfrm>
           <a:prstGeom prst="rect">
             <a:avLst/>
@@ -4496,7 +4496,7 @@
               <a:spcAft>
                 <a:spcPts val="400"/>
               </a:spcAft>
-              <a:defRPr sz="880" b="0" i="0">
+              <a:defRPr sz="1250" b="0" i="0">
                 <a:solidFill>
                   <a:srgbClr val="4D5A52"/>
                 </a:solidFill>
@@ -4517,8 +4517,8 @@
         </p:nvSpPr>
         <p:spPr>
           <a:xfrm>
-            <a:off x="16957548" y="6446520"/>
-            <a:ext cx="3730751" cy="1234440"/>
+            <a:off x="16957548" y="6638544"/>
+            <a:ext cx="3730751" cy="1325880"/>
           </a:xfrm>
           <a:prstGeom prst="roundRect">
             <a:avLst/>
@@ -4562,8 +4562,8 @@
         </p:nvSpPr>
         <p:spPr>
           <a:xfrm>
-            <a:off x="17012411" y="6537959"/>
-            <a:ext cx="3621023" cy="384048"/>
+            <a:off x="17012411" y="6711696"/>
+            <a:ext cx="3621023" cy="475488"/>
           </a:xfrm>
           <a:prstGeom prst="rect">
             <a:avLst/>
@@ -4580,7 +4580,7 @@
               <a:spcAft>
                 <a:spcPts val="400"/>
               </a:spcAft>
-              <a:defRPr sz="2300" b="1" i="0">
+              <a:defRPr sz="3000" b="1" i="0">
                 <a:solidFill>
                   <a:srgbClr val="4C8A61"/>
                 </a:solidFill>
@@ -4601,8 +4601,8 @@
         </p:nvSpPr>
         <p:spPr>
           <a:xfrm>
-            <a:off x="17048988" y="7004304"/>
-            <a:ext cx="3547871" cy="310896"/>
+            <a:off x="17048988" y="7306056"/>
+            <a:ext cx="3547871" cy="365760"/>
           </a:xfrm>
           <a:prstGeom prst="rect">
             <a:avLst/>
@@ -4619,7 +4619,7 @@
               <a:spcAft>
                 <a:spcPts val="400"/>
               </a:spcAft>
-              <a:defRPr sz="1120" b="1" i="0">
+              <a:defRPr sz="1420" b="1" i="0">
                 <a:solidFill>
                   <a:srgbClr val="17291F"/>
                 </a:solidFill>
@@ -4640,8 +4640,8 @@
         </p:nvSpPr>
         <p:spPr>
           <a:xfrm>
-            <a:off x="17067276" y="7342631"/>
-            <a:ext cx="3511295" cy="292608"/>
+            <a:off x="17067276" y="7708392"/>
+            <a:ext cx="3511295" cy="256032"/>
           </a:xfrm>
           <a:prstGeom prst="rect">
             <a:avLst/>
@@ -4658,7 +4658,7 @@
               <a:spcAft>
                 <a:spcPts val="400"/>
               </a:spcAft>
-              <a:defRPr sz="880" b="0" i="0">
+              <a:defRPr sz="1250" b="0" i="0">
                 <a:solidFill>
                   <a:srgbClr val="4D5A52"/>
                 </a:solidFill>
@@ -4679,8 +4679,8 @@
         </p:nvSpPr>
         <p:spPr>
           <a:xfrm>
-            <a:off x="20894039" y="6446520"/>
-            <a:ext cx="3730751" cy="1234440"/>
+            <a:off x="20894039" y="6638544"/>
+            <a:ext cx="3730751" cy="1325880"/>
           </a:xfrm>
           <a:prstGeom prst="roundRect">
             <a:avLst/>
@@ -4724,8 +4724,8 @@
         </p:nvSpPr>
         <p:spPr>
           <a:xfrm>
-            <a:off x="20948903" y="6537959"/>
-            <a:ext cx="3621023" cy="384048"/>
+            <a:off x="20948903" y="6711696"/>
+            <a:ext cx="3621023" cy="475488"/>
           </a:xfrm>
           <a:prstGeom prst="rect">
             <a:avLst/>
@@ -4742,7 +4742,7 @@
               <a:spcAft>
                 <a:spcPts val="400"/>
               </a:spcAft>
-              <a:defRPr sz="2300" b="1" i="0">
+              <a:defRPr sz="3000" b="1" i="0">
                 <a:solidFill>
                   <a:srgbClr val="C7563F"/>
                 </a:solidFill>
@@ -4763,8 +4763,8 @@
         </p:nvSpPr>
         <p:spPr>
           <a:xfrm>
-            <a:off x="20985480" y="7004304"/>
-            <a:ext cx="3547871" cy="310896"/>
+            <a:off x="20985480" y="7306056"/>
+            <a:ext cx="3547871" cy="365760"/>
           </a:xfrm>
           <a:prstGeom prst="rect">
             <a:avLst/>
@@ -4781,7 +4781,7 @@
               <a:spcAft>
                 <a:spcPts val="400"/>
               </a:spcAft>
-              <a:defRPr sz="1120" b="1" i="0">
+              <a:defRPr sz="1420" b="1" i="0">
                 <a:solidFill>
                   <a:srgbClr val="17291F"/>
                 </a:solidFill>
@@ -4802,8 +4802,8 @@
         </p:nvSpPr>
         <p:spPr>
           <a:xfrm>
-            <a:off x="21003768" y="7342631"/>
-            <a:ext cx="3511295" cy="292608"/>
+            <a:off x="21003768" y="7708392"/>
+            <a:ext cx="3511295" cy="256032"/>
           </a:xfrm>
           <a:prstGeom prst="rect">
             <a:avLst/>
@@ -4820,7 +4820,7 @@
               <a:spcAft>
                 <a:spcPts val="400"/>
               </a:spcAft>
-              <a:defRPr sz="880" b="0" i="0">
+              <a:defRPr sz="1250" b="0" i="0">
                 <a:solidFill>
                   <a:srgbClr val="4D5A52"/>
                 </a:solidFill>
@@ -4841,7 +4841,7 @@
         </p:nvSpPr>
         <p:spPr>
           <a:xfrm>
-            <a:off x="13139928" y="7955279"/>
+            <a:off x="13139928" y="8266176"/>
             <a:ext cx="11365992" cy="502920"/>
           </a:xfrm>
           <a:prstGeom prst="rect">
@@ -4859,7 +4859,7 @@
               <a:spcAft>
                 <a:spcPts val="400"/>
               </a:spcAft>
-              <a:defRPr sz="1500" b="1" i="0">
+              <a:defRPr sz="1750" b="1" i="0">
                 <a:solidFill>
                   <a:srgbClr val="17291F"/>
                 </a:solidFill>
@@ -4924,7 +4924,7 @@
         <p:spPr>
           <a:xfrm>
             <a:off x="777240" y="8933688"/>
-            <a:ext cx="11695176" cy="411480"/>
+            <a:ext cx="11695176" cy="502920"/>
           </a:xfrm>
           <a:prstGeom prst="rect">
             <a:avLst/>
@@ -4941,7 +4941,7 @@
               <a:spcAft>
                 <a:spcPts val="400"/>
               </a:spcAft>
-              <a:defRPr sz="2400" b="0" i="0">
+              <a:defRPr sz="2900" b="0" i="0">
                 <a:solidFill>
                   <a:srgbClr val="10231A"/>
                 </a:solidFill>
@@ -4970,8 +4970,8 @@
         </p:blipFill>
         <p:spPr>
           <a:xfrm>
-            <a:off x="3143367" y="9464040"/>
-            <a:ext cx="6962922" cy="4343400"/>
+            <a:off x="3410235" y="9555480"/>
+            <a:ext cx="6429186" cy="4343400"/>
           </a:xfrm>
           <a:prstGeom prst="rect">
             <a:avLst/>
@@ -4986,7 +4986,7 @@
         </p:nvSpPr>
         <p:spPr>
           <a:xfrm>
-            <a:off x="1005840" y="13926312"/>
+            <a:off x="1005840" y="14017752"/>
             <a:ext cx="11237976" cy="502920"/>
           </a:xfrm>
           <a:prstGeom prst="rect">
@@ -5004,7 +5004,7 @@
               <a:spcAft>
                 <a:spcPts val="400"/>
               </a:spcAft>
-              <a:defRPr sz="1350" b="0" i="0">
+              <a:defRPr sz="1600" b="0" i="0">
                 <a:solidFill>
                   <a:srgbClr val="4D5A52"/>
                 </a:solidFill>
@@ -5012,7 +5012,7 @@
               </a:defRPr>
             </a:pPr>
             <a:r>
-              <a:t>Forced-choice protocols share a common d-prime reporting scale while preserving each protocol's guessing structure.</a:t>
+              <a:t>Common d-prime scale, protocol-specific guessing.</a:t>
             </a:r>
           </a:p>
         </p:txBody>
@@ -5069,7 +5069,7 @@
         <p:spPr>
           <a:xfrm>
             <a:off x="12975336" y="8933688"/>
-            <a:ext cx="11695176" cy="411480"/>
+            <a:ext cx="11695176" cy="502920"/>
           </a:xfrm>
           <a:prstGeom prst="rect">
             <a:avLst/>
@@ -5086,7 +5086,7 @@
               <a:spcAft>
                 <a:spcPts val="400"/>
               </a:spcAft>
-              <a:defRPr sz="2400" b="0" i="0">
+              <a:defRPr sz="2900" b="0" i="0">
                 <a:solidFill>
                   <a:srgbClr val="10231A"/>
                 </a:solidFill>
@@ -5115,8 +5115,8 @@
         </p:blipFill>
         <p:spPr>
           <a:xfrm>
-            <a:off x="15640219" y="9464040"/>
-            <a:ext cx="6365409" cy="4370832"/>
+            <a:off x="15663551" y="9555480"/>
+            <a:ext cx="6318745" cy="4370832"/>
           </a:xfrm>
           <a:prstGeom prst="rect">
             <a:avLst/>
@@ -5131,7 +5131,7 @@
         </p:nvSpPr>
         <p:spPr>
           <a:xfrm>
-            <a:off x="13203936" y="13944600"/>
+            <a:off x="13203936" y="14036040"/>
             <a:ext cx="11237976" cy="457200"/>
           </a:xfrm>
           <a:prstGeom prst="rect">
@@ -5149,7 +5149,7 @@
               <a:spcAft>
                 <a:spcPts val="400"/>
               </a:spcAft>
-              <a:defRPr sz="1350" b="0" i="0">
+              <a:defRPr sz="1600" b="0" i="0">
                 <a:solidFill>
                   <a:srgbClr val="4D5A52"/>
                 </a:solidFill>
@@ -5157,7 +5157,7 @@
               </a:defRPr>
             </a:pPr>
             <a:r>
-              <a:t>One API maps Pc, Pd, and d-prime across sensory protocols.</a:t>
+              <a:t>One API maps Pc, Pd, and d-prime.</a:t>
             </a:r>
           </a:p>
         </p:txBody>
@@ -5214,7 +5214,7 @@
         <p:spPr>
           <a:xfrm>
             <a:off x="777240" y="14968728"/>
-            <a:ext cx="11695176" cy="411480"/>
+            <a:ext cx="11695176" cy="502920"/>
           </a:xfrm>
           <a:prstGeom prst="rect">
             <a:avLst/>
@@ -5231,7 +5231,7 @@
               <a:spcAft>
                 <a:spcPts val="400"/>
               </a:spcAft>
-              <a:defRPr sz="2400" b="0" i="0">
+              <a:defRPr sz="2900" b="0" i="0">
                 <a:solidFill>
                   <a:srgbClr val="10231A"/>
                 </a:solidFill>
@@ -5260,8 +5260,8 @@
         </p:blipFill>
         <p:spPr>
           <a:xfrm>
-            <a:off x="2955864" y="15499080"/>
-            <a:ext cx="7337928" cy="4526280"/>
+            <a:off x="2644389" y="15590520"/>
+            <a:ext cx="7960877" cy="4526280"/>
           </a:xfrm>
           <a:prstGeom prst="rect">
             <a:avLst/>
@@ -5276,7 +5276,7 @@
         </p:nvSpPr>
         <p:spPr>
           <a:xfrm>
-            <a:off x="1005840" y="20125944"/>
+            <a:off x="1005840" y="20217384"/>
             <a:ext cx="11237976" cy="457200"/>
           </a:xfrm>
           <a:prstGeom prst="rect">
@@ -5294,7 +5294,7 @@
               <a:spcAft>
                 <a:spcPts val="400"/>
               </a:spcAft>
-              <a:defRPr sz="1350" b="0" i="0">
+              <a:defRPr sz="1600" b="0" i="0">
                 <a:solidFill>
                   <a:srgbClr val="4D5A52"/>
                 </a:solidFill>
@@ -5302,7 +5302,7 @@
               </a:defRPr>
             </a:pPr>
             <a:r>
-              <a:t>Golden sensR fixtures run beside unit, coverage, simulation, plotting, and model tests.</a:t>
+              <a:t>Golden sensR fixtures run beside unit, model, power, and plotting tests.</a:t>
             </a:r>
           </a:p>
         </p:txBody>
@@ -5359,7 +5359,7 @@
         <p:spPr>
           <a:xfrm>
             <a:off x="12975336" y="14968728"/>
-            <a:ext cx="11695176" cy="411480"/>
+            <a:ext cx="11695176" cy="502920"/>
           </a:xfrm>
           <a:prstGeom prst="rect">
             <a:avLst/>
@@ -5376,7 +5376,7 @@
               <a:spcAft>
                 <a:spcPts val="400"/>
               </a:spcAft>
-              <a:defRPr sz="2400" b="0" i="0">
+              <a:defRPr sz="2900" b="0" i="0">
                 <a:solidFill>
                   <a:srgbClr val="10231A"/>
                 </a:solidFill>
@@ -5405,8 +5405,8 @@
         </p:blipFill>
         <p:spPr>
           <a:xfrm>
-            <a:off x="15824420" y="15553944"/>
-            <a:ext cx="5997007" cy="2331719"/>
+            <a:off x="15792527" y="15627096"/>
+            <a:ext cx="6060793" cy="2240280"/>
           </a:xfrm>
           <a:prstGeom prst="rect">
             <a:avLst/>
@@ -5429,8 +5429,8 @@
         </p:blipFill>
         <p:spPr>
           <a:xfrm>
-            <a:off x="17170526" y="18114264"/>
-            <a:ext cx="3304796" cy="2606040"/>
+            <a:off x="16990682" y="18041112"/>
+            <a:ext cx="3664483" cy="2834640"/>
           </a:xfrm>
           <a:prstGeom prst="rect">
             <a:avLst/>
@@ -5489,7 +5489,7 @@
         <p:spPr>
           <a:xfrm>
             <a:off x="777240" y="21095208"/>
-            <a:ext cx="11695176" cy="411480"/>
+            <a:ext cx="11695176" cy="502920"/>
           </a:xfrm>
           <a:prstGeom prst="rect">
             <a:avLst/>
@@ -5506,7 +5506,7 @@
               <a:spcAft>
                 <a:spcPts val="400"/>
               </a:spcAft>
-              <a:defRPr sz="2400" b="0" i="0">
+              <a:defRPr sz="2900" b="0" i="0">
                 <a:solidFill>
                   <a:srgbClr val="10231A"/>
                 </a:solidFill>
@@ -5527,7 +5527,7 @@
         </p:nvSpPr>
         <p:spPr>
           <a:xfrm>
-            <a:off x="960120" y="21652992"/>
+            <a:off x="960120" y="21744432"/>
             <a:ext cx="11329415" cy="2926080"/>
           </a:xfrm>
           <a:prstGeom prst="roundRect">
@@ -5572,7 +5572,7 @@
         </p:nvSpPr>
         <p:spPr>
           <a:xfrm>
-            <a:off x="1280160" y="21863304"/>
+            <a:off x="1280160" y="21954744"/>
             <a:ext cx="10689336" cy="2468880"/>
           </a:xfrm>
           <a:prstGeom prst="rect">
@@ -5590,7 +5590,7 @@
               <a:spcAft>
                 <a:spcPts val="400"/>
               </a:spcAft>
-              <a:defRPr sz="1230" b="0" i="0">
+              <a:defRPr sz="1520" b="0" i="0">
                 <a:solidFill>
                   <a:srgbClr val="17291F"/>
                 </a:solidFill>
@@ -5598,7 +5598,7 @@
               </a:defRPr>
             </a:pPr>
             <a:r>
-              <a:t>from senspy import discrim, discrim_power</a:t>
+              <a:t>from senspy import discrim, dprime_power</a:t>
             </a:r>
           </a:p>
           <a:p>
@@ -5606,7 +5606,7 @@
               <a:spcAft>
                 <a:spcPts val="400"/>
               </a:spcAft>
-              <a:defRPr sz="1230" b="0" i="0">
+              <a:defRPr sz="1520" b="0" i="0">
                 <a:solidFill>
                   <a:srgbClr val="17291F"/>
                 </a:solidFill>
@@ -5619,7 +5619,7 @@
               <a:spcAft>
                 <a:spcPts val="400"/>
               </a:spcAft>
-              <a:defRPr sz="1230" b="0" i="0">
+              <a:defRPr sz="1520" b="0" i="0">
                 <a:solidFill>
                   <a:srgbClr val="17291F"/>
                 </a:solidFill>
@@ -5635,7 +5635,7 @@
               <a:spcAft>
                 <a:spcPts val="400"/>
               </a:spcAft>
-              <a:defRPr sz="1230" b="0" i="0">
+              <a:defRPr sz="1520" b="0" i="0">
                 <a:solidFill>
                   <a:srgbClr val="17291F"/>
                 </a:solidFill>
@@ -5651,7 +5651,7 @@
               <a:spcAft>
                 <a:spcPts val="400"/>
               </a:spcAft>
-              <a:defRPr sz="1230" b="0" i="0">
+              <a:defRPr sz="1520" b="0" i="0">
                 <a:solidFill>
                   <a:srgbClr val="17291F"/>
                 </a:solidFill>
@@ -5659,7 +5659,7 @@
               </a:defRPr>
             </a:pPr>
             <a:r>
-              <a:t>print(result.d_prime, result.confint())</a:t>
+              <a:t>result.d_prime</a:t>
             </a:r>
           </a:p>
           <a:p>
@@ -5667,36 +5667,36 @@
               <a:spcAft>
                 <a:spcPts val="400"/>
               </a:spcAft>
-              <a:defRPr sz="1230" b="0" i="0">
+              <a:defRPr sz="1520" b="0" i="0">
                 <a:solidFill>
                   <a:srgbClr val="17291F"/>
                 </a:solidFill>
                 <a:latin typeface="Courier New"/>
               </a:defRPr>
             </a:pPr>
+            <a:r>
+              <a:t>result.confint()</a:t>
+            </a:r>
           </a:p>
           <a:p>
             <a:pPr algn="l">
               <a:spcAft>
                 <a:spcPts val="400"/>
               </a:spcAft>
-              <a:defRPr sz="1230" b="0" i="0">
+              <a:defRPr sz="1520" b="0" i="0">
                 <a:solidFill>
                   <a:srgbClr val="17291F"/>
                 </a:solidFill>
                 <a:latin typeface="Courier New"/>
               </a:defRPr>
             </a:pPr>
-            <a:r>
-              <a:t>power = discrim_power(d_prime=1.5,</a:t>
-            </a:r>
           </a:p>
           <a:p>
             <a:pPr algn="l">
               <a:spcAft>
                 <a:spcPts val="400"/>
               </a:spcAft>
-              <a:defRPr sz="1230" b="0" i="0">
+              <a:defRPr sz="1520" b="0" i="0">
                 <a:solidFill>
                   <a:srgbClr val="17291F"/>
                 </a:solidFill>
@@ -5704,7 +5704,7 @@
               </a:defRPr>
             </a:pPr>
             <a:r>
-              <a:t>                      sample_size=100,</a:t>
+              <a:t>dprime_power(1.5, 100,</a:t>
             </a:r>
           </a:p>
           <a:p>
@@ -5712,7 +5712,7 @@
               <a:spcAft>
                 <a:spcPts val="400"/>
               </a:spcAft>
-              <a:defRPr sz="1230" b="0" i="0">
+              <a:defRPr sz="1520" b="0" i="0">
                 <a:solidFill>
                   <a:srgbClr val="17291F"/>
                 </a:solidFill>
@@ -5720,7 +5720,7 @@
               </a:defRPr>
             </a:pPr>
             <a:r>
-              <a:t>                      method="triangle")</a:t>
+              <a:t>             method="triangle")</a:t>
             </a:r>
           </a:p>
         </p:txBody>
@@ -5733,7 +5733,7 @@
         </p:nvSpPr>
         <p:spPr>
           <a:xfrm>
-            <a:off x="1097280" y="24734519"/>
+            <a:off x="1097280" y="24825960"/>
             <a:ext cx="11055096" cy="731520"/>
           </a:xfrm>
           <a:prstGeom prst="rect">
@@ -5751,7 +5751,7 @@
               <a:spcAft>
                 <a:spcPts val="400"/>
               </a:spcAft>
-              <a:defRPr sz="1550" b="1" i="0">
+              <a:defRPr sz="1800" b="1" i="0">
                 <a:solidFill>
                   <a:srgbClr val="17291F"/>
                 </a:solidFill>
@@ -5759,7 +5759,7 @@
               </a:defRPr>
             </a:pPr>
             <a:r>
-              <a:t>Typed result objects replace loose console output: estimates, intervals, p-values, and summaries travel together.</a:t>
+              <a:t>Typed results keep estimates, intervals, p-values, and summaries together.</a:t>
             </a:r>
           </a:p>
         </p:txBody>
@@ -5816,7 +5816,7 @@
         <p:spPr>
           <a:xfrm>
             <a:off x="12975336" y="21095208"/>
-            <a:ext cx="11695176" cy="411480"/>
+            <a:ext cx="11695176" cy="502920"/>
           </a:xfrm>
           <a:prstGeom prst="rect">
             <a:avLst/>
@@ -5833,7 +5833,7 @@
               <a:spcAft>
                 <a:spcPts val="400"/>
               </a:spcAft>
-              <a:defRPr sz="2400" b="0" i="0">
+              <a:defRPr sz="2900" b="0" i="0">
                 <a:solidFill>
                   <a:srgbClr val="10231A"/>
                 </a:solidFill>
@@ -5854,7 +5854,7 @@
         </p:nvSpPr>
         <p:spPr>
           <a:xfrm>
-            <a:off x="13066776" y="21790152"/>
+            <a:off x="13066776" y="21881592"/>
             <a:ext cx="3669791" cy="1554480"/>
           </a:xfrm>
           <a:prstGeom prst="roundRect">
@@ -5899,7 +5899,7 @@
         </p:nvSpPr>
         <p:spPr>
           <a:xfrm>
-            <a:off x="13139928" y="21918168"/>
+            <a:off x="13139928" y="22009608"/>
             <a:ext cx="3523487" cy="502920"/>
           </a:xfrm>
           <a:prstGeom prst="rect">
@@ -5917,7 +5917,7 @@
               <a:spcAft>
                 <a:spcPts val="400"/>
               </a:spcAft>
-              <a:defRPr sz="2800" b="1" i="0">
+              <a:defRPr sz="3400" b="1" i="0">
                 <a:solidFill>
                   <a:srgbClr val="4C8A61"/>
                 </a:solidFill>
@@ -5938,7 +5938,7 @@
         </p:nvSpPr>
         <p:spPr>
           <a:xfrm>
-            <a:off x="13176503" y="22549103"/>
+            <a:off x="13176503" y="22640544"/>
             <a:ext cx="3450335" cy="457200"/>
           </a:xfrm>
           <a:prstGeom prst="rect">
@@ -5956,7 +5956,7 @@
               <a:spcAft>
                 <a:spcPts val="400"/>
               </a:spcAft>
-              <a:defRPr sz="1350" b="1" i="0">
+              <a:defRPr sz="1600" b="1" i="0">
                 <a:solidFill>
                   <a:srgbClr val="17291F"/>
                 </a:solidFill>
@@ -5977,7 +5977,7 @@
         </p:nvSpPr>
         <p:spPr>
           <a:xfrm>
-            <a:off x="13194792" y="22960584"/>
+            <a:off x="13194792" y="23052024"/>
             <a:ext cx="3413759" cy="438912"/>
           </a:xfrm>
           <a:prstGeom prst="rect">
@@ -5995,7 +5995,7 @@
               <a:spcAft>
                 <a:spcPts val="400"/>
               </a:spcAft>
-              <a:defRPr sz="1050" b="0" i="0">
+              <a:defRPr sz="1350" b="0" i="0">
                 <a:solidFill>
                   <a:srgbClr val="4D5A52"/>
                 </a:solidFill>
@@ -6016,7 +6016,7 @@
         </p:nvSpPr>
         <p:spPr>
           <a:xfrm>
-            <a:off x="16965167" y="21790152"/>
+            <a:off x="16965167" y="21881592"/>
             <a:ext cx="3669791" cy="1554480"/>
           </a:xfrm>
           <a:prstGeom prst="roundRect">
@@ -6061,7 +6061,7 @@
         </p:nvSpPr>
         <p:spPr>
           <a:xfrm>
-            <a:off x="17038319" y="21918168"/>
+            <a:off x="17038319" y="22009608"/>
             <a:ext cx="3523487" cy="502920"/>
           </a:xfrm>
           <a:prstGeom prst="rect">
@@ -6079,7 +6079,7 @@
               <a:spcAft>
                 <a:spcPts val="400"/>
               </a:spcAft>
-              <a:defRPr sz="2800" b="1" i="0">
+              <a:defRPr sz="3400" b="1" i="0">
                 <a:solidFill>
                   <a:srgbClr val="C7563F"/>
                 </a:solidFill>
@@ -6100,7 +6100,7 @@
         </p:nvSpPr>
         <p:spPr>
           <a:xfrm>
-            <a:off x="17074896" y="22549103"/>
+            <a:off x="17074896" y="22640544"/>
             <a:ext cx="3450335" cy="457200"/>
           </a:xfrm>
           <a:prstGeom prst="rect">
@@ -6118,7 +6118,7 @@
               <a:spcAft>
                 <a:spcPts val="400"/>
               </a:spcAft>
-              <a:defRPr sz="1350" b="1" i="0">
+              <a:defRPr sz="1600" b="1" i="0">
                 <a:solidFill>
                   <a:srgbClr val="17291F"/>
                 </a:solidFill>
@@ -6139,7 +6139,7 @@
         </p:nvSpPr>
         <p:spPr>
           <a:xfrm>
-            <a:off x="17093184" y="22960584"/>
+            <a:off x="17093184" y="23052024"/>
             <a:ext cx="3413759" cy="438912"/>
           </a:xfrm>
           <a:prstGeom prst="rect">
@@ -6157,7 +6157,7 @@
               <a:spcAft>
                 <a:spcPts val="400"/>
               </a:spcAft>
-              <a:defRPr sz="1050" b="0" i="0">
+              <a:defRPr sz="1350" b="0" i="0">
                 <a:solidFill>
                   <a:srgbClr val="4D5A52"/>
                 </a:solidFill>
@@ -6178,7 +6178,7 @@
         </p:nvSpPr>
         <p:spPr>
           <a:xfrm>
-            <a:off x="20863559" y="21790152"/>
+            <a:off x="20863559" y="21881592"/>
             <a:ext cx="3669791" cy="1554480"/>
           </a:xfrm>
           <a:prstGeom prst="roundRect">
@@ -6223,7 +6223,7 @@
         </p:nvSpPr>
         <p:spPr>
           <a:xfrm>
-            <a:off x="20936711" y="21918168"/>
+            <a:off x="20936711" y="22009608"/>
             <a:ext cx="3523487" cy="502920"/>
           </a:xfrm>
           <a:prstGeom prst="rect">
@@ -6241,7 +6241,7 @@
               <a:spcAft>
                 <a:spcPts val="400"/>
               </a:spcAft>
-              <a:defRPr sz="2800" b="1" i="0">
+              <a:defRPr sz="3400" b="1" i="0">
                 <a:solidFill>
                   <a:srgbClr val="4C8A61"/>
                 </a:solidFill>
@@ -6262,7 +6262,7 @@
         </p:nvSpPr>
         <p:spPr>
           <a:xfrm>
-            <a:off x="20973287" y="22549103"/>
+            <a:off x="20973287" y="22640544"/>
             <a:ext cx="3450335" cy="457200"/>
           </a:xfrm>
           <a:prstGeom prst="rect">
@@ -6280,7 +6280,7 @@
               <a:spcAft>
                 <a:spcPts val="400"/>
               </a:spcAft>
-              <a:defRPr sz="1350" b="1" i="0">
+              <a:defRPr sz="1600" b="1" i="0">
                 <a:solidFill>
                   <a:srgbClr val="17291F"/>
                 </a:solidFill>
@@ -6301,7 +6301,7 @@
         </p:nvSpPr>
         <p:spPr>
           <a:xfrm>
-            <a:off x="20991575" y="22960584"/>
+            <a:off x="20991575" y="23052024"/>
             <a:ext cx="3413759" cy="438912"/>
           </a:xfrm>
           <a:prstGeom prst="rect">
@@ -6319,7 +6319,7 @@
               <a:spcAft>
                 <a:spcPts val="400"/>
               </a:spcAft>
-              <a:defRPr sz="1050" b="0" i="0">
+              <a:defRPr sz="1350" b="0" i="0">
                 <a:solidFill>
                   <a:srgbClr val="4D5A52"/>
                 </a:solidFill>
@@ -6340,7 +6340,7 @@
         </p:nvSpPr>
         <p:spPr>
           <a:xfrm>
-            <a:off x="13203936" y="23664672"/>
+            <a:off x="13203936" y="23756112"/>
             <a:ext cx="11237976" cy="731520"/>
           </a:xfrm>
           <a:prstGeom prst="rect">
@@ -6358,7 +6358,7 @@
               <a:spcAft>
                 <a:spcPts val="400"/>
               </a:spcAft>
-              <a:defRPr sz="1550" b="1" i="0">
+              <a:defRPr sz="1750" b="1" i="0">
                 <a:solidFill>
                   <a:srgbClr val="17291F"/>
                 </a:solidFill>
@@ -6366,7 +6366,7 @@
               </a:defRPr>
             </a:pPr>
             <a:r>
-              <a:t>Also included: 2-AC, DOD, A-not-A, d-prime comparison, posthoc tests, simulation, power, and sample-size planning.</a:t>
+              <a:t>Also included: 2-AC, DOD, A-not-A, d-prime tests, posthoc, simulation, power, and sample-size planning.</a:t>
             </a:r>
           </a:p>
         </p:txBody>
@@ -6423,7 +6423,7 @@
         <p:spPr>
           <a:xfrm>
             <a:off x="777240" y="25941528"/>
-            <a:ext cx="23893272" cy="411480"/>
+            <a:ext cx="23893272" cy="502920"/>
           </a:xfrm>
           <a:prstGeom prst="rect">
             <a:avLst/>
@@ -6440,7 +6440,7 @@
               <a:spcAft>
                 <a:spcPts val="400"/>
               </a:spcAft>
-              <a:defRPr sz="2400" b="0" i="0">
+              <a:defRPr sz="2900" b="0" i="0">
                 <a:solidFill>
                   <a:srgbClr val="10231A"/>
                 </a:solidFill>
@@ -6462,7 +6462,7 @@
         <p:spPr>
           <a:xfrm>
             <a:off x="1783080" y="26618184"/>
-            <a:ext cx="21881592" cy="868680"/>
+            <a:ext cx="21881592" cy="1051560"/>
           </a:xfrm>
           <a:prstGeom prst="rect">
             <a:avLst/>
@@ -6479,7 +6479,7 @@
               <a:spcAft>
                 <a:spcPts val="400"/>
               </a:spcAft>
-              <a:defRPr sz="2000" b="1" i="0">
+              <a:defRPr sz="2400" b="1" i="0">
                 <a:solidFill>
                   <a:srgbClr val="17291F"/>
                 </a:solidFill>
@@ -6500,7 +6500,7 @@
         </p:nvSpPr>
         <p:spPr>
           <a:xfrm>
-            <a:off x="2240280" y="27614880"/>
+            <a:off x="2240280" y="27770328"/>
             <a:ext cx="20967192" cy="640080"/>
           </a:xfrm>
           <a:prstGeom prst="rect">
@@ -6518,7 +6518,7 @@
               <a:spcAft>
                 <a:spcPts val="400"/>
               </a:spcAft>
-              <a:defRPr sz="1350" b="0" i="0">
+              <a:defRPr sz="1550" b="0" i="0">
                 <a:solidFill>
                   <a:srgbClr val="4D5A52"/>
                 </a:solidFill>
@@ -6539,7 +6539,7 @@
         </p:nvSpPr>
         <p:spPr>
           <a:xfrm>
-            <a:off x="777240" y="28373832"/>
+            <a:off x="777240" y="28529280"/>
             <a:ext cx="23893272" cy="384048"/>
           </a:xfrm>
           <a:prstGeom prst="rect">
@@ -6557,7 +6557,7 @@
               <a:spcAft>
                 <a:spcPts val="400"/>
               </a:spcAft>
-              <a:defRPr sz="1800" b="0" i="0">
+              <a:defRPr sz="2100" b="0" i="0">
                 <a:solidFill>
                   <a:srgbClr val="10231A"/>
                 </a:solidFill>
@@ -6578,7 +6578,7 @@
         </p:nvSpPr>
         <p:spPr>
           <a:xfrm>
-            <a:off x="777240" y="28803600"/>
+            <a:off x="777240" y="28959048"/>
             <a:ext cx="7720584" cy="1874519"/>
           </a:xfrm>
           <a:prstGeom prst="roundRect">
@@ -6623,8 +6623,8 @@
         </p:nvSpPr>
         <p:spPr>
           <a:xfrm>
-            <a:off x="978408" y="28968192"/>
-            <a:ext cx="7318248" cy="329184"/>
+            <a:off x="978408" y="29123640"/>
+            <a:ext cx="7318248" cy="365760"/>
           </a:xfrm>
           <a:prstGeom prst="rect">
             <a:avLst/>
@@ -6641,7 +6641,7 @@
               <a:spcAft>
                 <a:spcPts val="400"/>
               </a:spcAft>
-              <a:defRPr sz="1500" b="1" i="0">
+              <a:defRPr sz="1800" b="1" i="0">
                 <a:solidFill>
                   <a:srgbClr val="4C8A61"/>
                 </a:solidFill>
@@ -6662,8 +6662,8 @@
         </p:nvSpPr>
         <p:spPr>
           <a:xfrm>
-            <a:off x="1051560" y="29425392"/>
-            <a:ext cx="7171944" cy="1124712"/>
+            <a:off x="1088136" y="29653992"/>
+            <a:ext cx="7098792" cy="1051560"/>
           </a:xfrm>
           <a:prstGeom prst="rect">
             <a:avLst/>
@@ -6680,7 +6680,7 @@
               <a:spcAft>
                 <a:spcPts val="400"/>
               </a:spcAft>
-              <a:defRPr sz="1270" b="0" i="0">
+              <a:defRPr sz="1530" b="0" i="0">
                 <a:solidFill>
                   <a:srgbClr val="17291F"/>
                 </a:solidFill>
@@ -6688,7 +6688,7 @@
               </a:defRPr>
             </a:pPr>
             <a:r>
-              <a:t>Keep sensR-backed decisions while moving analysis, planning, and visualization into Python notebooks and pipelines.</a:t>
+              <a:t>Keep sensR-backed decisions in Python notebooks and pipelines.</a:t>
             </a:r>
           </a:p>
         </p:txBody>
@@ -6701,7 +6701,7 @@
         </p:nvSpPr>
         <p:spPr>
           <a:xfrm>
-            <a:off x="8863584" y="28803600"/>
+            <a:off x="8863584" y="28959048"/>
             <a:ext cx="7720584" cy="1874519"/>
           </a:xfrm>
           <a:prstGeom prst="roundRect">
@@ -6746,8 +6746,8 @@
         </p:nvSpPr>
         <p:spPr>
           <a:xfrm>
-            <a:off x="9064752" y="28968192"/>
-            <a:ext cx="7318248" cy="329184"/>
+            <a:off x="9064752" y="29123640"/>
+            <a:ext cx="7318248" cy="365760"/>
           </a:xfrm>
           <a:prstGeom prst="rect">
             <a:avLst/>
@@ -6764,7 +6764,7 @@
               <a:spcAft>
                 <a:spcPts val="400"/>
               </a:spcAft>
-              <a:defRPr sz="1500" b="1" i="0">
+              <a:defRPr sz="1800" b="1" i="0">
                 <a:solidFill>
                   <a:srgbClr val="C7563F"/>
                 </a:solidFill>
@@ -6785,8 +6785,8 @@
         </p:nvSpPr>
         <p:spPr>
           <a:xfrm>
-            <a:off x="9137904" y="29425392"/>
-            <a:ext cx="7171944" cy="1124712"/>
+            <a:off x="9174480" y="29653992"/>
+            <a:ext cx="7098792" cy="1051560"/>
           </a:xfrm>
           <a:prstGeom prst="rect">
             <a:avLst/>
@@ -6803,7 +6803,7 @@
               <a:spcAft>
                 <a:spcPts val="400"/>
               </a:spcAft>
-              <a:defRPr sz="1270" b="0" i="0">
+              <a:defRPr sz="1530" b="0" i="0">
                 <a:solidFill>
                   <a:srgbClr val="17291F"/>
                 </a:solidFill>
@@ -6811,7 +6811,7 @@
               </a:defRPr>
             </a:pPr>
             <a:r>
-              <a:t>Protocols expose Pc, Pd, d-prime, confidence intervals, and power on a shared API surface.</a:t>
+              <a:t>Pc, Pd, d-prime, intervals, and power share one API.</a:t>
             </a:r>
           </a:p>
         </p:txBody>
@@ -6824,7 +6824,7 @@
         </p:nvSpPr>
         <p:spPr>
           <a:xfrm>
-            <a:off x="16949928" y="28803600"/>
+            <a:off x="16949928" y="28959048"/>
             <a:ext cx="7720584" cy="1874519"/>
           </a:xfrm>
           <a:prstGeom prst="roundRect">
@@ -6869,8 +6869,8 @@
         </p:nvSpPr>
         <p:spPr>
           <a:xfrm>
-            <a:off x="17151096" y="28968192"/>
-            <a:ext cx="7318248" cy="329184"/>
+            <a:off x="17151096" y="29123640"/>
+            <a:ext cx="7318248" cy="365760"/>
           </a:xfrm>
           <a:prstGeom prst="rect">
             <a:avLst/>
@@ -6887,7 +6887,7 @@
               <a:spcAft>
                 <a:spcPts val="400"/>
               </a:spcAft>
-              <a:defRPr sz="1500" b="1" i="0">
+              <a:defRPr sz="1800" b="1" i="0">
                 <a:solidFill>
                   <a:srgbClr val="4C8A61"/>
                 </a:solidFill>
@@ -6908,8 +6908,8 @@
         </p:nvSpPr>
         <p:spPr>
           <a:xfrm>
-            <a:off x="17224248" y="29425392"/>
-            <a:ext cx="7171944" cy="1124712"/>
+            <a:off x="17260824" y="29653992"/>
+            <a:ext cx="7098792" cy="1051560"/>
           </a:xfrm>
           <a:prstGeom prst="rect">
             <a:avLst/>
@@ -6926,7 +6926,7 @@
               <a:spcAft>
                 <a:spcPts val="400"/>
               </a:spcAft>
-              <a:defRPr sz="1270" b="0" i="0">
+              <a:defRPr sz="1530" b="0" i="0">
                 <a:solidFill>
                   <a:srgbClr val="17291F"/>
                 </a:solidFill>
@@ -6934,7 +6934,7 @@
               </a:defRPr>
             </a:pPr>
             <a:r>
-              <a:t>Typed result objects and Plotly figures make estimates easier to audit, compare, and reuse.</a:t>
+              <a:t>Typed results and Plotly figures are easier to audit and reuse.</a:t>
             </a:r>
           </a:p>
         </p:txBody>
@@ -6947,7 +6947,7 @@
         </p:nvSpPr>
         <p:spPr>
           <a:xfrm>
-            <a:off x="777240" y="30678119"/>
+            <a:off x="777240" y="31043880"/>
             <a:ext cx="23893272" cy="384048"/>
           </a:xfrm>
           <a:prstGeom prst="rect">
@@ -6986,7 +6986,7 @@
         </p:nvSpPr>
         <p:spPr>
           <a:xfrm>
-            <a:off x="777240" y="31208471"/>
+            <a:off x="777240" y="31574232"/>
             <a:ext cx="5698998" cy="2788920"/>
           </a:xfrm>
           <a:prstGeom prst="roundRect">
@@ -7031,8 +7031,8 @@
         </p:nvSpPr>
         <p:spPr>
           <a:xfrm>
-            <a:off x="914400" y="31501079"/>
-            <a:ext cx="5424678" cy="320040"/>
+            <a:off x="914400" y="31793688"/>
+            <a:ext cx="5424678" cy="384048"/>
           </a:xfrm>
           <a:prstGeom prst="rect">
             <a:avLst/>
@@ -7049,7 +7049,7 @@
               <a:spcAft>
                 <a:spcPts val="400"/>
               </a:spcAft>
-              <a:defRPr sz="1700" b="1" i="0">
+              <a:defRPr sz="2000" b="1" i="0">
                 <a:solidFill>
                   <a:srgbClr val="C7563F"/>
                 </a:solidFill>
@@ -7070,7 +7070,7 @@
         </p:nvSpPr>
         <p:spPr>
           <a:xfrm>
-            <a:off x="1161288" y="32004000"/>
+            <a:off x="1161288" y="32342328"/>
             <a:ext cx="4930902" cy="548640"/>
           </a:xfrm>
           <a:prstGeom prst="rect">
@@ -7088,7 +7088,7 @@
               <a:spcAft>
                 <a:spcPts val="400"/>
               </a:spcAft>
-              <a:defRPr sz="1330" b="0" i="0">
+              <a:defRPr sz="1600" b="0" i="0">
                 <a:solidFill>
                   <a:srgbClr val="17291F"/>
                 </a:solidFill>
@@ -7109,8 +7109,8 @@
         </p:nvSpPr>
         <p:spPr>
           <a:xfrm>
-            <a:off x="1161288" y="32634935"/>
-            <a:ext cx="4930902" cy="347472"/>
+            <a:off x="1161288" y="33000696"/>
+            <a:ext cx="4930902" cy="402336"/>
           </a:xfrm>
           <a:prstGeom prst="rect">
             <a:avLst/>
@@ -7127,7 +7127,7 @@
               <a:spcAft>
                 <a:spcPts val="400"/>
               </a:spcAft>
-              <a:defRPr sz="1070" b="0" i="0">
+              <a:defRPr sz="1420" b="0" i="0">
                 <a:solidFill>
                   <a:srgbClr val="10231A"/>
                 </a:solidFill>
@@ -7148,8 +7148,8 @@
         </p:nvSpPr>
         <p:spPr>
           <a:xfrm>
-            <a:off x="1161288" y="33119568"/>
-            <a:ext cx="4930902" cy="411480"/>
+            <a:off x="1161288" y="33494472"/>
+            <a:ext cx="4930902" cy="438912"/>
           </a:xfrm>
           <a:prstGeom prst="rect">
             <a:avLst/>
@@ -7166,7 +7166,7 @@
               <a:spcAft>
                 <a:spcPts val="400"/>
               </a:spcAft>
-              <a:defRPr sz="1060" b="0" i="0">
+              <a:defRPr sz="1380" b="0" i="0">
                 <a:solidFill>
                   <a:srgbClr val="4D5A52"/>
                 </a:solidFill>
@@ -7187,7 +7187,7 @@
         </p:nvSpPr>
         <p:spPr>
           <a:xfrm>
-            <a:off x="6841998" y="31208471"/>
+            <a:off x="6841998" y="31574232"/>
             <a:ext cx="5698998" cy="2788920"/>
           </a:xfrm>
           <a:prstGeom prst="roundRect">
@@ -7232,8 +7232,8 @@
         </p:nvSpPr>
         <p:spPr>
           <a:xfrm>
-            <a:off x="6979158" y="31501079"/>
-            <a:ext cx="5424678" cy="320040"/>
+            <a:off x="6979158" y="31793688"/>
+            <a:ext cx="5424678" cy="384048"/>
           </a:xfrm>
           <a:prstGeom prst="rect">
             <a:avLst/>
@@ -7250,7 +7250,7 @@
               <a:spcAft>
                 <a:spcPts val="400"/>
               </a:spcAft>
-              <a:defRPr sz="1700" b="1" i="0">
+              <a:defRPr sz="2000" b="1" i="0">
                 <a:solidFill>
                   <a:srgbClr val="C7563F"/>
                 </a:solidFill>
@@ -7271,7 +7271,7 @@
         </p:nvSpPr>
         <p:spPr>
           <a:xfrm>
-            <a:off x="7226046" y="32004000"/>
+            <a:off x="7226046" y="32342328"/>
             <a:ext cx="4930902" cy="548640"/>
           </a:xfrm>
           <a:prstGeom prst="rect">
@@ -7289,7 +7289,7 @@
               <a:spcAft>
                 <a:spcPts val="400"/>
               </a:spcAft>
-              <a:defRPr sz="1330" b="0" i="0">
+              <a:defRPr sz="1600" b="0" i="0">
                 <a:solidFill>
                   <a:srgbClr val="17291F"/>
                 </a:solidFill>
@@ -7310,8 +7310,8 @@
         </p:nvSpPr>
         <p:spPr>
           <a:xfrm>
-            <a:off x="7226046" y="32634935"/>
-            <a:ext cx="4930902" cy="347472"/>
+            <a:off x="7226046" y="33000696"/>
+            <a:ext cx="4930902" cy="402336"/>
           </a:xfrm>
           <a:prstGeom prst="rect">
             <a:avLst/>
@@ -7328,7 +7328,7 @@
               <a:spcAft>
                 <a:spcPts val="400"/>
               </a:spcAft>
-              <a:defRPr sz="1070" b="0" i="0">
+              <a:defRPr sz="1420" b="0" i="0">
                 <a:solidFill>
                   <a:srgbClr val="10231A"/>
                 </a:solidFill>
@@ -7349,8 +7349,8 @@
         </p:nvSpPr>
         <p:spPr>
           <a:xfrm>
-            <a:off x="7226046" y="33119568"/>
-            <a:ext cx="4930902" cy="411480"/>
+            <a:off x="7226046" y="33494472"/>
+            <a:ext cx="4930902" cy="438912"/>
           </a:xfrm>
           <a:prstGeom prst="rect">
             <a:avLst/>
@@ -7367,7 +7367,7 @@
               <a:spcAft>
                 <a:spcPts val="400"/>
               </a:spcAft>
-              <a:defRPr sz="1060" b="0" i="0">
+              <a:defRPr sz="1380" b="0" i="0">
                 <a:solidFill>
                   <a:srgbClr val="4D5A52"/>
                 </a:solidFill>
@@ -7388,7 +7388,7 @@
         </p:nvSpPr>
         <p:spPr>
           <a:xfrm>
-            <a:off x="12906756" y="31208471"/>
+            <a:off x="12906756" y="31574232"/>
             <a:ext cx="5698998" cy="2788920"/>
           </a:xfrm>
           <a:prstGeom prst="roundRect">
@@ -7433,8 +7433,8 @@
         </p:nvSpPr>
         <p:spPr>
           <a:xfrm>
-            <a:off x="13043916" y="31501079"/>
-            <a:ext cx="5424678" cy="320040"/>
+            <a:off x="13043916" y="31793688"/>
+            <a:ext cx="5424678" cy="384048"/>
           </a:xfrm>
           <a:prstGeom prst="rect">
             <a:avLst/>
@@ -7451,7 +7451,7 @@
               <a:spcAft>
                 <a:spcPts val="400"/>
               </a:spcAft>
-              <a:defRPr sz="1700" b="1" i="0">
+              <a:defRPr sz="2000" b="1" i="0">
                 <a:solidFill>
                   <a:srgbClr val="C7563F"/>
                 </a:solidFill>
@@ -7472,7 +7472,7 @@
         </p:nvSpPr>
         <p:spPr>
           <a:xfrm>
-            <a:off x="13290804" y="32004000"/>
+            <a:off x="13290804" y="32342328"/>
             <a:ext cx="4930902" cy="548640"/>
           </a:xfrm>
           <a:prstGeom prst="rect">
@@ -7490,7 +7490,7 @@
               <a:spcAft>
                 <a:spcPts val="400"/>
               </a:spcAft>
-              <a:defRPr sz="1330" b="0" i="0">
+              <a:defRPr sz="1600" b="0" i="0">
                 <a:solidFill>
                   <a:srgbClr val="17291F"/>
                 </a:solidFill>
@@ -7511,8 +7511,8 @@
         </p:nvSpPr>
         <p:spPr>
           <a:xfrm>
-            <a:off x="13290804" y="32634935"/>
-            <a:ext cx="4930902" cy="347472"/>
+            <a:off x="13290804" y="33000696"/>
+            <a:ext cx="4930902" cy="402336"/>
           </a:xfrm>
           <a:prstGeom prst="rect">
             <a:avLst/>
@@ -7529,7 +7529,7 @@
               <a:spcAft>
                 <a:spcPts val="400"/>
               </a:spcAft>
-              <a:defRPr sz="1070" b="0" i="0">
+              <a:defRPr sz="1420" b="0" i="0">
                 <a:solidFill>
                   <a:srgbClr val="10231A"/>
                 </a:solidFill>
@@ -7550,8 +7550,8 @@
         </p:nvSpPr>
         <p:spPr>
           <a:xfrm>
-            <a:off x="13290804" y="33119568"/>
-            <a:ext cx="4930902" cy="411480"/>
+            <a:off x="13290804" y="33494472"/>
+            <a:ext cx="4930902" cy="438912"/>
           </a:xfrm>
           <a:prstGeom prst="rect">
             <a:avLst/>
@@ -7568,7 +7568,7 @@
               <a:spcAft>
                 <a:spcPts val="400"/>
               </a:spcAft>
-              <a:defRPr sz="1060" b="0" i="0">
+              <a:defRPr sz="1380" b="0" i="0">
                 <a:solidFill>
                   <a:srgbClr val="4D5A52"/>
                 </a:solidFill>
@@ -7589,7 +7589,7 @@
         </p:nvSpPr>
         <p:spPr>
           <a:xfrm>
-            <a:off x="18971514" y="31208471"/>
+            <a:off x="18971514" y="31574232"/>
             <a:ext cx="5698998" cy="2788920"/>
           </a:xfrm>
           <a:prstGeom prst="roundRect">
@@ -7634,8 +7634,8 @@
         </p:nvSpPr>
         <p:spPr>
           <a:xfrm>
-            <a:off x="19108674" y="31501079"/>
-            <a:ext cx="5424678" cy="320040"/>
+            <a:off x="19108674" y="31793688"/>
+            <a:ext cx="5424678" cy="384048"/>
           </a:xfrm>
           <a:prstGeom prst="rect">
             <a:avLst/>
@@ -7652,7 +7652,7 @@
               <a:spcAft>
                 <a:spcPts val="400"/>
               </a:spcAft>
-              <a:defRPr sz="1700" b="1" i="0">
+              <a:defRPr sz="2000" b="1" i="0">
                 <a:solidFill>
                   <a:srgbClr val="C7563F"/>
                 </a:solidFill>
@@ -7673,7 +7673,7 @@
         </p:nvSpPr>
         <p:spPr>
           <a:xfrm>
-            <a:off x="19355562" y="32004000"/>
+            <a:off x="19355562" y="32342328"/>
             <a:ext cx="4930902" cy="548640"/>
           </a:xfrm>
           <a:prstGeom prst="rect">
@@ -7691,7 +7691,7 @@
               <a:spcAft>
                 <a:spcPts val="400"/>
               </a:spcAft>
-              <a:defRPr sz="1330" b="0" i="0">
+              <a:defRPr sz="1600" b="0" i="0">
                 <a:solidFill>
                   <a:srgbClr val="17291F"/>
                 </a:solidFill>
@@ -7712,8 +7712,8 @@
         </p:nvSpPr>
         <p:spPr>
           <a:xfrm>
-            <a:off x="19355562" y="32634935"/>
-            <a:ext cx="4930902" cy="347472"/>
+            <a:off x="19355562" y="33000696"/>
+            <a:ext cx="4930902" cy="402336"/>
           </a:xfrm>
           <a:prstGeom prst="rect">
             <a:avLst/>
@@ -7730,7 +7730,7 @@
               <a:spcAft>
                 <a:spcPts val="400"/>
               </a:spcAft>
-              <a:defRPr sz="1070" b="0" i="0">
+              <a:defRPr sz="1420" b="0" i="0">
                 <a:solidFill>
                   <a:srgbClr val="10231A"/>
                 </a:solidFill>
@@ -7751,8 +7751,8 @@
         </p:nvSpPr>
         <p:spPr>
           <a:xfrm>
-            <a:off x="19355562" y="33119568"/>
-            <a:ext cx="4930902" cy="411480"/>
+            <a:off x="19355562" y="33494472"/>
+            <a:ext cx="4930902" cy="438912"/>
           </a:xfrm>
           <a:prstGeom prst="rect">
             <a:avLst/>
@@ -7769,7 +7769,7 @@
               <a:spcAft>
                 <a:spcPts val="400"/>
               </a:spcAft>
-              <a:defRPr sz="1060" b="0" i="0">
+              <a:defRPr sz="1380" b="0" i="0">
                 <a:solidFill>
                   <a:srgbClr val="4D5A52"/>
                 </a:solidFill>
@@ -7890,7 +7890,7 @@
               <a:spcAft>
                 <a:spcPts val="400"/>
               </a:spcAft>
-              <a:defRPr sz="1500" b="0" i="0">
+              <a:defRPr sz="1700" b="0" i="0">
                 <a:solidFill>
                   <a:srgbClr val="FFFFFF"/>
                 </a:solidFill>

</xml_diff>

<commit_message>
[codex/senspy-sensometrics-poster · Batch 4/4] Redesign poster for larger type
</commit_message>
<xml_diff>
--- a/poster/print_artifacts/senspy-sensometrics-2026-poster.pptx
+++ b/poster/print_artifacts/senspy-sensometrics-2026-poster.pptx
@@ -3140,7 +3140,7 @@
         <p:spPr>
           <a:xfrm>
             <a:off x="0" y="0"/>
-            <a:ext cx="25447752" cy="3977639"/>
+            <a:ext cx="25447752" cy="4069080"/>
           </a:xfrm>
           <a:prstGeom prst="rect">
             <a:avLst/>
@@ -3182,7 +3182,7 @@
         </p:nvSpPr>
         <p:spPr>
           <a:xfrm>
-            <a:off x="0" y="3913631"/>
+            <a:off x="0" y="4005072"/>
             <a:ext cx="25447752" cy="64008"/>
           </a:xfrm>
           <a:prstGeom prst="rect">
@@ -3225,8 +3225,8 @@
         </p:nvSpPr>
         <p:spPr>
           <a:xfrm>
-            <a:off x="777240" y="457200"/>
-            <a:ext cx="23893272" cy="1143000"/>
+            <a:off x="777240" y="320040"/>
+            <a:ext cx="23893272" cy="1463040"/>
           </a:xfrm>
           <a:prstGeom prst="rect">
             <a:avLst/>
@@ -3243,7 +3243,7 @@
               <a:spcAft>
                 <a:spcPts val="400"/>
               </a:spcAft>
-              <a:defRPr sz="8800" b="0" i="0">
+              <a:defRPr sz="9400" b="0" i="0">
                 <a:solidFill>
                   <a:srgbClr val="10231A"/>
                 </a:solidFill>
@@ -3264,7 +3264,7 @@
         </p:nvSpPr>
         <p:spPr>
           <a:xfrm>
-            <a:off x="777240" y="1627632"/>
+            <a:off x="777240" y="1874519"/>
             <a:ext cx="23893272" cy="749808"/>
           </a:xfrm>
           <a:prstGeom prst="rect">
@@ -3282,7 +3282,7 @@
               <a:spcAft>
                 <a:spcPts val="400"/>
               </a:spcAft>
-              <a:defRPr sz="3200" b="0" i="0">
+              <a:defRPr sz="3700" b="0" i="0">
                 <a:solidFill>
                   <a:srgbClr val="C7563F"/>
                 </a:solidFill>
@@ -3303,7 +3303,7 @@
         </p:nvSpPr>
         <p:spPr>
           <a:xfrm>
-            <a:off x="777240" y="2743200"/>
+            <a:off x="777240" y="2971800"/>
             <a:ext cx="23893272" cy="457200"/>
           </a:xfrm>
           <a:prstGeom prst="rect">
@@ -3321,7 +3321,7 @@
               <a:spcAft>
                 <a:spcPts val="400"/>
               </a:spcAft>
-              <a:defRPr sz="2200" b="1" i="0">
+              <a:defRPr sz="2700" b="1" i="0">
                 <a:solidFill>
                   <a:srgbClr val="17291F"/>
                 </a:solidFill>
@@ -3342,8 +3342,8 @@
         </p:nvSpPr>
         <p:spPr>
           <a:xfrm>
-            <a:off x="19110960" y="566928"/>
-            <a:ext cx="4937760" cy="457200"/>
+            <a:off x="18105120" y="530352"/>
+            <a:ext cx="5852160" cy="502920"/>
           </a:xfrm>
           <a:prstGeom prst="rect">
             <a:avLst/>
@@ -3360,7 +3360,7 @@
               <a:spcAft>
                 <a:spcPts val="400"/>
               </a:spcAft>
-              <a:defRPr sz="1550" b="0" i="0">
+              <a:defRPr sz="1800" b="0" i="0">
                 <a:solidFill>
                   <a:srgbClr val="526057"/>
                 </a:solidFill>
@@ -3381,8 +3381,8 @@
         </p:nvSpPr>
         <p:spPr>
           <a:xfrm>
-            <a:off x="777240" y="4297680"/>
-            <a:ext cx="11695176" cy="50292"/>
+            <a:off x="777240" y="4251960"/>
+            <a:ext cx="11695176" cy="64008"/>
           </a:xfrm>
           <a:prstGeom prst="rect">
             <a:avLst/>
@@ -3424,8 +3424,8 @@
         </p:nvSpPr>
         <p:spPr>
           <a:xfrm>
-            <a:off x="777240" y="4407408"/>
-            <a:ext cx="11695176" cy="502920"/>
+            <a:off x="777240" y="4398264"/>
+            <a:ext cx="11695176" cy="694944"/>
           </a:xfrm>
           <a:prstGeom prst="rect">
             <a:avLst/>
@@ -3442,7 +3442,7 @@
               <a:spcAft>
                 <a:spcPts val="400"/>
               </a:spcAft>
-              <a:defRPr sz="2900" b="0" i="0">
+              <a:defRPr sz="3800" b="0" i="0">
                 <a:solidFill>
                   <a:srgbClr val="10231A"/>
                 </a:solidFill>
@@ -3450,7 +3450,7 @@
               </a:defRPr>
             </a:pPr>
             <a:r>
-              <a:t>The problem</a:t>
+              <a:t>Why this matters</a:t>
             </a:r>
           </a:p>
         </p:txBody>
@@ -3463,8 +3463,8 @@
         </p:nvSpPr>
         <p:spPr>
           <a:xfrm>
-            <a:off x="822960" y="5056632"/>
-            <a:ext cx="11603736" cy="1051560"/>
+            <a:off x="914400" y="5285232"/>
+            <a:ext cx="11420855" cy="1417320"/>
           </a:xfrm>
           <a:prstGeom prst="rect">
             <a:avLst/>
@@ -3481,7 +3481,7 @@
               <a:spcAft>
                 <a:spcPts val="400"/>
               </a:spcAft>
-              <a:defRPr sz="2100" b="0" i="0">
+              <a:defRPr sz="3100" b="1" i="0">
                 <a:solidFill>
                   <a:srgbClr val="17291F"/>
                 </a:solidFill>
@@ -3489,7 +3489,7 @@
               </a:defRPr>
             </a:pPr>
             <a:r>
-              <a:t>sensR is the trusted R reference for sensory discrimination. Python teams need the same signal-detection discipline without leaving their SciPy, dataclass, and Plotly workflows.</a:t>
+              <a:t>sensPy brings sensR-style sensory discrimination into Python without leaving SciPy, dataclasses, or Plotly.</a:t>
             </a:r>
           </a:p>
         </p:txBody>
@@ -3502,8 +3502,8 @@
         </p:nvSpPr>
         <p:spPr>
           <a:xfrm>
-            <a:off x="960120" y="6382512"/>
-            <a:ext cx="5573268" cy="1325880"/>
+            <a:off x="960120" y="7114032"/>
+            <a:ext cx="5573268" cy="2148840"/>
           </a:xfrm>
           <a:prstGeom prst="roundRect">
             <a:avLst/>
@@ -3547,8 +3547,8 @@
         </p:nvSpPr>
         <p:spPr>
           <a:xfrm>
-            <a:off x="1161288" y="6547104"/>
-            <a:ext cx="5170931" cy="320040"/>
+            <a:off x="1197864" y="7333488"/>
+            <a:ext cx="5097779" cy="457200"/>
           </a:xfrm>
           <a:prstGeom prst="rect">
             <a:avLst/>
@@ -3565,7 +3565,7 @@
               <a:spcAft>
                 <a:spcPts val="400"/>
               </a:spcAft>
-              <a:defRPr sz="1700" b="1" i="0">
+              <a:defRPr sz="2400" b="1" i="0">
                 <a:solidFill>
                   <a:srgbClr val="C7563F"/>
                 </a:solidFill>
@@ -3586,8 +3586,8 @@
         </p:nvSpPr>
         <p:spPr>
           <a:xfrm>
-            <a:off x="1252728" y="6949440"/>
-            <a:ext cx="4988052" cy="667512"/>
+            <a:off x="1307592" y="7955280"/>
+            <a:ext cx="4878324" cy="1188720"/>
           </a:xfrm>
           <a:prstGeom prst="rect">
             <a:avLst/>
@@ -3604,7 +3604,7 @@
               <a:spcAft>
                 <a:spcPts val="400"/>
               </a:spcAft>
-              <a:defRPr sz="1630" b="0" i="0">
+              <a:defRPr sz="2150" b="0" i="0">
                 <a:solidFill>
                   <a:srgbClr val="17291F"/>
                 </a:solidFill>
@@ -3625,8 +3625,8 @@
         </p:nvSpPr>
         <p:spPr>
           <a:xfrm>
-            <a:off x="6716268" y="6382512"/>
-            <a:ext cx="5573268" cy="1325880"/>
+            <a:off x="6716268" y="7114032"/>
+            <a:ext cx="5573268" cy="2148840"/>
           </a:xfrm>
           <a:prstGeom prst="roundRect">
             <a:avLst/>
@@ -3670,8 +3670,8 @@
         </p:nvSpPr>
         <p:spPr>
           <a:xfrm>
-            <a:off x="6917436" y="6547104"/>
-            <a:ext cx="5170931" cy="320040"/>
+            <a:off x="6954012" y="7333488"/>
+            <a:ext cx="5097779" cy="457200"/>
           </a:xfrm>
           <a:prstGeom prst="rect">
             <a:avLst/>
@@ -3688,7 +3688,7 @@
               <a:spcAft>
                 <a:spcPts val="400"/>
               </a:spcAft>
-              <a:defRPr sz="1700" b="1" i="0">
+              <a:defRPr sz="2400" b="1" i="0">
                 <a:solidFill>
                   <a:srgbClr val="C7563F"/>
                 </a:solidFill>
@@ -3709,8 +3709,8 @@
         </p:nvSpPr>
         <p:spPr>
           <a:xfrm>
-            <a:off x="7008876" y="6949440"/>
-            <a:ext cx="4988052" cy="667512"/>
+            <a:off x="7063740" y="7955280"/>
+            <a:ext cx="4878324" cy="1188720"/>
           </a:xfrm>
           <a:prstGeom prst="rect">
             <a:avLst/>
@@ -3727,7 +3727,7 @@
               <a:spcAft>
                 <a:spcPts val="400"/>
               </a:spcAft>
-              <a:defRPr sz="1630" b="0" i="0">
+              <a:defRPr sz="2150" b="0" i="0">
                 <a:solidFill>
                   <a:srgbClr val="17291F"/>
                 </a:solidFill>
@@ -3748,8 +3748,8 @@
         </p:nvSpPr>
         <p:spPr>
           <a:xfrm>
-            <a:off x="914400" y="8010144"/>
-            <a:ext cx="11420855" cy="731520"/>
+            <a:off x="1097280" y="9646920"/>
+            <a:ext cx="11055096" cy="731520"/>
           </a:xfrm>
           <a:prstGeom prst="rect">
             <a:avLst/>
@@ -3766,7 +3766,7 @@
               <a:spcAft>
                 <a:spcPts val="400"/>
               </a:spcAft>
-              <a:defRPr sz="1900" b="1" i="0">
+              <a:defRPr sz="2400" b="1" i="0">
                 <a:solidFill>
                   <a:srgbClr val="C7563F"/>
                 </a:solidFill>
@@ -3774,7 +3774,7 @@
               </a:defRPr>
             </a:pPr>
             <a:r>
-              <a:t>Goal: make sensory discrimination methods feel native in Python without loosening the validation discipline.</a:t>
+              <a:t>The result: validated migration for sensory teams already working in Python.</a:t>
             </a:r>
           </a:p>
         </p:txBody>
@@ -3787,8 +3787,8 @@
         </p:nvSpPr>
         <p:spPr>
           <a:xfrm>
-            <a:off x="12975336" y="4297680"/>
-            <a:ext cx="11695176" cy="50292"/>
+            <a:off x="12975336" y="4251960"/>
+            <a:ext cx="11695176" cy="64008"/>
           </a:xfrm>
           <a:prstGeom prst="rect">
             <a:avLst/>
@@ -3830,8 +3830,8 @@
         </p:nvSpPr>
         <p:spPr>
           <a:xfrm>
-            <a:off x="12975336" y="4407408"/>
-            <a:ext cx="11695176" cy="502920"/>
+            <a:off x="12975336" y="4398264"/>
+            <a:ext cx="11695176" cy="694944"/>
           </a:xfrm>
           <a:prstGeom prst="rect">
             <a:avLst/>
@@ -3848,7 +3848,7 @@
               <a:spcAft>
                 <a:spcPts val="400"/>
               </a:spcAft>
-              <a:defRPr sz="2900" b="0" i="0">
+              <a:defRPr sz="3800" b="0" i="0">
                 <a:solidFill>
                   <a:srgbClr val="10231A"/>
                 </a:solidFill>
@@ -3856,7 +3856,7 @@
               </a:defRPr>
             </a:pPr>
             <a:r>
-              <a:t>What sensPy ports</a:t>
+              <a:t>Evidence at a glance</a:t>
             </a:r>
           </a:p>
         </p:txBody>
@@ -3869,8 +3869,8 @@
         </p:nvSpPr>
         <p:spPr>
           <a:xfrm>
-            <a:off x="13021056" y="5102352"/>
-            <a:ext cx="3730751" cy="1325880"/>
+            <a:off x="13021056" y="5285232"/>
+            <a:ext cx="5641848" cy="2148840"/>
           </a:xfrm>
           <a:prstGeom prst="roundRect">
             <a:avLst/>
@@ -3914,8 +3914,8 @@
         </p:nvSpPr>
         <p:spPr>
           <a:xfrm>
-            <a:off x="13075920" y="5175504"/>
-            <a:ext cx="3621023" cy="475488"/>
+            <a:off x="13094208" y="5449824"/>
+            <a:ext cx="5495544" cy="713232"/>
           </a:xfrm>
           <a:prstGeom prst="rect">
             <a:avLst/>
@@ -3932,7 +3932,7 @@
               <a:spcAft>
                 <a:spcPts val="400"/>
               </a:spcAft>
-              <a:defRPr sz="3000" b="1" i="0">
+              <a:defRPr sz="5000" b="1" i="0">
                 <a:solidFill>
                   <a:srgbClr val="C7563F"/>
                 </a:solidFill>
@@ -3953,8 +3953,8 @@
         </p:nvSpPr>
         <p:spPr>
           <a:xfrm>
-            <a:off x="13112496" y="5769864"/>
-            <a:ext cx="3547871" cy="365760"/>
+            <a:off x="13130784" y="6272784"/>
+            <a:ext cx="5422392" cy="566928"/>
           </a:xfrm>
           <a:prstGeom prst="rect">
             <a:avLst/>
@@ -3971,7 +3971,7 @@
               <a:spcAft>
                 <a:spcPts val="400"/>
               </a:spcAft>
-              <a:defRPr sz="1420" b="1" i="0">
+              <a:defRPr sz="2100" b="1" i="0">
                 <a:solidFill>
                   <a:srgbClr val="17291F"/>
                 </a:solidFill>
@@ -3992,8 +3992,8 @@
         </p:nvSpPr>
         <p:spPr>
           <a:xfrm>
-            <a:off x="13130784" y="6172200"/>
-            <a:ext cx="3511295" cy="256032"/>
+            <a:off x="13149072" y="6912864"/>
+            <a:ext cx="5385816" cy="521208"/>
           </a:xfrm>
           <a:prstGeom prst="rect">
             <a:avLst/>
@@ -4010,7 +4010,7 @@
               <a:spcAft>
                 <a:spcPts val="400"/>
               </a:spcAft>
-              <a:defRPr sz="1250" b="0" i="0">
+              <a:defRPr sz="1700" b="0" i="0">
                 <a:solidFill>
                   <a:srgbClr val="4D5A52"/>
                 </a:solidFill>
@@ -4031,8 +4031,8 @@
         </p:nvSpPr>
         <p:spPr>
           <a:xfrm>
-            <a:off x="16957548" y="5102352"/>
-            <a:ext cx="3730751" cy="1325880"/>
+            <a:off x="18982944" y="5285232"/>
+            <a:ext cx="5641848" cy="2148840"/>
           </a:xfrm>
           <a:prstGeom prst="roundRect">
             <a:avLst/>
@@ -4076,8 +4076,8 @@
         </p:nvSpPr>
         <p:spPr>
           <a:xfrm>
-            <a:off x="17012411" y="5175504"/>
-            <a:ext cx="3621023" cy="475488"/>
+            <a:off x="19056095" y="5449824"/>
+            <a:ext cx="5495544" cy="713232"/>
           </a:xfrm>
           <a:prstGeom prst="rect">
             <a:avLst/>
@@ -4094,7 +4094,7 @@
               <a:spcAft>
                 <a:spcPts val="400"/>
               </a:spcAft>
-              <a:defRPr sz="3000" b="1" i="0">
+              <a:defRPr sz="5000" b="1" i="0">
                 <a:solidFill>
                   <a:srgbClr val="4C8A61"/>
                 </a:solidFill>
@@ -4115,8 +4115,8 @@
         </p:nvSpPr>
         <p:spPr>
           <a:xfrm>
-            <a:off x="17048988" y="5769864"/>
-            <a:ext cx="3547871" cy="365760"/>
+            <a:off x="19092672" y="6272784"/>
+            <a:ext cx="5422392" cy="566928"/>
           </a:xfrm>
           <a:prstGeom prst="rect">
             <a:avLst/>
@@ -4133,7 +4133,7 @@
               <a:spcAft>
                 <a:spcPts val="400"/>
               </a:spcAft>
-              <a:defRPr sz="1420" b="1" i="0">
+              <a:defRPr sz="2100" b="1" i="0">
                 <a:solidFill>
                   <a:srgbClr val="17291F"/>
                 </a:solidFill>
@@ -4154,8 +4154,8 @@
         </p:nvSpPr>
         <p:spPr>
           <a:xfrm>
-            <a:off x="17067276" y="6172200"/>
-            <a:ext cx="3511295" cy="256032"/>
+            <a:off x="19110960" y="6912864"/>
+            <a:ext cx="5385816" cy="521208"/>
           </a:xfrm>
           <a:prstGeom prst="rect">
             <a:avLst/>
@@ -4172,7 +4172,7 @@
               <a:spcAft>
                 <a:spcPts val="400"/>
               </a:spcAft>
-              <a:defRPr sz="1250" b="0" i="0">
+              <a:defRPr sz="1700" b="0" i="0">
                 <a:solidFill>
                   <a:srgbClr val="4D5A52"/>
                 </a:solidFill>
@@ -4193,8 +4193,8 @@
         </p:nvSpPr>
         <p:spPr>
           <a:xfrm>
-            <a:off x="20894039" y="5102352"/>
-            <a:ext cx="3730751" cy="1325880"/>
+            <a:off x="13021056" y="7781544"/>
+            <a:ext cx="5641848" cy="2148840"/>
           </a:xfrm>
           <a:prstGeom prst="roundRect">
             <a:avLst/>
@@ -4238,8 +4238,8 @@
         </p:nvSpPr>
         <p:spPr>
           <a:xfrm>
-            <a:off x="20948903" y="5175504"/>
-            <a:ext cx="3621023" cy="475488"/>
+            <a:off x="13094208" y="7946136"/>
+            <a:ext cx="5495544" cy="713232"/>
           </a:xfrm>
           <a:prstGeom prst="rect">
             <a:avLst/>
@@ -4256,7 +4256,7 @@
               <a:spcAft>
                 <a:spcPts val="400"/>
               </a:spcAft>
-              <a:defRPr sz="3000" b="1" i="0">
+              <a:defRPr sz="5000" b="1" i="0">
                 <a:solidFill>
                   <a:srgbClr val="C7563F"/>
                 </a:solidFill>
@@ -4277,8 +4277,8 @@
         </p:nvSpPr>
         <p:spPr>
           <a:xfrm>
-            <a:off x="20985480" y="5769864"/>
-            <a:ext cx="3547871" cy="365760"/>
+            <a:off x="13130784" y="8769096"/>
+            <a:ext cx="5422392" cy="566928"/>
           </a:xfrm>
           <a:prstGeom prst="rect">
             <a:avLst/>
@@ -4295,7 +4295,7 @@
               <a:spcAft>
                 <a:spcPts val="400"/>
               </a:spcAft>
-              <a:defRPr sz="1420" b="1" i="0">
+              <a:defRPr sz="2100" b="1" i="0">
                 <a:solidFill>
                   <a:srgbClr val="17291F"/>
                 </a:solidFill>
@@ -4316,8 +4316,8 @@
         </p:nvSpPr>
         <p:spPr>
           <a:xfrm>
-            <a:off x="21003768" y="6172200"/>
-            <a:ext cx="3511295" cy="256032"/>
+            <a:off x="13149072" y="9409176"/>
+            <a:ext cx="5385816" cy="521208"/>
           </a:xfrm>
           <a:prstGeom prst="rect">
             <a:avLst/>
@@ -4334,7 +4334,7 @@
               <a:spcAft>
                 <a:spcPts val="400"/>
               </a:spcAft>
-              <a:defRPr sz="1250" b="0" i="0">
+              <a:defRPr sz="1700" b="0" i="0">
                 <a:solidFill>
                   <a:srgbClr val="4D5A52"/>
                 </a:solidFill>
@@ -4355,8 +4355,8 @@
         </p:nvSpPr>
         <p:spPr>
           <a:xfrm>
-            <a:off x="13021056" y="6638544"/>
-            <a:ext cx="3730751" cy="1325880"/>
+            <a:off x="18982944" y="7781544"/>
+            <a:ext cx="5641848" cy="2148840"/>
           </a:xfrm>
           <a:prstGeom prst="roundRect">
             <a:avLst/>
@@ -4400,8 +4400,8 @@
         </p:nvSpPr>
         <p:spPr>
           <a:xfrm>
-            <a:off x="13075920" y="6711696"/>
-            <a:ext cx="3621023" cy="475488"/>
+            <a:off x="19056095" y="7946136"/>
+            <a:ext cx="5495544" cy="713232"/>
           </a:xfrm>
           <a:prstGeom prst="rect">
             <a:avLst/>
@@ -4418,7 +4418,7 @@
               <a:spcAft>
                 <a:spcPts val="400"/>
               </a:spcAft>
-              <a:defRPr sz="3000" b="1" i="0">
+              <a:defRPr sz="5000" b="1" i="0">
                 <a:solidFill>
                   <a:srgbClr val="4C8A61"/>
                 </a:solidFill>
@@ -4426,7 +4426,7 @@
               </a:defRPr>
             </a:pPr>
             <a:r>
-              <a:t>21</a:t>
+              <a:t>Plotly</a:t>
             </a:r>
           </a:p>
         </p:txBody>
@@ -4439,8 +4439,8 @@
         </p:nvSpPr>
         <p:spPr>
           <a:xfrm>
-            <a:off x="13112496" y="7306056"/>
-            <a:ext cx="3547871" cy="365760"/>
+            <a:off x="19092672" y="8769096"/>
+            <a:ext cx="5422392" cy="566928"/>
           </a:xfrm>
           <a:prstGeom prst="rect">
             <a:avLst/>
@@ -4457,7 +4457,7 @@
               <a:spcAft>
                 <a:spcPts val="400"/>
               </a:spcAft>
-              <a:defRPr sz="1420" b="1" i="0">
+              <a:defRPr sz="2100" b="1" i="0">
                 <a:solidFill>
                   <a:srgbClr val="17291F"/>
                 </a:solidFill>
@@ -4465,7 +4465,7 @@
               </a:defRPr>
             </a:pPr>
             <a:r>
-              <a:t>dataclasses</a:t>
+              <a:t>interactive figures</a:t>
             </a:r>
           </a:p>
         </p:txBody>
@@ -4478,8 +4478,8 @@
         </p:nvSpPr>
         <p:spPr>
           <a:xfrm>
-            <a:off x="13130784" y="7708392"/>
-            <a:ext cx="3511295" cy="256032"/>
+            <a:off x="19110960" y="9409176"/>
+            <a:ext cx="5385816" cy="521208"/>
           </a:xfrm>
           <a:prstGeom prst="rect">
             <a:avLst/>
@@ -4496,7 +4496,7 @@
               <a:spcAft>
                 <a:spcPts val="400"/>
               </a:spcAft>
-              <a:defRPr sz="1250" b="0" i="0">
+              <a:defRPr sz="1700" b="0" i="0">
                 <a:solidFill>
                   <a:srgbClr val="4D5A52"/>
                 </a:solidFill>
@@ -4504,21 +4504,577 @@
               </a:defRPr>
             </a:pPr>
             <a:r>
-              <a:t>typed Python results</a:t>
-            </a:r>
-          </a:p>
-        </p:txBody>
-      </p:sp>
-      <p:sp>
-        <p:nvSpPr>
-          <p:cNvPr id="37" name="Rounded Rectangle 36"/>
+              <a:t>psychometric + ROC</a:t>
+            </a:r>
+          </a:p>
+        </p:txBody>
+      </p:sp>
+      <p:sp>
+        <p:nvSpPr>
+          <p:cNvPr id="37" name="TextBox 36"/>
+          <p:cNvSpPr txBox="1"/>
+          <p:nvPr/>
+        </p:nvSpPr>
+        <p:spPr>
+          <a:xfrm>
+            <a:off x="13249656" y="10222992"/>
+            <a:ext cx="11146536" cy="594360"/>
+          </a:xfrm>
+          <a:prstGeom prst="rect">
+            <a:avLst/>
+          </a:prstGeom>
+          <a:noFill/>
+        </p:spPr>
+        <p:txBody>
+          <a:bodyPr wrap="square" anchor="t" lIns="45720" rIns="45720" tIns="18288" bIns="18288">
+            <a:spAutoFit/>
+          </a:bodyPr>
+          <a:lstStyle/>
+          <a:p>
+            <a:pPr algn="ctr">
+              <a:spcAft>
+                <a:spcPts val="400"/>
+              </a:spcAft>
+              <a:defRPr sz="2400" b="1" i="0">
+                <a:solidFill>
+                  <a:srgbClr val="17291F"/>
+                </a:solidFill>
+                <a:latin typeface="Arial"/>
+              </a:defRPr>
+            </a:pPr>
+            <a:r>
+              <a:t>Numerical parity target: 3-6 decimal places.</a:t>
+            </a:r>
+          </a:p>
+        </p:txBody>
+      </p:sp>
+      <p:sp>
+        <p:nvSpPr>
+          <p:cNvPr id="38" name="Rectangle 37"/>
           <p:cNvSpPr/>
           <p:nvPr/>
         </p:nvSpPr>
         <p:spPr>
           <a:xfrm>
-            <a:off x="16957548" y="6638544"/>
-            <a:ext cx="3730751" cy="1325880"/>
+            <a:off x="777240" y="11018520"/>
+            <a:ext cx="11695176" cy="64008"/>
+          </a:xfrm>
+          <a:prstGeom prst="rect">
+            <a:avLst/>
+          </a:prstGeom>
+          <a:solidFill>
+            <a:srgbClr val="C7563F"/>
+          </a:solidFill>
+          <a:ln>
+            <a:noFill/>
+          </a:ln>
+        </p:spPr>
+        <p:style>
+          <a:lnRef idx="1">
+            <a:schemeClr val="accent1"/>
+          </a:lnRef>
+          <a:fillRef idx="3">
+            <a:schemeClr val="accent1"/>
+          </a:fillRef>
+          <a:effectRef idx="2">
+            <a:schemeClr val="accent1"/>
+          </a:effectRef>
+          <a:fontRef idx="minor">
+            <a:schemeClr val="lt1"/>
+          </a:fontRef>
+        </p:style>
+        <p:txBody>
+          <a:bodyPr rtlCol="0" anchor="ctr"/>
+          <a:lstStyle/>
+          <a:p>
+            <a:pPr algn="ctr"/>
+          </a:p>
+        </p:txBody>
+      </p:sp>
+      <p:sp>
+        <p:nvSpPr>
+          <p:cNvPr id="39" name="TextBox 38"/>
+          <p:cNvSpPr txBox="1"/>
+          <p:nvPr/>
+        </p:nvSpPr>
+        <p:spPr>
+          <a:xfrm>
+            <a:off x="777240" y="11164824"/>
+            <a:ext cx="11695176" cy="694944"/>
+          </a:xfrm>
+          <a:prstGeom prst="rect">
+            <a:avLst/>
+          </a:prstGeom>
+          <a:noFill/>
+        </p:spPr>
+        <p:txBody>
+          <a:bodyPr wrap="square" anchor="t" lIns="0" rIns="0" tIns="18288" bIns="18288">
+            <a:spAutoFit/>
+          </a:bodyPr>
+          <a:lstStyle/>
+          <a:p>
+            <a:pPr algn="ctr">
+              <a:spcAft>
+                <a:spcPts val="400"/>
+              </a:spcAft>
+              <a:defRPr sz="3800" b="0" i="0">
+                <a:solidFill>
+                  <a:srgbClr val="10231A"/>
+                </a:solidFill>
+                <a:latin typeface="Georgia"/>
+              </a:defRPr>
+            </a:pPr>
+            <a:r>
+              <a:t>Protocol coverage</a:t>
+            </a:r>
+          </a:p>
+        </p:txBody>
+      </p:sp>
+      <p:pic>
+        <p:nvPicPr>
+          <p:cNvPr id="40" name="Picture 39" descr="protocol_coverage.png"/>
+          <p:cNvPicPr>
+            <a:picLocks noChangeAspect="1"/>
+          </p:cNvPicPr>
+          <p:nvPr/>
+        </p:nvPicPr>
+        <p:blipFill>
+          <a:blip r:embed="rId2"/>
+          <a:stretch>
+            <a:fillRect/>
+          </a:stretch>
+        </p:blipFill>
+        <p:spPr>
+          <a:xfrm>
+            <a:off x="2520866" y="12051792"/>
+            <a:ext cx="8207923" cy="5440680"/>
+          </a:xfrm>
+          <a:prstGeom prst="rect">
+            <a:avLst/>
+          </a:prstGeom>
+        </p:spPr>
+      </p:pic>
+      <p:sp>
+        <p:nvSpPr>
+          <p:cNvPr id="41" name="TextBox 40"/>
+          <p:cNvSpPr txBox="1"/>
+          <p:nvPr/>
+        </p:nvSpPr>
+        <p:spPr>
+          <a:xfrm>
+            <a:off x="1005840" y="17629632"/>
+            <a:ext cx="11237976" cy="594360"/>
+          </a:xfrm>
+          <a:prstGeom prst="rect">
+            <a:avLst/>
+          </a:prstGeom>
+          <a:noFill/>
+        </p:spPr>
+        <p:txBody>
+          <a:bodyPr wrap="square" anchor="t" lIns="45720" rIns="45720" tIns="18288" bIns="18288">
+            <a:spAutoFit/>
+          </a:bodyPr>
+          <a:lstStyle/>
+          <a:p>
+            <a:pPr algn="ctr">
+              <a:spcAft>
+                <a:spcPts val="400"/>
+              </a:spcAft>
+              <a:defRPr sz="2200" b="0" i="0">
+                <a:solidFill>
+                  <a:srgbClr val="4D5A52"/>
+                </a:solidFill>
+                <a:latin typeface="Arial"/>
+              </a:defRPr>
+            </a:pPr>
+            <a:r>
+              <a:t>Common d-prime scale, protocol-specific guessing.</a:t>
+            </a:r>
+          </a:p>
+        </p:txBody>
+      </p:sp>
+      <p:sp>
+        <p:nvSpPr>
+          <p:cNvPr id="42" name="Rectangle 41"/>
+          <p:cNvSpPr/>
+          <p:nvPr/>
+        </p:nvSpPr>
+        <p:spPr>
+          <a:xfrm>
+            <a:off x="12975336" y="11018520"/>
+            <a:ext cx="11695176" cy="64008"/>
+          </a:xfrm>
+          <a:prstGeom prst="rect">
+            <a:avLst/>
+          </a:prstGeom>
+          <a:solidFill>
+            <a:srgbClr val="C7563F"/>
+          </a:solidFill>
+          <a:ln>
+            <a:noFill/>
+          </a:ln>
+        </p:spPr>
+        <p:style>
+          <a:lnRef idx="1">
+            <a:schemeClr val="accent1"/>
+          </a:lnRef>
+          <a:fillRef idx="3">
+            <a:schemeClr val="accent1"/>
+          </a:fillRef>
+          <a:effectRef idx="2">
+            <a:schemeClr val="accent1"/>
+          </a:effectRef>
+          <a:fontRef idx="minor">
+            <a:schemeClr val="lt1"/>
+          </a:fontRef>
+        </p:style>
+        <p:txBody>
+          <a:bodyPr rtlCol="0" anchor="ctr"/>
+          <a:lstStyle/>
+          <a:p>
+            <a:pPr algn="ctr"/>
+          </a:p>
+        </p:txBody>
+      </p:sp>
+      <p:sp>
+        <p:nvSpPr>
+          <p:cNvPr id="43" name="TextBox 42"/>
+          <p:cNvSpPr txBox="1"/>
+          <p:nvPr/>
+        </p:nvSpPr>
+        <p:spPr>
+          <a:xfrm>
+            <a:off x="12975336" y="11164824"/>
+            <a:ext cx="11695176" cy="694944"/>
+          </a:xfrm>
+          <a:prstGeom prst="rect">
+            <a:avLst/>
+          </a:prstGeom>
+          <a:noFill/>
+        </p:spPr>
+        <p:txBody>
+          <a:bodyPr wrap="square" anchor="t" lIns="0" rIns="0" tIns="18288" bIns="18288">
+            <a:spAutoFit/>
+          </a:bodyPr>
+          <a:lstStyle/>
+          <a:p>
+            <a:pPr algn="ctr">
+              <a:spcAft>
+                <a:spcPts val="400"/>
+              </a:spcAft>
+              <a:defRPr sz="3800" b="0" i="0">
+                <a:solidFill>
+                  <a:srgbClr val="10231A"/>
+                </a:solidFill>
+                <a:latin typeface="Georgia"/>
+              </a:defRPr>
+            </a:pPr>
+            <a:r>
+              <a:t>Psychometric functions</a:t>
+            </a:r>
+          </a:p>
+        </p:txBody>
+      </p:sp>
+      <p:pic>
+        <p:nvPicPr>
+          <p:cNvPr id="44" name="Picture 43" descr="psychometric_curves.png"/>
+          <p:cNvPicPr>
+            <a:picLocks noChangeAspect="1"/>
+          </p:cNvPicPr>
+          <p:nvPr/>
+        </p:nvPicPr>
+        <p:blipFill>
+          <a:blip r:embed="rId3"/>
+          <a:stretch>
+            <a:fillRect/>
+          </a:stretch>
+        </p:blipFill>
+        <p:spPr>
+          <a:xfrm>
+            <a:off x="14497059" y="12051792"/>
+            <a:ext cx="8651729" cy="5440680"/>
+          </a:xfrm>
+          <a:prstGeom prst="rect">
+            <a:avLst/>
+          </a:prstGeom>
+        </p:spPr>
+      </p:pic>
+      <p:sp>
+        <p:nvSpPr>
+          <p:cNvPr id="45" name="TextBox 44"/>
+          <p:cNvSpPr txBox="1"/>
+          <p:nvPr/>
+        </p:nvSpPr>
+        <p:spPr>
+          <a:xfrm>
+            <a:off x="13203936" y="17629632"/>
+            <a:ext cx="11237976" cy="594360"/>
+          </a:xfrm>
+          <a:prstGeom prst="rect">
+            <a:avLst/>
+          </a:prstGeom>
+          <a:noFill/>
+        </p:spPr>
+        <p:txBody>
+          <a:bodyPr wrap="square" anchor="t" lIns="45720" rIns="45720" tIns="18288" bIns="18288">
+            <a:spAutoFit/>
+          </a:bodyPr>
+          <a:lstStyle/>
+          <a:p>
+            <a:pPr algn="ctr">
+              <a:spcAft>
+                <a:spcPts val="400"/>
+              </a:spcAft>
+              <a:defRPr sz="2200" b="0" i="0">
+                <a:solidFill>
+                  <a:srgbClr val="4D5A52"/>
+                </a:solidFill>
+                <a:latin typeface="Arial"/>
+              </a:defRPr>
+            </a:pPr>
+            <a:r>
+              <a:t>One API maps Pc, Pd, and d-prime.</a:t>
+            </a:r>
+          </a:p>
+        </p:txBody>
+      </p:sp>
+      <p:sp>
+        <p:nvSpPr>
+          <p:cNvPr id="46" name="Rectangle 45"/>
+          <p:cNvSpPr/>
+          <p:nvPr/>
+        </p:nvSpPr>
+        <p:spPr>
+          <a:xfrm>
+            <a:off x="777240" y="19248120"/>
+            <a:ext cx="11695176" cy="64008"/>
+          </a:xfrm>
+          <a:prstGeom prst="rect">
+            <a:avLst/>
+          </a:prstGeom>
+          <a:solidFill>
+            <a:srgbClr val="C7563F"/>
+          </a:solidFill>
+          <a:ln>
+            <a:noFill/>
+          </a:ln>
+        </p:spPr>
+        <p:style>
+          <a:lnRef idx="1">
+            <a:schemeClr val="accent1"/>
+          </a:lnRef>
+          <a:fillRef idx="3">
+            <a:schemeClr val="accent1"/>
+          </a:fillRef>
+          <a:effectRef idx="2">
+            <a:schemeClr val="accent1"/>
+          </a:effectRef>
+          <a:fontRef idx="minor">
+            <a:schemeClr val="lt1"/>
+          </a:fontRef>
+        </p:style>
+        <p:txBody>
+          <a:bodyPr rtlCol="0" anchor="ctr"/>
+          <a:lstStyle/>
+          <a:p>
+            <a:pPr algn="ctr"/>
+          </a:p>
+        </p:txBody>
+      </p:sp>
+      <p:sp>
+        <p:nvSpPr>
+          <p:cNvPr id="47" name="TextBox 46"/>
+          <p:cNvSpPr txBox="1"/>
+          <p:nvPr/>
+        </p:nvSpPr>
+        <p:spPr>
+          <a:xfrm>
+            <a:off x="777240" y="19394424"/>
+            <a:ext cx="11695176" cy="694944"/>
+          </a:xfrm>
+          <a:prstGeom prst="rect">
+            <a:avLst/>
+          </a:prstGeom>
+          <a:noFill/>
+        </p:spPr>
+        <p:txBody>
+          <a:bodyPr wrap="square" anchor="t" lIns="0" rIns="0" tIns="18288" bIns="18288">
+            <a:spAutoFit/>
+          </a:bodyPr>
+          <a:lstStyle/>
+          <a:p>
+            <a:pPr algn="ctr">
+              <a:spcAft>
+                <a:spcPts val="400"/>
+              </a:spcAft>
+              <a:defRPr sz="3800" b="0" i="0">
+                <a:solidFill>
+                  <a:srgbClr val="10231A"/>
+                </a:solidFill>
+                <a:latin typeface="Georgia"/>
+              </a:defRPr>
+            </a:pPr>
+            <a:r>
+              <a:t>Validation surface</a:t>
+            </a:r>
+          </a:p>
+        </p:txBody>
+      </p:sp>
+      <p:pic>
+        <p:nvPicPr>
+          <p:cNvPr id="48" name="Picture 47" descr="test_inventory.png"/>
+          <p:cNvPicPr>
+            <a:picLocks noChangeAspect="1"/>
+          </p:cNvPicPr>
+          <p:nvPr/>
+        </p:nvPicPr>
+        <p:blipFill>
+          <a:blip r:embed="rId4"/>
+          <a:stretch>
+            <a:fillRect/>
+          </a:stretch>
+        </p:blipFill>
+        <p:spPr>
+          <a:xfrm>
+            <a:off x="1407302" y="20281392"/>
+            <a:ext cx="10435051" cy="5394960"/>
+          </a:xfrm>
+          <a:prstGeom prst="rect">
+            <a:avLst/>
+          </a:prstGeom>
+        </p:spPr>
+      </p:pic>
+      <p:sp>
+        <p:nvSpPr>
+          <p:cNvPr id="49" name="TextBox 48"/>
+          <p:cNvSpPr txBox="1"/>
+          <p:nvPr/>
+        </p:nvSpPr>
+        <p:spPr>
+          <a:xfrm>
+            <a:off x="1005840" y="25831800"/>
+            <a:ext cx="11237976" cy="594360"/>
+          </a:xfrm>
+          <a:prstGeom prst="rect">
+            <a:avLst/>
+          </a:prstGeom>
+          <a:noFill/>
+        </p:spPr>
+        <p:txBody>
+          <a:bodyPr wrap="square" anchor="t" lIns="45720" rIns="45720" tIns="18288" bIns="18288">
+            <a:spAutoFit/>
+          </a:bodyPr>
+          <a:lstStyle/>
+          <a:p>
+            <a:pPr algn="ctr">
+              <a:spcAft>
+                <a:spcPts val="400"/>
+              </a:spcAft>
+              <a:defRPr sz="2200" b="0" i="0">
+                <a:solidFill>
+                  <a:srgbClr val="4D5A52"/>
+                </a:solidFill>
+                <a:latin typeface="Arial"/>
+              </a:defRPr>
+            </a:pPr>
+            <a:r>
+              <a:t>Golden sensR fixtures run beside unit, model, power, and plotting tests.</a:t>
+            </a:r>
+          </a:p>
+        </p:txBody>
+      </p:sp>
+      <p:sp>
+        <p:nvSpPr>
+          <p:cNvPr id="50" name="Rectangle 49"/>
+          <p:cNvSpPr/>
+          <p:nvPr/>
+        </p:nvSpPr>
+        <p:spPr>
+          <a:xfrm>
+            <a:off x="12975336" y="19248120"/>
+            <a:ext cx="11695176" cy="64008"/>
+          </a:xfrm>
+          <a:prstGeom prst="rect">
+            <a:avLst/>
+          </a:prstGeom>
+          <a:solidFill>
+            <a:srgbClr val="C7563F"/>
+          </a:solidFill>
+          <a:ln>
+            <a:noFill/>
+          </a:ln>
+        </p:spPr>
+        <p:style>
+          <a:lnRef idx="1">
+            <a:schemeClr val="accent1"/>
+          </a:lnRef>
+          <a:fillRef idx="3">
+            <a:schemeClr val="accent1"/>
+          </a:fillRef>
+          <a:effectRef idx="2">
+            <a:schemeClr val="accent1"/>
+          </a:effectRef>
+          <a:fontRef idx="minor">
+            <a:schemeClr val="lt1"/>
+          </a:fontRef>
+        </p:style>
+        <p:txBody>
+          <a:bodyPr rtlCol="0" anchor="ctr"/>
+          <a:lstStyle/>
+          <a:p>
+            <a:pPr algn="ctr"/>
+          </a:p>
+        </p:txBody>
+      </p:sp>
+      <p:sp>
+        <p:nvSpPr>
+          <p:cNvPr id="51" name="TextBox 50"/>
+          <p:cNvSpPr txBox="1"/>
+          <p:nvPr/>
+        </p:nvSpPr>
+        <p:spPr>
+          <a:xfrm>
+            <a:off x="12975336" y="19394424"/>
+            <a:ext cx="11695176" cy="694944"/>
+          </a:xfrm>
+          <a:prstGeom prst="rect">
+            <a:avLst/>
+          </a:prstGeom>
+          <a:noFill/>
+        </p:spPr>
+        <p:txBody>
+          <a:bodyPr wrap="square" anchor="t" lIns="0" rIns="0" tIns="18288" bIns="18288">
+            <a:spAutoFit/>
+          </a:bodyPr>
+          <a:lstStyle/>
+          <a:p>
+            <a:pPr algn="ctr">
+              <a:spcAft>
+                <a:spcPts val="400"/>
+              </a:spcAft>
+              <a:defRPr sz="3800" b="0" i="0">
+                <a:solidFill>
+                  <a:srgbClr val="10231A"/>
+                </a:solidFill>
+                <a:latin typeface="Georgia"/>
+              </a:defRPr>
+            </a:pPr>
+            <a:r>
+              <a:t>Advanced models</a:t>
+            </a:r>
+          </a:p>
+        </p:txBody>
+      </p:sp>
+      <p:sp>
+        <p:nvSpPr>
+          <p:cNvPr id="52" name="Rounded Rectangle 51"/>
+          <p:cNvSpPr/>
+          <p:nvPr/>
+        </p:nvSpPr>
+        <p:spPr>
+          <a:xfrm>
+            <a:off x="13021056" y="20372832"/>
+            <a:ext cx="3700271" cy="2377440"/>
           </a:xfrm>
           <a:prstGeom prst="roundRect">
             <a:avLst/>
@@ -4556,14 +5112,14 @@
       </p:sp>
       <p:sp>
         <p:nvSpPr>
-          <p:cNvPr id="38" name="TextBox 37"/>
+          <p:cNvPr id="53" name="TextBox 52"/>
           <p:cNvSpPr txBox="1"/>
           <p:nvPr/>
         </p:nvSpPr>
         <p:spPr>
           <a:xfrm>
-            <a:off x="17012411" y="6711696"/>
-            <a:ext cx="3621023" cy="475488"/>
+            <a:off x="13094208" y="20537424"/>
+            <a:ext cx="3553967" cy="713232"/>
           </a:xfrm>
           <a:prstGeom prst="rect">
             <a:avLst/>
@@ -4580,7 +5136,7 @@
               <a:spcAft>
                 <a:spcPts val="400"/>
               </a:spcAft>
-              <a:defRPr sz="3000" b="1" i="0">
+              <a:defRPr sz="5000" b="1" i="0">
                 <a:solidFill>
                   <a:srgbClr val="4C8A61"/>
                 </a:solidFill>
@@ -4588,21 +5144,21 @@
               </a:defRPr>
             </a:pPr>
             <a:r>
-              <a:t>82</a:t>
-            </a:r>
-          </a:p>
-        </p:txBody>
-      </p:sp>
-      <p:sp>
-        <p:nvSpPr>
-          <p:cNvPr id="39" name="TextBox 38"/>
+              <a:t>BB</a:t>
+            </a:r>
+          </a:p>
+        </p:txBody>
+      </p:sp>
+      <p:sp>
+        <p:nvSpPr>
+          <p:cNvPr id="54" name="TextBox 53"/>
           <p:cNvSpPr txBox="1"/>
           <p:nvPr/>
         </p:nvSpPr>
         <p:spPr>
           <a:xfrm>
-            <a:off x="17048988" y="7306056"/>
-            <a:ext cx="3547871" cy="365760"/>
+            <a:off x="13130784" y="21360384"/>
+            <a:ext cx="3480815" cy="566928"/>
           </a:xfrm>
           <a:prstGeom prst="rect">
             <a:avLst/>
@@ -4619,7 +5175,7 @@
               <a:spcAft>
                 <a:spcPts val="400"/>
               </a:spcAft>
-              <a:defRPr sz="1420" b="1" i="0">
+              <a:defRPr sz="2100" b="1" i="0">
                 <a:solidFill>
                   <a:srgbClr val="17291F"/>
                 </a:solidFill>
@@ -4627,21 +5183,21 @@
               </a:defRPr>
             </a:pPr>
             <a:r>
-              <a:t>public exports</a:t>
-            </a:r>
-          </a:p>
-        </p:txBody>
-      </p:sp>
-      <p:sp>
-        <p:nvSpPr>
-          <p:cNvPr id="40" name="TextBox 39"/>
+              <a:t>Beta-Binomial</a:t>
+            </a:r>
+          </a:p>
+        </p:txBody>
+      </p:sp>
+      <p:sp>
+        <p:nvSpPr>
+          <p:cNvPr id="55" name="TextBox 54"/>
           <p:cNvSpPr txBox="1"/>
           <p:nvPr/>
         </p:nvSpPr>
         <p:spPr>
           <a:xfrm>
-            <a:off x="17067276" y="7708392"/>
-            <a:ext cx="3511295" cy="256032"/>
+            <a:off x="13149072" y="22000464"/>
+            <a:ext cx="3444239" cy="749808"/>
           </a:xfrm>
           <a:prstGeom prst="rect">
             <a:avLst/>
@@ -4658,7 +5214,7 @@
               <a:spcAft>
                 <a:spcPts val="400"/>
               </a:spcAft>
-              <a:defRPr sz="1250" b="0" i="0">
+              <a:defRPr sz="1700" b="0" i="0">
                 <a:solidFill>
                   <a:srgbClr val="4D5A52"/>
                 </a:solidFill>
@@ -4666,21 +5222,21 @@
               </a:defRPr>
             </a:pPr>
             <a:r>
-              <a:t>single import surface</a:t>
-            </a:r>
-          </a:p>
-        </p:txBody>
-      </p:sp>
-      <p:sp>
-        <p:nvSpPr>
-          <p:cNvPr id="41" name="Rounded Rectangle 40"/>
+              <a:t>overdispersed panel data</a:t>
+            </a:r>
+          </a:p>
+        </p:txBody>
+      </p:sp>
+      <p:sp>
+        <p:nvSpPr>
+          <p:cNvPr id="56" name="Rounded Rectangle 55"/>
           <p:cNvSpPr/>
           <p:nvPr/>
         </p:nvSpPr>
         <p:spPr>
           <a:xfrm>
-            <a:off x="20894039" y="6638544"/>
-            <a:ext cx="3730751" cy="1325880"/>
+            <a:off x="16972787" y="20372832"/>
+            <a:ext cx="3700271" cy="2377440"/>
           </a:xfrm>
           <a:prstGeom prst="roundRect">
             <a:avLst/>
@@ -4718,14 +5274,14 @@
       </p:sp>
       <p:sp>
         <p:nvSpPr>
-          <p:cNvPr id="42" name="TextBox 41"/>
+          <p:cNvPr id="57" name="TextBox 56"/>
           <p:cNvSpPr txBox="1"/>
           <p:nvPr/>
         </p:nvSpPr>
         <p:spPr>
           <a:xfrm>
-            <a:off x="20948903" y="6711696"/>
-            <a:ext cx="3621023" cy="475488"/>
+            <a:off x="17045939" y="20537424"/>
+            <a:ext cx="3553967" cy="713232"/>
           </a:xfrm>
           <a:prstGeom prst="rect">
             <a:avLst/>
@@ -4742,7 +5298,7 @@
               <a:spcAft>
                 <a:spcPts val="400"/>
               </a:spcAft>
-              <a:defRPr sz="3000" b="1" i="0">
+              <a:defRPr sz="5000" b="1" i="0">
                 <a:solidFill>
                   <a:srgbClr val="C7563F"/>
                 </a:solidFill>
@@ -4750,21 +5306,21 @@
               </a:defRPr>
             </a:pPr>
             <a:r>
-              <a:t>Plotly</a:t>
-            </a:r>
-          </a:p>
-        </p:txBody>
-      </p:sp>
-      <p:sp>
-        <p:nvSpPr>
-          <p:cNvPr id="43" name="TextBox 42"/>
+              <a:t>SD</a:t>
+            </a:r>
+          </a:p>
+        </p:txBody>
+      </p:sp>
+      <p:sp>
+        <p:nvSpPr>
+          <p:cNvPr id="58" name="TextBox 57"/>
           <p:cNvSpPr txBox="1"/>
           <p:nvPr/>
         </p:nvSpPr>
         <p:spPr>
           <a:xfrm>
-            <a:off x="20985480" y="7306056"/>
-            <a:ext cx="3547871" cy="365760"/>
+            <a:off x="17082516" y="21360384"/>
+            <a:ext cx="3480815" cy="566928"/>
           </a:xfrm>
           <a:prstGeom prst="rect">
             <a:avLst/>
@@ -4781,7 +5337,7 @@
               <a:spcAft>
                 <a:spcPts val="400"/>
               </a:spcAft>
-              <a:defRPr sz="1420" b="1" i="0">
+              <a:defRPr sz="2100" b="1" i="0">
                 <a:solidFill>
                   <a:srgbClr val="17291F"/>
                 </a:solidFill>
@@ -4789,21 +5345,21 @@
               </a:defRPr>
             </a:pPr>
             <a:r>
-              <a:t>interactive figures</a:t>
-            </a:r>
-          </a:p>
-        </p:txBody>
-      </p:sp>
-      <p:sp>
-        <p:nvSpPr>
-          <p:cNvPr id="44" name="TextBox 43"/>
+              <a:t>Same-Different</a:t>
+            </a:r>
+          </a:p>
+        </p:txBody>
+      </p:sp>
+      <p:sp>
+        <p:nvSpPr>
+          <p:cNvPr id="59" name="TextBox 58"/>
           <p:cNvSpPr txBox="1"/>
           <p:nvPr/>
         </p:nvSpPr>
         <p:spPr>
           <a:xfrm>
-            <a:off x="21003768" y="7708392"/>
-            <a:ext cx="3511295" cy="256032"/>
+            <a:off x="17100803" y="22000464"/>
+            <a:ext cx="3444239" cy="749808"/>
           </a:xfrm>
           <a:prstGeom prst="rect">
             <a:avLst/>
@@ -4820,7 +5376,7 @@
               <a:spcAft>
                 <a:spcPts val="400"/>
               </a:spcAft>
-              <a:defRPr sz="1250" b="0" i="0">
+              <a:defRPr sz="1700" b="0" i="0">
                 <a:solidFill>
                   <a:srgbClr val="4D5A52"/>
                 </a:solidFill>
@@ -4828,707 +5384,21 @@
               </a:defRPr>
             </a:pPr>
             <a:r>
-              <a:t>psychometric + ROC</a:t>
-            </a:r>
-          </a:p>
-        </p:txBody>
-      </p:sp>
-      <p:sp>
-        <p:nvSpPr>
-          <p:cNvPr id="45" name="TextBox 44"/>
-          <p:cNvSpPr txBox="1"/>
-          <p:nvPr/>
-        </p:nvSpPr>
-        <p:spPr>
-          <a:xfrm>
-            <a:off x="13139928" y="8266176"/>
-            <a:ext cx="11365992" cy="502920"/>
-          </a:xfrm>
-          <a:prstGeom prst="rect">
-            <a:avLst/>
-          </a:prstGeom>
-          <a:noFill/>
-        </p:spPr>
-        <p:txBody>
-          <a:bodyPr wrap="square" anchor="t" lIns="45720" rIns="45720" tIns="18288" bIns="18288">
-            <a:spAutoFit/>
-          </a:bodyPr>
-          <a:lstStyle/>
-          <a:p>
-            <a:pPr algn="ctr">
-              <a:spcAft>
-                <a:spcPts val="400"/>
-              </a:spcAft>
-              <a:defRPr sz="1750" b="1" i="0">
-                <a:solidFill>
-                  <a:srgbClr val="17291F"/>
-                </a:solidFill>
-                <a:latin typeface="Arial"/>
-              </a:defRPr>
-            </a:pPr>
-            <a:r>
-              <a:t>Numerical parity targets: 3-6 decimal places across sensR-backed fixtures and boundary cases.</a:t>
-            </a:r>
-          </a:p>
-        </p:txBody>
-      </p:sp>
-      <p:sp>
-        <p:nvSpPr>
-          <p:cNvPr id="46" name="Rectangle 45"/>
+              <a:t>Thurstonian criterion model</a:t>
+            </a:r>
+          </a:p>
+        </p:txBody>
+      </p:sp>
+      <p:sp>
+        <p:nvSpPr>
+          <p:cNvPr id="60" name="Rounded Rectangle 59"/>
           <p:cNvSpPr/>
           <p:nvPr/>
         </p:nvSpPr>
         <p:spPr>
           <a:xfrm>
-            <a:off x="777240" y="8823960"/>
-            <a:ext cx="11695176" cy="50292"/>
-          </a:xfrm>
-          <a:prstGeom prst="rect">
-            <a:avLst/>
-          </a:prstGeom>
-          <a:solidFill>
-            <a:srgbClr val="C7563F"/>
-          </a:solidFill>
-          <a:ln>
-            <a:noFill/>
-          </a:ln>
-        </p:spPr>
-        <p:style>
-          <a:lnRef idx="1">
-            <a:schemeClr val="accent1"/>
-          </a:lnRef>
-          <a:fillRef idx="3">
-            <a:schemeClr val="accent1"/>
-          </a:fillRef>
-          <a:effectRef idx="2">
-            <a:schemeClr val="accent1"/>
-          </a:effectRef>
-          <a:fontRef idx="minor">
-            <a:schemeClr val="lt1"/>
-          </a:fontRef>
-        </p:style>
-        <p:txBody>
-          <a:bodyPr rtlCol="0" anchor="ctr"/>
-          <a:lstStyle/>
-          <a:p>
-            <a:pPr algn="ctr"/>
-          </a:p>
-        </p:txBody>
-      </p:sp>
-      <p:sp>
-        <p:nvSpPr>
-          <p:cNvPr id="47" name="TextBox 46"/>
-          <p:cNvSpPr txBox="1"/>
-          <p:nvPr/>
-        </p:nvSpPr>
-        <p:spPr>
-          <a:xfrm>
-            <a:off x="777240" y="8933688"/>
-            <a:ext cx="11695176" cy="502920"/>
-          </a:xfrm>
-          <a:prstGeom prst="rect">
-            <a:avLst/>
-          </a:prstGeom>
-          <a:noFill/>
-        </p:spPr>
-        <p:txBody>
-          <a:bodyPr wrap="square" anchor="t" lIns="0" rIns="0" tIns="18288" bIns="18288">
-            <a:spAutoFit/>
-          </a:bodyPr>
-          <a:lstStyle/>
-          <a:p>
-            <a:pPr algn="ctr">
-              <a:spcAft>
-                <a:spcPts val="400"/>
-              </a:spcAft>
-              <a:defRPr sz="2900" b="0" i="0">
-                <a:solidFill>
-                  <a:srgbClr val="10231A"/>
-                </a:solidFill>
-                <a:latin typeface="Georgia"/>
-              </a:defRPr>
-            </a:pPr>
-            <a:r>
-              <a:t>Protocol coverage</a:t>
-            </a:r>
-          </a:p>
-        </p:txBody>
-      </p:sp>
-      <p:pic>
-        <p:nvPicPr>
-          <p:cNvPr id="48" name="Picture 47" descr="protocol_coverage.png"/>
-          <p:cNvPicPr>
-            <a:picLocks noChangeAspect="1"/>
-          </p:cNvPicPr>
-          <p:nvPr/>
-        </p:nvPicPr>
-        <p:blipFill>
-          <a:blip r:embed="rId2"/>
-          <a:stretch>
-            <a:fillRect/>
-          </a:stretch>
-        </p:blipFill>
-        <p:spPr>
-          <a:xfrm>
-            <a:off x="3410235" y="9555480"/>
-            <a:ext cx="6429186" cy="4343400"/>
-          </a:xfrm>
-          <a:prstGeom prst="rect">
-            <a:avLst/>
-          </a:prstGeom>
-        </p:spPr>
-      </p:pic>
-      <p:sp>
-        <p:nvSpPr>
-          <p:cNvPr id="49" name="TextBox 48"/>
-          <p:cNvSpPr txBox="1"/>
-          <p:nvPr/>
-        </p:nvSpPr>
-        <p:spPr>
-          <a:xfrm>
-            <a:off x="1005840" y="14017752"/>
-            <a:ext cx="11237976" cy="502920"/>
-          </a:xfrm>
-          <a:prstGeom prst="rect">
-            <a:avLst/>
-          </a:prstGeom>
-          <a:noFill/>
-        </p:spPr>
-        <p:txBody>
-          <a:bodyPr wrap="square" anchor="t" lIns="45720" rIns="45720" tIns="18288" bIns="18288">
-            <a:spAutoFit/>
-          </a:bodyPr>
-          <a:lstStyle/>
-          <a:p>
-            <a:pPr algn="ctr">
-              <a:spcAft>
-                <a:spcPts val="400"/>
-              </a:spcAft>
-              <a:defRPr sz="1600" b="0" i="0">
-                <a:solidFill>
-                  <a:srgbClr val="4D5A52"/>
-                </a:solidFill>
-                <a:latin typeface="Arial"/>
-              </a:defRPr>
-            </a:pPr>
-            <a:r>
-              <a:t>Common d-prime scale, protocol-specific guessing.</a:t>
-            </a:r>
-          </a:p>
-        </p:txBody>
-      </p:sp>
-      <p:sp>
-        <p:nvSpPr>
-          <p:cNvPr id="50" name="Rectangle 49"/>
-          <p:cNvSpPr/>
-          <p:nvPr/>
-        </p:nvSpPr>
-        <p:spPr>
-          <a:xfrm>
-            <a:off x="12975336" y="8823960"/>
-            <a:ext cx="11695176" cy="50292"/>
-          </a:xfrm>
-          <a:prstGeom prst="rect">
-            <a:avLst/>
-          </a:prstGeom>
-          <a:solidFill>
-            <a:srgbClr val="C7563F"/>
-          </a:solidFill>
-          <a:ln>
-            <a:noFill/>
-          </a:ln>
-        </p:spPr>
-        <p:style>
-          <a:lnRef idx="1">
-            <a:schemeClr val="accent1"/>
-          </a:lnRef>
-          <a:fillRef idx="3">
-            <a:schemeClr val="accent1"/>
-          </a:fillRef>
-          <a:effectRef idx="2">
-            <a:schemeClr val="accent1"/>
-          </a:effectRef>
-          <a:fontRef idx="minor">
-            <a:schemeClr val="lt1"/>
-          </a:fontRef>
-        </p:style>
-        <p:txBody>
-          <a:bodyPr rtlCol="0" anchor="ctr"/>
-          <a:lstStyle/>
-          <a:p>
-            <a:pPr algn="ctr"/>
-          </a:p>
-        </p:txBody>
-      </p:sp>
-      <p:sp>
-        <p:nvSpPr>
-          <p:cNvPr id="51" name="TextBox 50"/>
-          <p:cNvSpPr txBox="1"/>
-          <p:nvPr/>
-        </p:nvSpPr>
-        <p:spPr>
-          <a:xfrm>
-            <a:off x="12975336" y="8933688"/>
-            <a:ext cx="11695176" cy="502920"/>
-          </a:xfrm>
-          <a:prstGeom prst="rect">
-            <a:avLst/>
-          </a:prstGeom>
-          <a:noFill/>
-        </p:spPr>
-        <p:txBody>
-          <a:bodyPr wrap="square" anchor="t" lIns="0" rIns="0" tIns="18288" bIns="18288">
-            <a:spAutoFit/>
-          </a:bodyPr>
-          <a:lstStyle/>
-          <a:p>
-            <a:pPr algn="ctr">
-              <a:spcAft>
-                <a:spcPts val="400"/>
-              </a:spcAft>
-              <a:defRPr sz="2900" b="0" i="0">
-                <a:solidFill>
-                  <a:srgbClr val="10231A"/>
-                </a:solidFill>
-                <a:latin typeface="Georgia"/>
-              </a:defRPr>
-            </a:pPr>
-            <a:r>
-              <a:t>Psychometric functions</a:t>
-            </a:r>
-          </a:p>
-        </p:txBody>
-      </p:sp>
-      <p:pic>
-        <p:nvPicPr>
-          <p:cNvPr id="52" name="Picture 51" descr="psychometric_curves.png"/>
-          <p:cNvPicPr>
-            <a:picLocks noChangeAspect="1"/>
-          </p:cNvPicPr>
-          <p:nvPr/>
-        </p:nvPicPr>
-        <p:blipFill>
-          <a:blip r:embed="rId3"/>
-          <a:stretch>
-            <a:fillRect/>
-          </a:stretch>
-        </p:blipFill>
-        <p:spPr>
-          <a:xfrm>
-            <a:off x="15663551" y="9555480"/>
-            <a:ext cx="6318745" cy="4370832"/>
-          </a:xfrm>
-          <a:prstGeom prst="rect">
-            <a:avLst/>
-          </a:prstGeom>
-        </p:spPr>
-      </p:pic>
-      <p:sp>
-        <p:nvSpPr>
-          <p:cNvPr id="53" name="TextBox 52"/>
-          <p:cNvSpPr txBox="1"/>
-          <p:nvPr/>
-        </p:nvSpPr>
-        <p:spPr>
-          <a:xfrm>
-            <a:off x="13203936" y="14036040"/>
-            <a:ext cx="11237976" cy="457200"/>
-          </a:xfrm>
-          <a:prstGeom prst="rect">
-            <a:avLst/>
-          </a:prstGeom>
-          <a:noFill/>
-        </p:spPr>
-        <p:txBody>
-          <a:bodyPr wrap="square" anchor="t" lIns="45720" rIns="45720" tIns="18288" bIns="18288">
-            <a:spAutoFit/>
-          </a:bodyPr>
-          <a:lstStyle/>
-          <a:p>
-            <a:pPr algn="ctr">
-              <a:spcAft>
-                <a:spcPts val="400"/>
-              </a:spcAft>
-              <a:defRPr sz="1600" b="0" i="0">
-                <a:solidFill>
-                  <a:srgbClr val="4D5A52"/>
-                </a:solidFill>
-                <a:latin typeface="Arial"/>
-              </a:defRPr>
-            </a:pPr>
-            <a:r>
-              <a:t>One API maps Pc, Pd, and d-prime.</a:t>
-            </a:r>
-          </a:p>
-        </p:txBody>
-      </p:sp>
-      <p:sp>
-        <p:nvSpPr>
-          <p:cNvPr id="54" name="Rectangle 53"/>
-          <p:cNvSpPr/>
-          <p:nvPr/>
-        </p:nvSpPr>
-        <p:spPr>
-          <a:xfrm>
-            <a:off x="777240" y="14859000"/>
-            <a:ext cx="11695176" cy="50292"/>
-          </a:xfrm>
-          <a:prstGeom prst="rect">
-            <a:avLst/>
-          </a:prstGeom>
-          <a:solidFill>
-            <a:srgbClr val="C7563F"/>
-          </a:solidFill>
-          <a:ln>
-            <a:noFill/>
-          </a:ln>
-        </p:spPr>
-        <p:style>
-          <a:lnRef idx="1">
-            <a:schemeClr val="accent1"/>
-          </a:lnRef>
-          <a:fillRef idx="3">
-            <a:schemeClr val="accent1"/>
-          </a:fillRef>
-          <a:effectRef idx="2">
-            <a:schemeClr val="accent1"/>
-          </a:effectRef>
-          <a:fontRef idx="minor">
-            <a:schemeClr val="lt1"/>
-          </a:fontRef>
-        </p:style>
-        <p:txBody>
-          <a:bodyPr rtlCol="0" anchor="ctr"/>
-          <a:lstStyle/>
-          <a:p>
-            <a:pPr algn="ctr"/>
-          </a:p>
-        </p:txBody>
-      </p:sp>
-      <p:sp>
-        <p:nvSpPr>
-          <p:cNvPr id="55" name="TextBox 54"/>
-          <p:cNvSpPr txBox="1"/>
-          <p:nvPr/>
-        </p:nvSpPr>
-        <p:spPr>
-          <a:xfrm>
-            <a:off x="777240" y="14968728"/>
-            <a:ext cx="11695176" cy="502920"/>
-          </a:xfrm>
-          <a:prstGeom prst="rect">
-            <a:avLst/>
-          </a:prstGeom>
-          <a:noFill/>
-        </p:spPr>
-        <p:txBody>
-          <a:bodyPr wrap="square" anchor="t" lIns="0" rIns="0" tIns="18288" bIns="18288">
-            <a:spAutoFit/>
-          </a:bodyPr>
-          <a:lstStyle/>
-          <a:p>
-            <a:pPr algn="ctr">
-              <a:spcAft>
-                <a:spcPts val="400"/>
-              </a:spcAft>
-              <a:defRPr sz="2900" b="0" i="0">
-                <a:solidFill>
-                  <a:srgbClr val="10231A"/>
-                </a:solidFill>
-                <a:latin typeface="Georgia"/>
-              </a:defRPr>
-            </a:pPr>
-            <a:r>
-              <a:t>Validation surface</a:t>
-            </a:r>
-          </a:p>
-        </p:txBody>
-      </p:sp>
-      <p:pic>
-        <p:nvPicPr>
-          <p:cNvPr id="56" name="Picture 55" descr="test_inventory.png"/>
-          <p:cNvPicPr>
-            <a:picLocks noChangeAspect="1"/>
-          </p:cNvPicPr>
-          <p:nvPr/>
-        </p:nvPicPr>
-        <p:blipFill>
-          <a:blip r:embed="rId4"/>
-          <a:stretch>
-            <a:fillRect/>
-          </a:stretch>
-        </p:blipFill>
-        <p:spPr>
-          <a:xfrm>
-            <a:off x="2644389" y="15590520"/>
-            <a:ext cx="7960877" cy="4526280"/>
-          </a:xfrm>
-          <a:prstGeom prst="rect">
-            <a:avLst/>
-          </a:prstGeom>
-        </p:spPr>
-      </p:pic>
-      <p:sp>
-        <p:nvSpPr>
-          <p:cNvPr id="57" name="TextBox 56"/>
-          <p:cNvSpPr txBox="1"/>
-          <p:nvPr/>
-        </p:nvSpPr>
-        <p:spPr>
-          <a:xfrm>
-            <a:off x="1005840" y="20217384"/>
-            <a:ext cx="11237976" cy="457200"/>
-          </a:xfrm>
-          <a:prstGeom prst="rect">
-            <a:avLst/>
-          </a:prstGeom>
-          <a:noFill/>
-        </p:spPr>
-        <p:txBody>
-          <a:bodyPr wrap="square" anchor="t" lIns="45720" rIns="45720" tIns="18288" bIns="18288">
-            <a:spAutoFit/>
-          </a:bodyPr>
-          <a:lstStyle/>
-          <a:p>
-            <a:pPr algn="ctr">
-              <a:spcAft>
-                <a:spcPts val="400"/>
-              </a:spcAft>
-              <a:defRPr sz="1600" b="0" i="0">
-                <a:solidFill>
-                  <a:srgbClr val="4D5A52"/>
-                </a:solidFill>
-                <a:latin typeface="Arial"/>
-              </a:defRPr>
-            </a:pPr>
-            <a:r>
-              <a:t>Golden sensR fixtures run beside unit, model, power, and plotting tests.</a:t>
-            </a:r>
-          </a:p>
-        </p:txBody>
-      </p:sp>
-      <p:sp>
-        <p:nvSpPr>
-          <p:cNvPr id="58" name="Rectangle 57"/>
-          <p:cNvSpPr/>
-          <p:nvPr/>
-        </p:nvSpPr>
-        <p:spPr>
-          <a:xfrm>
-            <a:off x="12975336" y="14859000"/>
-            <a:ext cx="11695176" cy="50292"/>
-          </a:xfrm>
-          <a:prstGeom prst="rect">
-            <a:avLst/>
-          </a:prstGeom>
-          <a:solidFill>
-            <a:srgbClr val="C7563F"/>
-          </a:solidFill>
-          <a:ln>
-            <a:noFill/>
-          </a:ln>
-        </p:spPr>
-        <p:style>
-          <a:lnRef idx="1">
-            <a:schemeClr val="accent1"/>
-          </a:lnRef>
-          <a:fillRef idx="3">
-            <a:schemeClr val="accent1"/>
-          </a:fillRef>
-          <a:effectRef idx="2">
-            <a:schemeClr val="accent1"/>
-          </a:effectRef>
-          <a:fontRef idx="minor">
-            <a:schemeClr val="lt1"/>
-          </a:fontRef>
-        </p:style>
-        <p:txBody>
-          <a:bodyPr rtlCol="0" anchor="ctr"/>
-          <a:lstStyle/>
-          <a:p>
-            <a:pPr algn="ctr"/>
-          </a:p>
-        </p:txBody>
-      </p:sp>
-      <p:sp>
-        <p:nvSpPr>
-          <p:cNvPr id="59" name="TextBox 58"/>
-          <p:cNvSpPr txBox="1"/>
-          <p:nvPr/>
-        </p:nvSpPr>
-        <p:spPr>
-          <a:xfrm>
-            <a:off x="12975336" y="14968728"/>
-            <a:ext cx="11695176" cy="502920"/>
-          </a:xfrm>
-          <a:prstGeom prst="rect">
-            <a:avLst/>
-          </a:prstGeom>
-          <a:noFill/>
-        </p:spPr>
-        <p:txBody>
-          <a:bodyPr wrap="square" anchor="t" lIns="0" rIns="0" tIns="18288" bIns="18288">
-            <a:spAutoFit/>
-          </a:bodyPr>
-          <a:lstStyle/>
-          <a:p>
-            <a:pPr algn="ctr">
-              <a:spcAft>
-                <a:spcPts val="400"/>
-              </a:spcAft>
-              <a:defRPr sz="2900" b="0" i="0">
-                <a:solidFill>
-                  <a:srgbClr val="10231A"/>
-                </a:solidFill>
-                <a:latin typeface="Georgia"/>
-              </a:defRPr>
-            </a:pPr>
-            <a:r>
-              <a:t>SciPy-native architecture</a:t>
-            </a:r>
-          </a:p>
-        </p:txBody>
-      </p:sp>
-      <p:pic>
-        <p:nvPicPr>
-          <p:cNvPr id="60" name="Picture 59" descr="architecture_pipeline.png"/>
-          <p:cNvPicPr>
-            <a:picLocks noChangeAspect="1"/>
-          </p:cNvPicPr>
-          <p:nvPr/>
-        </p:nvPicPr>
-        <p:blipFill>
-          <a:blip r:embed="rId5"/>
-          <a:stretch>
-            <a:fillRect/>
-          </a:stretch>
-        </p:blipFill>
-        <p:spPr>
-          <a:xfrm>
-            <a:off x="15792527" y="15627096"/>
-            <a:ext cx="6060793" cy="2240280"/>
-          </a:xfrm>
-          <a:prstGeom prst="rect">
-            <a:avLst/>
-          </a:prstGeom>
-        </p:spPr>
-      </p:pic>
-      <p:pic>
-        <p:nvPicPr>
-          <p:cNvPr id="61" name="Picture 60" descr="roc_bridge.png"/>
-          <p:cNvPicPr>
-            <a:picLocks noChangeAspect="1"/>
-          </p:cNvPicPr>
-          <p:nvPr/>
-        </p:nvPicPr>
-        <p:blipFill>
-          <a:blip r:embed="rId6"/>
-          <a:stretch>
-            <a:fillRect/>
-          </a:stretch>
-        </p:blipFill>
-        <p:spPr>
-          <a:xfrm>
-            <a:off x="16990682" y="18041112"/>
-            <a:ext cx="3664483" cy="2834640"/>
-          </a:xfrm>
-          <a:prstGeom prst="rect">
-            <a:avLst/>
-          </a:prstGeom>
-        </p:spPr>
-      </p:pic>
-      <p:sp>
-        <p:nvSpPr>
-          <p:cNvPr id="62" name="Rectangle 61"/>
-          <p:cNvSpPr/>
-          <p:nvPr/>
-        </p:nvSpPr>
-        <p:spPr>
-          <a:xfrm>
-            <a:off x="777240" y="20985480"/>
-            <a:ext cx="11695176" cy="50292"/>
-          </a:xfrm>
-          <a:prstGeom prst="rect">
-            <a:avLst/>
-          </a:prstGeom>
-          <a:solidFill>
-            <a:srgbClr val="C7563F"/>
-          </a:solidFill>
-          <a:ln>
-            <a:noFill/>
-          </a:ln>
-        </p:spPr>
-        <p:style>
-          <a:lnRef idx="1">
-            <a:schemeClr val="accent1"/>
-          </a:lnRef>
-          <a:fillRef idx="3">
-            <a:schemeClr val="accent1"/>
-          </a:fillRef>
-          <a:effectRef idx="2">
-            <a:schemeClr val="accent1"/>
-          </a:effectRef>
-          <a:fontRef idx="minor">
-            <a:schemeClr val="lt1"/>
-          </a:fontRef>
-        </p:style>
-        <p:txBody>
-          <a:bodyPr rtlCol="0" anchor="ctr"/>
-          <a:lstStyle/>
-          <a:p>
-            <a:pPr algn="ctr"/>
-          </a:p>
-        </p:txBody>
-      </p:sp>
-      <p:sp>
-        <p:nvSpPr>
-          <p:cNvPr id="63" name="TextBox 62"/>
-          <p:cNvSpPr txBox="1"/>
-          <p:nvPr/>
-        </p:nvSpPr>
-        <p:spPr>
-          <a:xfrm>
-            <a:off x="777240" y="21095208"/>
-            <a:ext cx="11695176" cy="502920"/>
-          </a:xfrm>
-          <a:prstGeom prst="rect">
-            <a:avLst/>
-          </a:prstGeom>
-          <a:noFill/>
-        </p:spPr>
-        <p:txBody>
-          <a:bodyPr wrap="square" anchor="t" lIns="0" rIns="0" tIns="18288" bIns="18288">
-            <a:spAutoFit/>
-          </a:bodyPr>
-          <a:lstStyle/>
-          <a:p>
-            <a:pPr algn="ctr">
-              <a:spcAft>
-                <a:spcPts val="400"/>
-              </a:spcAft>
-              <a:defRPr sz="2900" b="0" i="0">
-                <a:solidFill>
-                  <a:srgbClr val="10231A"/>
-                </a:solidFill>
-                <a:latin typeface="Georgia"/>
-              </a:defRPr>
-            </a:pPr>
-            <a:r>
-              <a:t>Python ergonomics</a:t>
-            </a:r>
-          </a:p>
-        </p:txBody>
-      </p:sp>
-      <p:sp>
-        <p:nvSpPr>
-          <p:cNvPr id="64" name="Rounded Rectangle 63"/>
-          <p:cNvSpPr/>
-          <p:nvPr/>
-        </p:nvSpPr>
-        <p:spPr>
-          <a:xfrm>
-            <a:off x="960120" y="21744432"/>
-            <a:ext cx="11329415" cy="2926080"/>
+            <a:off x="20924520" y="20372832"/>
+            <a:ext cx="3700271" cy="2377440"/>
           </a:xfrm>
           <a:prstGeom prst="roundRect">
             <a:avLst/>
@@ -5566,14 +5436,14 @@
       </p:sp>
       <p:sp>
         <p:nvSpPr>
-          <p:cNvPr id="65" name="TextBox 64"/>
+          <p:cNvPr id="61" name="TextBox 60"/>
           <p:cNvSpPr txBox="1"/>
           <p:nvPr/>
         </p:nvSpPr>
         <p:spPr>
           <a:xfrm>
-            <a:off x="1280160" y="21954744"/>
-            <a:ext cx="10689336" cy="2468880"/>
+            <a:off x="20997671" y="20537424"/>
+            <a:ext cx="3553967" cy="713232"/>
           </a:xfrm>
           <a:prstGeom prst="rect">
             <a:avLst/>
@@ -5581,168 +5451,7 @@
           <a:noFill/>
         </p:spPr>
         <p:txBody>
-          <a:bodyPr wrap="square" anchor="t" lIns="45720" rIns="45720" tIns="18288" bIns="18288">
-            <a:spAutoFit/>
-          </a:bodyPr>
-          <a:lstStyle/>
-          <a:p>
-            <a:pPr algn="l">
-              <a:spcAft>
-                <a:spcPts val="400"/>
-              </a:spcAft>
-              <a:defRPr sz="1520" b="0" i="0">
-                <a:solidFill>
-                  <a:srgbClr val="17291F"/>
-                </a:solidFill>
-                <a:latin typeface="Courier New"/>
-              </a:defRPr>
-            </a:pPr>
-            <a:r>
-              <a:t>from senspy import discrim, dprime_power</a:t>
-            </a:r>
-          </a:p>
-          <a:p>
-            <a:pPr algn="l">
-              <a:spcAft>
-                <a:spcPts val="400"/>
-              </a:spcAft>
-              <a:defRPr sz="1520" b="0" i="0">
-                <a:solidFill>
-                  <a:srgbClr val="17291F"/>
-                </a:solidFill>
-                <a:latin typeface="Courier New"/>
-              </a:defRPr>
-            </a:pPr>
-          </a:p>
-          <a:p>
-            <a:pPr algn="l">
-              <a:spcAft>
-                <a:spcPts val="400"/>
-              </a:spcAft>
-              <a:defRPr sz="1520" b="0" i="0">
-                <a:solidFill>
-                  <a:srgbClr val="17291F"/>
-                </a:solidFill>
-                <a:latin typeface="Courier New"/>
-              </a:defRPr>
-            </a:pPr>
-            <a:r>
-              <a:t>result = discrim(correct=80, total=100,</a:t>
-            </a:r>
-          </a:p>
-          <a:p>
-            <a:pPr algn="l">
-              <a:spcAft>
-                <a:spcPts val="400"/>
-              </a:spcAft>
-              <a:defRPr sz="1520" b="0" i="0">
-                <a:solidFill>
-                  <a:srgbClr val="17291F"/>
-                </a:solidFill>
-                <a:latin typeface="Courier New"/>
-              </a:defRPr>
-            </a:pPr>
-            <a:r>
-              <a:t>                 method="triangle")</a:t>
-            </a:r>
-          </a:p>
-          <a:p>
-            <a:pPr algn="l">
-              <a:spcAft>
-                <a:spcPts val="400"/>
-              </a:spcAft>
-              <a:defRPr sz="1520" b="0" i="0">
-                <a:solidFill>
-                  <a:srgbClr val="17291F"/>
-                </a:solidFill>
-                <a:latin typeface="Courier New"/>
-              </a:defRPr>
-            </a:pPr>
-            <a:r>
-              <a:t>result.d_prime</a:t>
-            </a:r>
-          </a:p>
-          <a:p>
-            <a:pPr algn="l">
-              <a:spcAft>
-                <a:spcPts val="400"/>
-              </a:spcAft>
-              <a:defRPr sz="1520" b="0" i="0">
-                <a:solidFill>
-                  <a:srgbClr val="17291F"/>
-                </a:solidFill>
-                <a:latin typeface="Courier New"/>
-              </a:defRPr>
-            </a:pPr>
-            <a:r>
-              <a:t>result.confint()</a:t>
-            </a:r>
-          </a:p>
-          <a:p>
-            <a:pPr algn="l">
-              <a:spcAft>
-                <a:spcPts val="400"/>
-              </a:spcAft>
-              <a:defRPr sz="1520" b="0" i="0">
-                <a:solidFill>
-                  <a:srgbClr val="17291F"/>
-                </a:solidFill>
-                <a:latin typeface="Courier New"/>
-              </a:defRPr>
-            </a:pPr>
-          </a:p>
-          <a:p>
-            <a:pPr algn="l">
-              <a:spcAft>
-                <a:spcPts val="400"/>
-              </a:spcAft>
-              <a:defRPr sz="1520" b="0" i="0">
-                <a:solidFill>
-                  <a:srgbClr val="17291F"/>
-                </a:solidFill>
-                <a:latin typeface="Courier New"/>
-              </a:defRPr>
-            </a:pPr>
-            <a:r>
-              <a:t>dprime_power(1.5, 100,</a:t>
-            </a:r>
-          </a:p>
-          <a:p>
-            <a:pPr algn="l">
-              <a:spcAft>
-                <a:spcPts val="400"/>
-              </a:spcAft>
-              <a:defRPr sz="1520" b="0" i="0">
-                <a:solidFill>
-                  <a:srgbClr val="17291F"/>
-                </a:solidFill>
-                <a:latin typeface="Courier New"/>
-              </a:defRPr>
-            </a:pPr>
-            <a:r>
-              <a:t>             method="triangle")</a:t>
-            </a:r>
-          </a:p>
-        </p:txBody>
-      </p:sp>
-      <p:sp>
-        <p:nvSpPr>
-          <p:cNvPr id="66" name="TextBox 65"/>
-          <p:cNvSpPr txBox="1"/>
-          <p:nvPr/>
-        </p:nvSpPr>
-        <p:spPr>
-          <a:xfrm>
-            <a:off x="1097280" y="24825960"/>
-            <a:ext cx="11055096" cy="731520"/>
-          </a:xfrm>
-          <a:prstGeom prst="rect">
-            <a:avLst/>
-          </a:prstGeom>
-          <a:noFill/>
-        </p:spPr>
-        <p:txBody>
-          <a:bodyPr wrap="square" anchor="t" lIns="45720" rIns="45720" tIns="18288" bIns="18288">
+          <a:bodyPr wrap="square" anchor="t" lIns="0" rIns="0" tIns="18288" bIns="18288">
             <a:spAutoFit/>
           </a:bodyPr>
           <a:lstStyle/>
@@ -5751,72 +5460,29 @@
               <a:spcAft>
                 <a:spcPts val="400"/>
               </a:spcAft>
-              <a:defRPr sz="1800" b="1" i="0">
-                <a:solidFill>
-                  <a:srgbClr val="17291F"/>
+              <a:defRPr sz="5000" b="1" i="0">
+                <a:solidFill>
+                  <a:srgbClr val="4C8A61"/>
                 </a:solidFill>
                 <a:latin typeface="Arial"/>
               </a:defRPr>
             </a:pPr>
             <a:r>
-              <a:t>Typed results keep estimates, intervals, p-values, and summaries together.</a:t>
-            </a:r>
-          </a:p>
-        </p:txBody>
-      </p:sp>
-      <p:sp>
-        <p:nvSpPr>
-          <p:cNvPr id="67" name="Rectangle 66"/>
-          <p:cNvSpPr/>
-          <p:nvPr/>
-        </p:nvSpPr>
-        <p:spPr>
-          <a:xfrm>
-            <a:off x="12975336" y="20985480"/>
-            <a:ext cx="11695176" cy="50292"/>
-          </a:xfrm>
-          <a:prstGeom prst="rect">
-            <a:avLst/>
-          </a:prstGeom>
-          <a:solidFill>
-            <a:srgbClr val="C7563F"/>
-          </a:solidFill>
-          <a:ln>
-            <a:noFill/>
-          </a:ln>
-        </p:spPr>
-        <p:style>
-          <a:lnRef idx="1">
-            <a:schemeClr val="accent1"/>
-          </a:lnRef>
-          <a:fillRef idx="3">
-            <a:schemeClr val="accent1"/>
-          </a:fillRef>
-          <a:effectRef idx="2">
-            <a:schemeClr val="accent1"/>
-          </a:effectRef>
-          <a:fontRef idx="minor">
-            <a:schemeClr val="lt1"/>
-          </a:fontRef>
-        </p:style>
-        <p:txBody>
-          <a:bodyPr rtlCol="0" anchor="ctr"/>
-          <a:lstStyle/>
-          <a:p>
-            <a:pPr algn="ctr"/>
-          </a:p>
-        </p:txBody>
-      </p:sp>
-      <p:sp>
-        <p:nvSpPr>
-          <p:cNvPr id="68" name="TextBox 67"/>
+              <a:t>ROC</a:t>
+            </a:r>
+          </a:p>
+        </p:txBody>
+      </p:sp>
+      <p:sp>
+        <p:nvSpPr>
+          <p:cNvPr id="62" name="TextBox 61"/>
           <p:cNvSpPr txBox="1"/>
           <p:nvPr/>
         </p:nvSpPr>
         <p:spPr>
           <a:xfrm>
-            <a:off x="12975336" y="21095208"/>
-            <a:ext cx="11695176" cy="502920"/>
+            <a:off x="21034248" y="21360384"/>
+            <a:ext cx="3480815" cy="566928"/>
           </a:xfrm>
           <a:prstGeom prst="rect">
             <a:avLst/>
@@ -5833,29 +5499,68 @@
               <a:spcAft>
                 <a:spcPts val="400"/>
               </a:spcAft>
-              <a:defRPr sz="2900" b="0" i="0">
-                <a:solidFill>
-                  <a:srgbClr val="10231A"/>
-                </a:solidFill>
-                <a:latin typeface="Georgia"/>
+              <a:defRPr sz="2100" b="1" i="0">
+                <a:solidFill>
+                  <a:srgbClr val="17291F"/>
+                </a:solidFill>
+                <a:latin typeface="Arial"/>
               </a:defRPr>
             </a:pPr>
             <a:r>
-              <a:t>Advanced models</a:t>
-            </a:r>
-          </a:p>
-        </p:txBody>
-      </p:sp>
-      <p:sp>
-        <p:nvSpPr>
-          <p:cNvPr id="69" name="Rounded Rectangle 68"/>
+              <a:t>SDT analysis</a:t>
+            </a:r>
+          </a:p>
+        </p:txBody>
+      </p:sp>
+      <p:sp>
+        <p:nvSpPr>
+          <p:cNvPr id="63" name="TextBox 62"/>
+          <p:cNvSpPr txBox="1"/>
+          <p:nvPr/>
+        </p:nvSpPr>
+        <p:spPr>
+          <a:xfrm>
+            <a:off x="21052536" y="22000464"/>
+            <a:ext cx="3444239" cy="749808"/>
+          </a:xfrm>
+          <a:prstGeom prst="rect">
+            <a:avLst/>
+          </a:prstGeom>
+          <a:noFill/>
+        </p:spPr>
+        <p:txBody>
+          <a:bodyPr wrap="square" anchor="t" lIns="0" rIns="0" tIns="18288" bIns="18288">
+            <a:spAutoFit/>
+          </a:bodyPr>
+          <a:lstStyle/>
+          <a:p>
+            <a:pPr algn="ctr">
+              <a:spcAft>
+                <a:spcPts val="400"/>
+              </a:spcAft>
+              <a:defRPr sz="1700" b="0" i="0">
+                <a:solidFill>
+                  <a:srgbClr val="4D5A52"/>
+                </a:solidFill>
+                <a:latin typeface="Arial"/>
+              </a:defRPr>
+            </a:pPr>
+            <a:r>
+              <a:t>AUC + rating data</a:t>
+            </a:r>
+          </a:p>
+        </p:txBody>
+      </p:sp>
+      <p:sp>
+        <p:nvSpPr>
+          <p:cNvPr id="64" name="Rounded Rectangle 63"/>
           <p:cNvSpPr/>
           <p:nvPr/>
         </p:nvSpPr>
         <p:spPr>
           <a:xfrm>
-            <a:off x="13066776" y="21881592"/>
-            <a:ext cx="3669791" cy="1554480"/>
+            <a:off x="13021056" y="23143464"/>
+            <a:ext cx="11603736" cy="2395728"/>
           </a:xfrm>
           <a:prstGeom prst="roundRect">
             <a:avLst/>
@@ -5893,14 +5598,14 @@
       </p:sp>
       <p:sp>
         <p:nvSpPr>
-          <p:cNvPr id="70" name="TextBox 69"/>
+          <p:cNvPr id="65" name="TextBox 64"/>
           <p:cNvSpPr txBox="1"/>
           <p:nvPr/>
         </p:nvSpPr>
         <p:spPr>
           <a:xfrm>
-            <a:off x="13139928" y="22009608"/>
-            <a:ext cx="3523487" cy="502920"/>
+            <a:off x="13295376" y="23417784"/>
+            <a:ext cx="11055096" cy="530352"/>
           </a:xfrm>
           <a:prstGeom prst="rect">
             <a:avLst/>
@@ -5908,7 +5613,7 @@
           <a:noFill/>
         </p:spPr>
         <p:txBody>
-          <a:bodyPr wrap="square" anchor="t" lIns="0" rIns="0" tIns="18288" bIns="18288">
+          <a:bodyPr wrap="square" anchor="t" lIns="45720" rIns="45720" tIns="18288" bIns="18288">
             <a:spAutoFit/>
           </a:bodyPr>
           <a:lstStyle/>
@@ -5917,29 +5622,29 @@
               <a:spcAft>
                 <a:spcPts val="400"/>
               </a:spcAft>
-              <a:defRPr sz="3400" b="1" i="0">
-                <a:solidFill>
-                  <a:srgbClr val="4C8A61"/>
+              <a:defRPr sz="2500" b="1" i="0">
+                <a:solidFill>
+                  <a:srgbClr val="C7563F"/>
                 </a:solidFill>
                 <a:latin typeface="Arial"/>
               </a:defRPr>
             </a:pPr>
             <a:r>
-              <a:t>BB</a:t>
-            </a:r>
-          </a:p>
-        </p:txBody>
-      </p:sp>
-      <p:sp>
-        <p:nvSpPr>
-          <p:cNvPr id="71" name="TextBox 70"/>
+              <a:t>Validation is built into the architecture.</a:t>
+            </a:r>
+          </a:p>
+        </p:txBody>
+      </p:sp>
+      <p:sp>
+        <p:nvSpPr>
+          <p:cNvPr id="66" name="TextBox 65"/>
           <p:cNvSpPr txBox="1"/>
           <p:nvPr/>
         </p:nvSpPr>
         <p:spPr>
           <a:xfrm>
-            <a:off x="13176503" y="22640544"/>
-            <a:ext cx="3450335" cy="457200"/>
+            <a:off x="13341096" y="24213312"/>
+            <a:ext cx="10963655" cy="868680"/>
           </a:xfrm>
           <a:prstGeom prst="rect">
             <a:avLst/>
@@ -5947,7 +5652,7 @@
           <a:noFill/>
         </p:spPr>
         <p:txBody>
-          <a:bodyPr wrap="square" anchor="t" lIns="0" rIns="0" tIns="18288" bIns="18288">
+          <a:bodyPr wrap="square" anchor="t" lIns="45720" rIns="45720" tIns="18288" bIns="18288">
             <a:spAutoFit/>
           </a:bodyPr>
           <a:lstStyle/>
@@ -5956,7 +5661,7 @@
               <a:spcAft>
                 <a:spcPts val="400"/>
               </a:spcAft>
-              <a:defRPr sz="1600" b="1" i="0">
+              <a:defRPr sz="2400" b="1" i="0">
                 <a:solidFill>
                   <a:srgbClr val="17291F"/>
                 </a:solidFill>
@@ -5964,21 +5669,21 @@
               </a:defRPr>
             </a:pPr>
             <a:r>
-              <a:t>Beta-Binomial</a:t>
-            </a:r>
-          </a:p>
-        </p:txBody>
-      </p:sp>
-      <p:sp>
-        <p:nvSpPr>
-          <p:cNvPr id="72" name="TextBox 71"/>
+              <a:t>sensR fixtures -&gt; SciPy kernels -&gt; dataclass results -&gt; Plotly figures</a:t>
+            </a:r>
+          </a:p>
+        </p:txBody>
+      </p:sp>
+      <p:sp>
+        <p:nvSpPr>
+          <p:cNvPr id="67" name="TextBox 66"/>
           <p:cNvSpPr txBox="1"/>
           <p:nvPr/>
         </p:nvSpPr>
         <p:spPr>
           <a:xfrm>
-            <a:off x="13194792" y="23052024"/>
-            <a:ext cx="3413759" cy="438912"/>
+            <a:off x="13203936" y="25831800"/>
+            <a:ext cx="11237976" cy="685800"/>
           </a:xfrm>
           <a:prstGeom prst="rect">
             <a:avLst/>
@@ -5986,7 +5691,7 @@
           <a:noFill/>
         </p:spPr>
         <p:txBody>
-          <a:bodyPr wrap="square" anchor="t" lIns="0" rIns="0" tIns="18288" bIns="18288">
+          <a:bodyPr wrap="square" anchor="t" lIns="45720" rIns="45720" tIns="18288" bIns="18288">
             <a:spAutoFit/>
           </a:bodyPr>
           <a:lstStyle/>
@@ -5995,29 +5700,189 @@
               <a:spcAft>
                 <a:spcPts val="400"/>
               </a:spcAft>
-              <a:defRPr sz="1350" b="0" i="0">
-                <a:solidFill>
-                  <a:srgbClr val="4D5A52"/>
+              <a:defRPr sz="2200" b="1" i="0">
+                <a:solidFill>
+                  <a:srgbClr val="17291F"/>
                 </a:solidFill>
                 <a:latin typeface="Arial"/>
               </a:defRPr>
             </a:pPr>
             <a:r>
-              <a:t>overdispersed panel data</a:t>
-            </a:r>
-          </a:p>
-        </p:txBody>
-      </p:sp>
-      <p:sp>
-        <p:nvSpPr>
-          <p:cNvPr id="73" name="Rounded Rectangle 72"/>
+              <a:t>Also included: 2-AC, DOD, A-not-A, d-prime tests, posthoc, simulation, power, and sample-size planning.</a:t>
+            </a:r>
+          </a:p>
+        </p:txBody>
+      </p:sp>
+      <p:sp>
+        <p:nvSpPr>
+          <p:cNvPr id="68" name="Rectangle 67"/>
           <p:cNvSpPr/>
           <p:nvPr/>
         </p:nvSpPr>
         <p:spPr>
           <a:xfrm>
-            <a:off x="16965167" y="21881592"/>
-            <a:ext cx="3669791" cy="1554480"/>
+            <a:off x="777240" y="27569160"/>
+            <a:ext cx="23893272" cy="64008"/>
+          </a:xfrm>
+          <a:prstGeom prst="rect">
+            <a:avLst/>
+          </a:prstGeom>
+          <a:solidFill>
+            <a:srgbClr val="C7563F"/>
+          </a:solidFill>
+          <a:ln>
+            <a:noFill/>
+          </a:ln>
+        </p:spPr>
+        <p:style>
+          <a:lnRef idx="1">
+            <a:schemeClr val="accent1"/>
+          </a:lnRef>
+          <a:fillRef idx="3">
+            <a:schemeClr val="accent1"/>
+          </a:fillRef>
+          <a:effectRef idx="2">
+            <a:schemeClr val="accent1"/>
+          </a:effectRef>
+          <a:fontRef idx="minor">
+            <a:schemeClr val="lt1"/>
+          </a:fontRef>
+        </p:style>
+        <p:txBody>
+          <a:bodyPr rtlCol="0" anchor="ctr"/>
+          <a:lstStyle/>
+          <a:p>
+            <a:pPr algn="ctr"/>
+          </a:p>
+        </p:txBody>
+      </p:sp>
+      <p:sp>
+        <p:nvSpPr>
+          <p:cNvPr id="69" name="TextBox 68"/>
+          <p:cNvSpPr txBox="1"/>
+          <p:nvPr/>
+        </p:nvSpPr>
+        <p:spPr>
+          <a:xfrm>
+            <a:off x="777240" y="27715464"/>
+            <a:ext cx="23893272" cy="694944"/>
+          </a:xfrm>
+          <a:prstGeom prst="rect">
+            <a:avLst/>
+          </a:prstGeom>
+          <a:noFill/>
+        </p:spPr>
+        <p:txBody>
+          <a:bodyPr wrap="square" anchor="t" lIns="0" rIns="0" tIns="18288" bIns="18288">
+            <a:spAutoFit/>
+          </a:bodyPr>
+          <a:lstStyle/>
+          <a:p>
+            <a:pPr algn="ctr">
+              <a:spcAft>
+                <a:spcPts val="400"/>
+              </a:spcAft>
+              <a:defRPr sz="3800" b="0" i="0">
+                <a:solidFill>
+                  <a:srgbClr val="10231A"/>
+                </a:solidFill>
+                <a:latin typeface="Georgia"/>
+              </a:defRPr>
+            </a:pPr>
+            <a:r>
+              <a:t>Conclusion</a:t>
+            </a:r>
+          </a:p>
+        </p:txBody>
+      </p:sp>
+      <p:sp>
+        <p:nvSpPr>
+          <p:cNvPr id="70" name="TextBox 69"/>
+          <p:cNvSpPr txBox="1"/>
+          <p:nvPr/>
+        </p:nvSpPr>
+        <p:spPr>
+          <a:xfrm>
+            <a:off x="1783080" y="28355544"/>
+            <a:ext cx="21881592" cy="1371600"/>
+          </a:xfrm>
+          <a:prstGeom prst="rect">
+            <a:avLst/>
+          </a:prstGeom>
+          <a:noFill/>
+        </p:spPr>
+        <p:txBody>
+          <a:bodyPr wrap="square" anchor="t" lIns="45720" rIns="45720" tIns="18288" bIns="18288">
+            <a:spAutoFit/>
+          </a:bodyPr>
+          <a:lstStyle/>
+          <a:p>
+            <a:pPr algn="ctr">
+              <a:spcAft>
+                <a:spcPts val="400"/>
+              </a:spcAft>
+              <a:defRPr sz="3100" b="1" i="0">
+                <a:solidFill>
+                  <a:srgbClr val="17291F"/>
+                </a:solidFill>
+                <a:latin typeface="Arial"/>
+              </a:defRPr>
+            </a:pPr>
+            <a:r>
+              <a:t>sensPy brings the sensR contract into Python: validated sensory discrimination, typed results, and interactive figures in one workflow.</a:t>
+            </a:r>
+          </a:p>
+        </p:txBody>
+      </p:sp>
+      <p:sp>
+        <p:nvSpPr>
+          <p:cNvPr id="71" name="TextBox 70"/>
+          <p:cNvSpPr txBox="1"/>
+          <p:nvPr/>
+        </p:nvSpPr>
+        <p:spPr>
+          <a:xfrm>
+            <a:off x="777240" y="29900879"/>
+            <a:ext cx="23893272" cy="502920"/>
+          </a:xfrm>
+          <a:prstGeom prst="rect">
+            <a:avLst/>
+          </a:prstGeom>
+          <a:noFill/>
+        </p:spPr>
+        <p:txBody>
+          <a:bodyPr wrap="square" anchor="t" lIns="0" rIns="0" tIns="18288" bIns="18288">
+            <a:spAutoFit/>
+          </a:bodyPr>
+          <a:lstStyle/>
+          <a:p>
+            <a:pPr algn="ctr">
+              <a:spcAft>
+                <a:spcPts val="400"/>
+              </a:spcAft>
+              <a:defRPr sz="3000" b="0" i="0">
+                <a:solidFill>
+                  <a:srgbClr val="10231A"/>
+                </a:solidFill>
+                <a:latin typeface="Georgia"/>
+              </a:defRPr>
+            </a:pPr>
+            <a:r>
+              <a:t>What changes for sensometricians</a:t>
+            </a:r>
+          </a:p>
+        </p:txBody>
+      </p:sp>
+      <p:sp>
+        <p:nvSpPr>
+          <p:cNvPr id="72" name="Rounded Rectangle 71"/>
+          <p:cNvSpPr/>
+          <p:nvPr/>
+        </p:nvSpPr>
+        <p:spPr>
+          <a:xfrm>
+            <a:off x="777240" y="30540960"/>
+            <a:ext cx="7720584" cy="2971800"/>
           </a:xfrm>
           <a:prstGeom prst="roundRect">
             <a:avLst/>
@@ -6055,14 +5920,14 @@
       </p:sp>
       <p:sp>
         <p:nvSpPr>
-          <p:cNvPr id="74" name="TextBox 73"/>
+          <p:cNvPr id="73" name="TextBox 72"/>
           <p:cNvSpPr txBox="1"/>
           <p:nvPr/>
         </p:nvSpPr>
         <p:spPr>
           <a:xfrm>
-            <a:off x="17038319" y="22009608"/>
-            <a:ext cx="3523487" cy="502920"/>
+            <a:off x="1033271" y="30796992"/>
+            <a:ext cx="7208520" cy="530352"/>
           </a:xfrm>
           <a:prstGeom prst="rect">
             <a:avLst/>
@@ -6079,29 +5944,29 @@
               <a:spcAft>
                 <a:spcPts val="400"/>
               </a:spcAft>
-              <a:defRPr sz="3400" b="1" i="0">
-                <a:solidFill>
-                  <a:srgbClr val="C7563F"/>
+              <a:defRPr sz="2500" b="1" i="0">
+                <a:solidFill>
+                  <a:srgbClr val="4C8A61"/>
                 </a:solidFill>
                 <a:latin typeface="Arial"/>
               </a:defRPr>
             </a:pPr>
             <a:r>
-              <a:t>SD</a:t>
-            </a:r>
-          </a:p>
-        </p:txBody>
-      </p:sp>
-      <p:sp>
-        <p:nvSpPr>
-          <p:cNvPr id="75" name="TextBox 74"/>
+              <a:t>Validated migration</a:t>
+            </a:r>
+          </a:p>
+        </p:txBody>
+      </p:sp>
+      <p:sp>
+        <p:nvSpPr>
+          <p:cNvPr id="74" name="TextBox 73"/>
           <p:cNvSpPr txBox="1"/>
           <p:nvPr/>
         </p:nvSpPr>
         <p:spPr>
           <a:xfrm>
-            <a:off x="17074896" y="22640544"/>
-            <a:ext cx="3450335" cy="457200"/>
+            <a:off x="1161288" y="31528511"/>
+            <a:ext cx="6952488" cy="1837943"/>
           </a:xfrm>
           <a:prstGeom prst="rect">
             <a:avLst/>
@@ -6118,7 +5983,7 @@
               <a:spcAft>
                 <a:spcPts val="400"/>
               </a:spcAft>
-              <a:defRPr sz="1600" b="1" i="0">
+              <a:defRPr sz="2200" b="0" i="0">
                 <a:solidFill>
                   <a:srgbClr val="17291F"/>
                 </a:solidFill>
@@ -6126,60 +5991,21 @@
               </a:defRPr>
             </a:pPr>
             <a:r>
-              <a:t>Same-Different</a:t>
-            </a:r>
-          </a:p>
-        </p:txBody>
-      </p:sp>
-      <p:sp>
-        <p:nvSpPr>
-          <p:cNvPr id="76" name="TextBox 75"/>
-          <p:cNvSpPr txBox="1"/>
-          <p:nvPr/>
-        </p:nvSpPr>
-        <p:spPr>
-          <a:xfrm>
-            <a:off x="17093184" y="23052024"/>
-            <a:ext cx="3413759" cy="438912"/>
-          </a:xfrm>
-          <a:prstGeom prst="rect">
-            <a:avLst/>
-          </a:prstGeom>
-          <a:noFill/>
-        </p:spPr>
-        <p:txBody>
-          <a:bodyPr wrap="square" anchor="t" lIns="0" rIns="0" tIns="18288" bIns="18288">
-            <a:spAutoFit/>
-          </a:bodyPr>
-          <a:lstStyle/>
-          <a:p>
-            <a:pPr algn="ctr">
-              <a:spcAft>
-                <a:spcPts val="400"/>
-              </a:spcAft>
-              <a:defRPr sz="1350" b="0" i="0">
-                <a:solidFill>
-                  <a:srgbClr val="4D5A52"/>
-                </a:solidFill>
-                <a:latin typeface="Arial"/>
-              </a:defRPr>
-            </a:pPr>
-            <a:r>
-              <a:t>Thurstonian criterion model</a:t>
-            </a:r>
-          </a:p>
-        </p:txBody>
-      </p:sp>
-      <p:sp>
-        <p:nvSpPr>
-          <p:cNvPr id="77" name="Rounded Rectangle 76"/>
+              <a:t>Keep sensR-backed decisions in Python notebooks and pipelines.</a:t>
+            </a:r>
+          </a:p>
+        </p:txBody>
+      </p:sp>
+      <p:sp>
+        <p:nvSpPr>
+          <p:cNvPr id="75" name="Rounded Rectangle 74"/>
           <p:cNvSpPr/>
           <p:nvPr/>
         </p:nvSpPr>
         <p:spPr>
           <a:xfrm>
-            <a:off x="20863559" y="21881592"/>
-            <a:ext cx="3669791" cy="1554480"/>
+            <a:off x="8863584" y="30540960"/>
+            <a:ext cx="7720584" cy="2971800"/>
           </a:xfrm>
           <a:prstGeom prst="roundRect">
             <a:avLst/>
@@ -6217,14 +6043,14 @@
       </p:sp>
       <p:sp>
         <p:nvSpPr>
-          <p:cNvPr id="78" name="TextBox 77"/>
+          <p:cNvPr id="76" name="TextBox 75"/>
           <p:cNvSpPr txBox="1"/>
           <p:nvPr/>
         </p:nvSpPr>
         <p:spPr>
           <a:xfrm>
-            <a:off x="20936711" y="22009608"/>
-            <a:ext cx="3523487" cy="502920"/>
+            <a:off x="9119616" y="30796992"/>
+            <a:ext cx="7208520" cy="530352"/>
           </a:xfrm>
           <a:prstGeom prst="rect">
             <a:avLst/>
@@ -6241,29 +6067,29 @@
               <a:spcAft>
                 <a:spcPts val="400"/>
               </a:spcAft>
-              <a:defRPr sz="3400" b="1" i="0">
-                <a:solidFill>
-                  <a:srgbClr val="4C8A61"/>
+              <a:defRPr sz="2500" b="1" i="0">
+                <a:solidFill>
+                  <a:srgbClr val="C7563F"/>
                 </a:solidFill>
                 <a:latin typeface="Arial"/>
               </a:defRPr>
             </a:pPr>
             <a:r>
-              <a:t>ROC</a:t>
-            </a:r>
-          </a:p>
-        </p:txBody>
-      </p:sp>
-      <p:sp>
-        <p:nvSpPr>
-          <p:cNvPr id="79" name="TextBox 78"/>
+              <a:t>One reporting scale</a:t>
+            </a:r>
+          </a:p>
+        </p:txBody>
+      </p:sp>
+      <p:sp>
+        <p:nvSpPr>
+          <p:cNvPr id="77" name="TextBox 76"/>
           <p:cNvSpPr txBox="1"/>
           <p:nvPr/>
         </p:nvSpPr>
         <p:spPr>
           <a:xfrm>
-            <a:off x="20973287" y="22640544"/>
-            <a:ext cx="3450335" cy="457200"/>
+            <a:off x="9247632" y="31528511"/>
+            <a:ext cx="6952488" cy="1837943"/>
           </a:xfrm>
           <a:prstGeom prst="rect">
             <a:avLst/>
@@ -6280,7 +6106,7 @@
               <a:spcAft>
                 <a:spcPts val="400"/>
               </a:spcAft>
-              <a:defRPr sz="1600" b="1" i="0">
+              <a:defRPr sz="2200" b="0" i="0">
                 <a:solidFill>
                   <a:srgbClr val="17291F"/>
                 </a:solidFill>
@@ -6288,298 +6114,21 @@
               </a:defRPr>
             </a:pPr>
             <a:r>
-              <a:t>SDT analysis</a:t>
-            </a:r>
-          </a:p>
-        </p:txBody>
-      </p:sp>
-      <p:sp>
-        <p:nvSpPr>
-          <p:cNvPr id="80" name="TextBox 79"/>
-          <p:cNvSpPr txBox="1"/>
-          <p:nvPr/>
-        </p:nvSpPr>
-        <p:spPr>
-          <a:xfrm>
-            <a:off x="20991575" y="23052024"/>
-            <a:ext cx="3413759" cy="438912"/>
-          </a:xfrm>
-          <a:prstGeom prst="rect">
-            <a:avLst/>
-          </a:prstGeom>
-          <a:noFill/>
-        </p:spPr>
-        <p:txBody>
-          <a:bodyPr wrap="square" anchor="t" lIns="0" rIns="0" tIns="18288" bIns="18288">
-            <a:spAutoFit/>
-          </a:bodyPr>
-          <a:lstStyle/>
-          <a:p>
-            <a:pPr algn="ctr">
-              <a:spcAft>
-                <a:spcPts val="400"/>
-              </a:spcAft>
-              <a:defRPr sz="1350" b="0" i="0">
-                <a:solidFill>
-                  <a:srgbClr val="4D5A52"/>
-                </a:solidFill>
-                <a:latin typeface="Arial"/>
-              </a:defRPr>
-            </a:pPr>
-            <a:r>
-              <a:t>AUC + rating data</a:t>
-            </a:r>
-          </a:p>
-        </p:txBody>
-      </p:sp>
-      <p:sp>
-        <p:nvSpPr>
-          <p:cNvPr id="81" name="TextBox 80"/>
-          <p:cNvSpPr txBox="1"/>
-          <p:nvPr/>
-        </p:nvSpPr>
-        <p:spPr>
-          <a:xfrm>
-            <a:off x="13203936" y="23756112"/>
-            <a:ext cx="11237976" cy="731520"/>
-          </a:xfrm>
-          <a:prstGeom prst="rect">
-            <a:avLst/>
-          </a:prstGeom>
-          <a:noFill/>
-        </p:spPr>
-        <p:txBody>
-          <a:bodyPr wrap="square" anchor="t" lIns="45720" rIns="45720" tIns="18288" bIns="18288">
-            <a:spAutoFit/>
-          </a:bodyPr>
-          <a:lstStyle/>
-          <a:p>
-            <a:pPr algn="ctr">
-              <a:spcAft>
-                <a:spcPts val="400"/>
-              </a:spcAft>
-              <a:defRPr sz="1750" b="1" i="0">
-                <a:solidFill>
-                  <a:srgbClr val="17291F"/>
-                </a:solidFill>
-                <a:latin typeface="Arial"/>
-              </a:defRPr>
-            </a:pPr>
-            <a:r>
-              <a:t>Also included: 2-AC, DOD, A-not-A, d-prime tests, posthoc, simulation, power, and sample-size planning.</a:t>
-            </a:r>
-          </a:p>
-        </p:txBody>
-      </p:sp>
-      <p:sp>
-        <p:nvSpPr>
-          <p:cNvPr id="82" name="Rectangle 81"/>
+              <a:t>Pc, Pd, d-prime, intervals, and power share one API.</a:t>
+            </a:r>
+          </a:p>
+        </p:txBody>
+      </p:sp>
+      <p:sp>
+        <p:nvSpPr>
+          <p:cNvPr id="78" name="Rounded Rectangle 77"/>
           <p:cNvSpPr/>
           <p:nvPr/>
         </p:nvSpPr>
         <p:spPr>
           <a:xfrm>
-            <a:off x="777240" y="25831800"/>
-            <a:ext cx="23893272" cy="50292"/>
-          </a:xfrm>
-          <a:prstGeom prst="rect">
-            <a:avLst/>
-          </a:prstGeom>
-          <a:solidFill>
-            <a:srgbClr val="C7563F"/>
-          </a:solidFill>
-          <a:ln>
-            <a:noFill/>
-          </a:ln>
-        </p:spPr>
-        <p:style>
-          <a:lnRef idx="1">
-            <a:schemeClr val="accent1"/>
-          </a:lnRef>
-          <a:fillRef idx="3">
-            <a:schemeClr val="accent1"/>
-          </a:fillRef>
-          <a:effectRef idx="2">
-            <a:schemeClr val="accent1"/>
-          </a:effectRef>
-          <a:fontRef idx="minor">
-            <a:schemeClr val="lt1"/>
-          </a:fontRef>
-        </p:style>
-        <p:txBody>
-          <a:bodyPr rtlCol="0" anchor="ctr"/>
-          <a:lstStyle/>
-          <a:p>
-            <a:pPr algn="ctr"/>
-          </a:p>
-        </p:txBody>
-      </p:sp>
-      <p:sp>
-        <p:nvSpPr>
-          <p:cNvPr id="83" name="TextBox 82"/>
-          <p:cNvSpPr txBox="1"/>
-          <p:nvPr/>
-        </p:nvSpPr>
-        <p:spPr>
-          <a:xfrm>
-            <a:off x="777240" y="25941528"/>
-            <a:ext cx="23893272" cy="502920"/>
-          </a:xfrm>
-          <a:prstGeom prst="rect">
-            <a:avLst/>
-          </a:prstGeom>
-          <a:noFill/>
-        </p:spPr>
-        <p:txBody>
-          <a:bodyPr wrap="square" anchor="t" lIns="0" rIns="0" tIns="18288" bIns="18288">
-            <a:spAutoFit/>
-          </a:bodyPr>
-          <a:lstStyle/>
-          <a:p>
-            <a:pPr algn="ctr">
-              <a:spcAft>
-                <a:spcPts val="400"/>
-              </a:spcAft>
-              <a:defRPr sz="2900" b="0" i="0">
-                <a:solidFill>
-                  <a:srgbClr val="10231A"/>
-                </a:solidFill>
-                <a:latin typeface="Georgia"/>
-              </a:defRPr>
-            </a:pPr>
-            <a:r>
-              <a:t>Conclusion</a:t>
-            </a:r>
-          </a:p>
-        </p:txBody>
-      </p:sp>
-      <p:sp>
-        <p:nvSpPr>
-          <p:cNvPr id="84" name="TextBox 83"/>
-          <p:cNvSpPr txBox="1"/>
-          <p:nvPr/>
-        </p:nvSpPr>
-        <p:spPr>
-          <a:xfrm>
-            <a:off x="1783080" y="26618184"/>
-            <a:ext cx="21881592" cy="1051560"/>
-          </a:xfrm>
-          <a:prstGeom prst="rect">
-            <a:avLst/>
-          </a:prstGeom>
-          <a:noFill/>
-        </p:spPr>
-        <p:txBody>
-          <a:bodyPr wrap="square" anchor="t" lIns="45720" rIns="45720" tIns="18288" bIns="18288">
-            <a:spAutoFit/>
-          </a:bodyPr>
-          <a:lstStyle/>
-          <a:p>
-            <a:pPr algn="ctr">
-              <a:spcAft>
-                <a:spcPts val="400"/>
-              </a:spcAft>
-              <a:defRPr sz="2400" b="1" i="0">
-                <a:solidFill>
-                  <a:srgbClr val="17291F"/>
-                </a:solidFill>
-                <a:latin typeface="Arial"/>
-              </a:defRPr>
-            </a:pPr>
-            <a:r>
-              <a:t>sensPy brings the sensR contract into Python: the same sensory discrimination ideas, validated against the R reference, expressed as SciPy-native functions, typed dataclasses, and interactive Plotly figures.</a:t>
-            </a:r>
-          </a:p>
-        </p:txBody>
-      </p:sp>
-      <p:sp>
-        <p:nvSpPr>
-          <p:cNvPr id="85" name="TextBox 84"/>
-          <p:cNvSpPr txBox="1"/>
-          <p:nvPr/>
-        </p:nvSpPr>
-        <p:spPr>
-          <a:xfrm>
-            <a:off x="2240280" y="27770328"/>
-            <a:ext cx="20967192" cy="640080"/>
-          </a:xfrm>
-          <a:prstGeom prst="rect">
-            <a:avLst/>
-          </a:prstGeom>
-          <a:noFill/>
-        </p:spPr>
-        <p:txBody>
-          <a:bodyPr wrap="square" anchor="t" lIns="45720" rIns="45720" tIns="18288" bIns="18288">
-            <a:spAutoFit/>
-          </a:bodyPr>
-          <a:lstStyle/>
-          <a:p>
-            <a:pPr algn="ctr">
-              <a:spcAft>
-                <a:spcPts val="400"/>
-              </a:spcAft>
-              <a:defRPr sz="1550" b="0" i="0">
-                <a:solidFill>
-                  <a:srgbClr val="4D5A52"/>
-                </a:solidFill>
-                <a:latin typeface="Arial"/>
-              </a:defRPr>
-            </a:pPr>
-            <a:r>
-              <a:t>Selected references: Brockhoff &amp; Christensen, sensR package; Macmillan &amp; Creelman, Detection Theory; SciPy; Plotly. Repository includes golden sensR v1.5.3 fixtures.</a:t>
-            </a:r>
-          </a:p>
-        </p:txBody>
-      </p:sp>
-      <p:sp>
-        <p:nvSpPr>
-          <p:cNvPr id="86" name="TextBox 85"/>
-          <p:cNvSpPr txBox="1"/>
-          <p:nvPr/>
-        </p:nvSpPr>
-        <p:spPr>
-          <a:xfrm>
-            <a:off x="777240" y="28529280"/>
-            <a:ext cx="23893272" cy="384048"/>
-          </a:xfrm>
-          <a:prstGeom prst="rect">
-            <a:avLst/>
-          </a:prstGeom>
-          <a:noFill/>
-        </p:spPr>
-        <p:txBody>
-          <a:bodyPr wrap="square" anchor="t" lIns="0" rIns="0" tIns="18288" bIns="18288">
-            <a:spAutoFit/>
-          </a:bodyPr>
-          <a:lstStyle/>
-          <a:p>
-            <a:pPr algn="ctr">
-              <a:spcAft>
-                <a:spcPts val="400"/>
-              </a:spcAft>
-              <a:defRPr sz="2100" b="0" i="0">
-                <a:solidFill>
-                  <a:srgbClr val="10231A"/>
-                </a:solidFill>
-                <a:latin typeface="Georgia"/>
-              </a:defRPr>
-            </a:pPr>
-            <a:r>
-              <a:t>What changes for sensometricians</a:t>
-            </a:r>
-          </a:p>
-        </p:txBody>
-      </p:sp>
-      <p:sp>
-        <p:nvSpPr>
-          <p:cNvPr id="87" name="Rounded Rectangle 86"/>
-          <p:cNvSpPr/>
-          <p:nvPr/>
-        </p:nvSpPr>
-        <p:spPr>
-          <a:xfrm>
-            <a:off x="777240" y="28959048"/>
-            <a:ext cx="7720584" cy="1874519"/>
+            <a:off x="16949928" y="30540960"/>
+            <a:ext cx="7720584" cy="2971800"/>
           </a:xfrm>
           <a:prstGeom prst="roundRect">
             <a:avLst/>
@@ -6617,14 +6166,14 @@
       </p:sp>
       <p:sp>
         <p:nvSpPr>
-          <p:cNvPr id="88" name="TextBox 87"/>
+          <p:cNvPr id="79" name="TextBox 78"/>
           <p:cNvSpPr txBox="1"/>
           <p:nvPr/>
         </p:nvSpPr>
         <p:spPr>
           <a:xfrm>
-            <a:off x="978408" y="29123640"/>
-            <a:ext cx="7318248" cy="365760"/>
+            <a:off x="17205960" y="30796992"/>
+            <a:ext cx="7208520" cy="530352"/>
           </a:xfrm>
           <a:prstGeom prst="rect">
             <a:avLst/>
@@ -6641,7 +6190,7 @@
               <a:spcAft>
                 <a:spcPts val="400"/>
               </a:spcAft>
-              <a:defRPr sz="1800" b="1" i="0">
+              <a:defRPr sz="2500" b="1" i="0">
                 <a:solidFill>
                   <a:srgbClr val="4C8A61"/>
                 </a:solidFill>
@@ -6649,21 +6198,21 @@
               </a:defRPr>
             </a:pPr>
             <a:r>
-              <a:t>Validated migration</a:t>
-            </a:r>
-          </a:p>
-        </p:txBody>
-      </p:sp>
-      <p:sp>
-        <p:nvSpPr>
-          <p:cNvPr id="89" name="TextBox 88"/>
+              <a:t>Modern outputs</a:t>
+            </a:r>
+          </a:p>
+        </p:txBody>
+      </p:sp>
+      <p:sp>
+        <p:nvSpPr>
+          <p:cNvPr id="80" name="TextBox 79"/>
           <p:cNvSpPr txBox="1"/>
           <p:nvPr/>
         </p:nvSpPr>
         <p:spPr>
           <a:xfrm>
-            <a:off x="1088136" y="29653992"/>
-            <a:ext cx="7098792" cy="1051560"/>
+            <a:off x="17333976" y="31528511"/>
+            <a:ext cx="6952488" cy="1837943"/>
           </a:xfrm>
           <a:prstGeom prst="rect">
             <a:avLst/>
@@ -6680,7 +6229,7 @@
               <a:spcAft>
                 <a:spcPts val="400"/>
               </a:spcAft>
-              <a:defRPr sz="1530" b="0" i="0">
+              <a:defRPr sz="2200" b="0" i="0">
                 <a:solidFill>
                   <a:srgbClr val="17291F"/>
                 </a:solidFill>
@@ -6688,66 +6237,21 @@
               </a:defRPr>
             </a:pPr>
             <a:r>
-              <a:t>Keep sensR-backed decisions in Python notebooks and pipelines.</a:t>
-            </a:r>
-          </a:p>
-        </p:txBody>
-      </p:sp>
-      <p:sp>
-        <p:nvSpPr>
-          <p:cNvPr id="90" name="Rounded Rectangle 89"/>
-          <p:cNvSpPr/>
-          <p:nvPr/>
-        </p:nvSpPr>
-        <p:spPr>
-          <a:xfrm>
-            <a:off x="8863584" y="28959048"/>
-            <a:ext cx="7720584" cy="1874519"/>
-          </a:xfrm>
-          <a:prstGeom prst="roundRect">
-            <a:avLst/>
-          </a:prstGeom>
-          <a:solidFill>
-            <a:srgbClr val="E8E3D8"/>
-          </a:solidFill>
-          <a:ln w="12700">
-            <a:solidFill>
-              <a:srgbClr val="D2C9BB"/>
-            </a:solidFill>
-          </a:ln>
-        </p:spPr>
-        <p:style>
-          <a:lnRef idx="1">
-            <a:schemeClr val="accent1"/>
-          </a:lnRef>
-          <a:fillRef idx="3">
-            <a:schemeClr val="accent1"/>
-          </a:fillRef>
-          <a:effectRef idx="2">
-            <a:schemeClr val="accent1"/>
-          </a:effectRef>
-          <a:fontRef idx="minor">
-            <a:schemeClr val="lt1"/>
-          </a:fontRef>
-        </p:style>
-        <p:txBody>
-          <a:bodyPr rtlCol="0" anchor="ctr"/>
-          <a:lstStyle/>
-          <a:p>
-            <a:pPr algn="ctr"/>
-          </a:p>
-        </p:txBody>
-      </p:sp>
-      <p:sp>
-        <p:nvSpPr>
-          <p:cNvPr id="91" name="TextBox 90"/>
+              <a:t>Typed results and Plotly figures are easier to audit and reuse.</a:t>
+            </a:r>
+          </a:p>
+        </p:txBody>
+      </p:sp>
+      <p:sp>
+        <p:nvSpPr>
+          <p:cNvPr id="81" name="TextBox 80"/>
           <p:cNvSpPr txBox="1"/>
           <p:nvPr/>
         </p:nvSpPr>
         <p:spPr>
           <a:xfrm>
-            <a:off x="9064752" y="29123640"/>
-            <a:ext cx="7318248" cy="365760"/>
+            <a:off x="2240280" y="33878520"/>
+            <a:ext cx="20967192" cy="548640"/>
           </a:xfrm>
           <a:prstGeom prst="rect">
             <a:avLst/>
@@ -6755,7 +6259,7 @@
           <a:noFill/>
         </p:spPr>
         <p:txBody>
-          <a:bodyPr wrap="square" anchor="t" lIns="0" rIns="0" tIns="18288" bIns="18288">
+          <a:bodyPr wrap="square" anchor="t" lIns="45720" rIns="45720" tIns="18288" bIns="18288">
             <a:spAutoFit/>
           </a:bodyPr>
           <a:lstStyle/>
@@ -6764,1027 +6268,22 @@
               <a:spcAft>
                 <a:spcPts val="400"/>
               </a:spcAft>
-              <a:defRPr sz="1800" b="1" i="0">
-                <a:solidFill>
-                  <a:srgbClr val="C7563F"/>
+              <a:defRPr sz="1800" b="0" i="0">
+                <a:solidFill>
+                  <a:srgbClr val="4D5A52"/>
                 </a:solidFill>
                 <a:latin typeface="Arial"/>
               </a:defRPr>
             </a:pPr>
             <a:r>
-              <a:t>One reporting scale</a:t>
-            </a:r>
-          </a:p>
-        </p:txBody>
-      </p:sp>
-      <p:sp>
-        <p:nvSpPr>
-          <p:cNvPr id="92" name="TextBox 91"/>
-          <p:cNvSpPr txBox="1"/>
-          <p:nvPr/>
-        </p:nvSpPr>
-        <p:spPr>
-          <a:xfrm>
-            <a:off x="9174480" y="29653992"/>
-            <a:ext cx="7098792" cy="1051560"/>
-          </a:xfrm>
-          <a:prstGeom prst="rect">
-            <a:avLst/>
-          </a:prstGeom>
-          <a:noFill/>
-        </p:spPr>
-        <p:txBody>
-          <a:bodyPr wrap="square" anchor="t" lIns="0" rIns="0" tIns="18288" bIns="18288">
-            <a:spAutoFit/>
-          </a:bodyPr>
-          <a:lstStyle/>
-          <a:p>
-            <a:pPr algn="ctr">
-              <a:spcAft>
-                <a:spcPts val="400"/>
-              </a:spcAft>
-              <a:defRPr sz="1530" b="0" i="0">
-                <a:solidFill>
-                  <a:srgbClr val="17291F"/>
-                </a:solidFill>
-                <a:latin typeface="Arial"/>
-              </a:defRPr>
-            </a:pPr>
-            <a:r>
-              <a:t>Pc, Pd, d-prime, intervals, and power share one API.</a:t>
-            </a:r>
-          </a:p>
-        </p:txBody>
-      </p:sp>
-      <p:sp>
-        <p:nvSpPr>
-          <p:cNvPr id="93" name="Rounded Rectangle 92"/>
-          <p:cNvSpPr/>
-          <p:nvPr/>
-        </p:nvSpPr>
-        <p:spPr>
-          <a:xfrm>
-            <a:off x="16949928" y="28959048"/>
-            <a:ext cx="7720584" cy="1874519"/>
-          </a:xfrm>
-          <a:prstGeom prst="roundRect">
-            <a:avLst/>
-          </a:prstGeom>
-          <a:solidFill>
-            <a:srgbClr val="E8E3D8"/>
-          </a:solidFill>
-          <a:ln w="12700">
-            <a:solidFill>
-              <a:srgbClr val="D2C9BB"/>
-            </a:solidFill>
-          </a:ln>
-        </p:spPr>
-        <p:style>
-          <a:lnRef idx="1">
-            <a:schemeClr val="accent1"/>
-          </a:lnRef>
-          <a:fillRef idx="3">
-            <a:schemeClr val="accent1"/>
-          </a:fillRef>
-          <a:effectRef idx="2">
-            <a:schemeClr val="accent1"/>
-          </a:effectRef>
-          <a:fontRef idx="minor">
-            <a:schemeClr val="lt1"/>
-          </a:fontRef>
-        </p:style>
-        <p:txBody>
-          <a:bodyPr rtlCol="0" anchor="ctr"/>
-          <a:lstStyle/>
-          <a:p>
-            <a:pPr algn="ctr"/>
-          </a:p>
-        </p:txBody>
-      </p:sp>
-      <p:sp>
-        <p:nvSpPr>
-          <p:cNvPr id="94" name="TextBox 93"/>
-          <p:cNvSpPr txBox="1"/>
-          <p:nvPr/>
-        </p:nvSpPr>
-        <p:spPr>
-          <a:xfrm>
-            <a:off x="17151096" y="29123640"/>
-            <a:ext cx="7318248" cy="365760"/>
-          </a:xfrm>
-          <a:prstGeom prst="rect">
-            <a:avLst/>
-          </a:prstGeom>
-          <a:noFill/>
-        </p:spPr>
-        <p:txBody>
-          <a:bodyPr wrap="square" anchor="t" lIns="0" rIns="0" tIns="18288" bIns="18288">
-            <a:spAutoFit/>
-          </a:bodyPr>
-          <a:lstStyle/>
-          <a:p>
-            <a:pPr algn="ctr">
-              <a:spcAft>
-                <a:spcPts val="400"/>
-              </a:spcAft>
-              <a:defRPr sz="1800" b="1" i="0">
-                <a:solidFill>
-                  <a:srgbClr val="4C8A61"/>
-                </a:solidFill>
-                <a:latin typeface="Arial"/>
-              </a:defRPr>
-            </a:pPr>
-            <a:r>
-              <a:t>Modern outputs</a:t>
-            </a:r>
-          </a:p>
-        </p:txBody>
-      </p:sp>
-      <p:sp>
-        <p:nvSpPr>
-          <p:cNvPr id="95" name="TextBox 94"/>
-          <p:cNvSpPr txBox="1"/>
-          <p:nvPr/>
-        </p:nvSpPr>
-        <p:spPr>
-          <a:xfrm>
-            <a:off x="17260824" y="29653992"/>
-            <a:ext cx="7098792" cy="1051560"/>
-          </a:xfrm>
-          <a:prstGeom prst="rect">
-            <a:avLst/>
-          </a:prstGeom>
-          <a:noFill/>
-        </p:spPr>
-        <p:txBody>
-          <a:bodyPr wrap="square" anchor="t" lIns="0" rIns="0" tIns="18288" bIns="18288">
-            <a:spAutoFit/>
-          </a:bodyPr>
-          <a:lstStyle/>
-          <a:p>
-            <a:pPr algn="ctr">
-              <a:spcAft>
-                <a:spcPts val="400"/>
-              </a:spcAft>
-              <a:defRPr sz="1530" b="0" i="0">
-                <a:solidFill>
-                  <a:srgbClr val="17291F"/>
-                </a:solidFill>
-                <a:latin typeface="Arial"/>
-              </a:defRPr>
-            </a:pPr>
-            <a:r>
-              <a:t>Typed results and Plotly figures are easier to audit and reuse.</a:t>
-            </a:r>
-          </a:p>
-        </p:txBody>
-      </p:sp>
-      <p:sp>
-        <p:nvSpPr>
-          <p:cNvPr id="96" name="TextBox 95"/>
-          <p:cNvSpPr txBox="1"/>
-          <p:nvPr/>
-        </p:nvSpPr>
-        <p:spPr>
-          <a:xfrm>
-            <a:off x="777240" y="31043880"/>
-            <a:ext cx="23893272" cy="384048"/>
-          </a:xfrm>
-          <a:prstGeom prst="rect">
-            <a:avLst/>
-          </a:prstGeom>
-          <a:noFill/>
-        </p:spPr>
-        <p:txBody>
-          <a:bodyPr wrap="square" anchor="t" lIns="0" rIns="0" tIns="18288" bIns="18288">
-            <a:spAutoFit/>
-          </a:bodyPr>
-          <a:lstStyle/>
-          <a:p>
-            <a:pPr algn="ctr">
-              <a:spcAft>
-                <a:spcPts val="400"/>
-              </a:spcAft>
-              <a:defRPr sz="2000" b="0" i="0">
-                <a:solidFill>
-                  <a:srgbClr val="10231A"/>
-                </a:solidFill>
-                <a:latin typeface="Georgia"/>
-              </a:defRPr>
-            </a:pPr>
-            <a:r>
-              <a:t>Open Python sensory workflow</a:t>
-            </a:r>
-          </a:p>
-        </p:txBody>
-      </p:sp>
-      <p:sp>
-        <p:nvSpPr>
-          <p:cNvPr id="97" name="Rounded Rectangle 96"/>
-          <p:cNvSpPr/>
-          <p:nvPr/>
-        </p:nvSpPr>
-        <p:spPr>
-          <a:xfrm>
-            <a:off x="777240" y="31574232"/>
-            <a:ext cx="5698998" cy="2788920"/>
-          </a:xfrm>
-          <a:prstGeom prst="roundRect">
-            <a:avLst/>
-          </a:prstGeom>
-          <a:solidFill>
-            <a:srgbClr val="E8E3D8"/>
-          </a:solidFill>
-          <a:ln w="12700">
-            <a:solidFill>
-              <a:srgbClr val="D2C9BB"/>
-            </a:solidFill>
-          </a:ln>
-        </p:spPr>
-        <p:style>
-          <a:lnRef idx="1">
-            <a:schemeClr val="accent1"/>
-          </a:lnRef>
-          <a:fillRef idx="3">
-            <a:schemeClr val="accent1"/>
-          </a:fillRef>
-          <a:effectRef idx="2">
-            <a:schemeClr val="accent1"/>
-          </a:effectRef>
-          <a:fontRef idx="minor">
-            <a:schemeClr val="lt1"/>
-          </a:fontRef>
-        </p:style>
-        <p:txBody>
-          <a:bodyPr rtlCol="0" anchor="ctr"/>
-          <a:lstStyle/>
-          <a:p>
-            <a:pPr algn="ctr"/>
-          </a:p>
-        </p:txBody>
-      </p:sp>
-      <p:sp>
-        <p:nvSpPr>
-          <p:cNvPr id="98" name="TextBox 97"/>
-          <p:cNvSpPr txBox="1"/>
-          <p:nvPr/>
-        </p:nvSpPr>
-        <p:spPr>
-          <a:xfrm>
-            <a:off x="914400" y="31793688"/>
-            <a:ext cx="5424678" cy="384048"/>
-          </a:xfrm>
-          <a:prstGeom prst="rect">
-            <a:avLst/>
-          </a:prstGeom>
-          <a:noFill/>
-        </p:spPr>
-        <p:txBody>
-          <a:bodyPr wrap="square" anchor="t" lIns="0" rIns="0" tIns="18288" bIns="18288">
-            <a:spAutoFit/>
-          </a:bodyPr>
-          <a:lstStyle/>
-          <a:p>
-            <a:pPr algn="ctr">
-              <a:spcAft>
-                <a:spcPts val="400"/>
-              </a:spcAft>
-              <a:defRPr sz="2000" b="1" i="0">
-                <a:solidFill>
-                  <a:srgbClr val="C7563F"/>
-                </a:solidFill>
-                <a:latin typeface="Arial"/>
-              </a:defRPr>
-            </a:pPr>
-            <a:r>
-              <a:t>1. Estimate</a:t>
-            </a:r>
-          </a:p>
-        </p:txBody>
-      </p:sp>
-      <p:sp>
-        <p:nvSpPr>
-          <p:cNvPr id="99" name="TextBox 98"/>
-          <p:cNvSpPr txBox="1"/>
-          <p:nvPr/>
-        </p:nvSpPr>
-        <p:spPr>
-          <a:xfrm>
-            <a:off x="1161288" y="32342328"/>
-            <a:ext cx="4930902" cy="548640"/>
-          </a:xfrm>
-          <a:prstGeom prst="rect">
-            <a:avLst/>
-          </a:prstGeom>
-          <a:noFill/>
-        </p:spPr>
-        <p:txBody>
-          <a:bodyPr wrap="square" anchor="t" lIns="0" rIns="0" tIns="18288" bIns="18288">
-            <a:spAutoFit/>
-          </a:bodyPr>
-          <a:lstStyle/>
-          <a:p>
-            <a:pPr algn="ctr">
-              <a:spcAft>
-                <a:spcPts val="400"/>
-              </a:spcAft>
-              <a:defRPr sz="1600" b="0" i="0">
-                <a:solidFill>
-                  <a:srgbClr val="17291F"/>
-                </a:solidFill>
-                <a:latin typeface="Arial"/>
-              </a:defRPr>
-            </a:pPr>
-            <a:r>
-              <a:t>d-prime, Pc, Pd, intervals</a:t>
-            </a:r>
-          </a:p>
-        </p:txBody>
-      </p:sp>
-      <p:sp>
-        <p:nvSpPr>
-          <p:cNvPr id="100" name="TextBox 99"/>
-          <p:cNvSpPr txBox="1"/>
-          <p:nvPr/>
-        </p:nvSpPr>
-        <p:spPr>
-          <a:xfrm>
-            <a:off x="1161288" y="33000696"/>
-            <a:ext cx="4930902" cy="402336"/>
-          </a:xfrm>
-          <a:prstGeom prst="rect">
-            <a:avLst/>
-          </a:prstGeom>
-          <a:noFill/>
-        </p:spPr>
-        <p:txBody>
-          <a:bodyPr wrap="square" anchor="t" lIns="0" rIns="0" tIns="18288" bIns="18288">
-            <a:spAutoFit/>
-          </a:bodyPr>
-          <a:lstStyle/>
-          <a:p>
-            <a:pPr algn="ctr">
-              <a:spcAft>
-                <a:spcPts val="400"/>
-              </a:spcAft>
-              <a:defRPr sz="1420" b="0" i="0">
-                <a:solidFill>
-                  <a:srgbClr val="10231A"/>
-                </a:solidFill>
-                <a:latin typeface="Courier New"/>
-              </a:defRPr>
-            </a:pPr>
-            <a:r>
-              <a:t>discrim(), samediff(), dod()</a:t>
-            </a:r>
-          </a:p>
-        </p:txBody>
-      </p:sp>
-      <p:sp>
-        <p:nvSpPr>
-          <p:cNvPr id="101" name="TextBox 100"/>
-          <p:cNvSpPr txBox="1"/>
-          <p:nvPr/>
-        </p:nvSpPr>
-        <p:spPr>
-          <a:xfrm>
-            <a:off x="1161288" y="33494472"/>
-            <a:ext cx="4930902" cy="438912"/>
-          </a:xfrm>
-          <a:prstGeom prst="rect">
-            <a:avLst/>
-          </a:prstGeom>
-          <a:noFill/>
-        </p:spPr>
-        <p:txBody>
-          <a:bodyPr wrap="square" anchor="t" lIns="0" rIns="0" tIns="18288" bIns="18288">
-            <a:spAutoFit/>
-          </a:bodyPr>
-          <a:lstStyle/>
-          <a:p>
-            <a:pPr algn="ctr">
-              <a:spcAft>
-                <a:spcPts val="400"/>
-              </a:spcAft>
-              <a:defRPr sz="1380" b="0" i="0">
-                <a:solidFill>
-                  <a:srgbClr val="4D5A52"/>
-                </a:solidFill>
-                <a:latin typeface="Arial"/>
-              </a:defRPr>
-            </a:pPr>
-            <a:r>
-              <a:t>typed estimates + confidence intervals</a:t>
-            </a:r>
-          </a:p>
-        </p:txBody>
-      </p:sp>
-      <p:sp>
-        <p:nvSpPr>
-          <p:cNvPr id="102" name="Rounded Rectangle 101"/>
-          <p:cNvSpPr/>
-          <p:nvPr/>
-        </p:nvSpPr>
-        <p:spPr>
-          <a:xfrm>
-            <a:off x="6841998" y="31574232"/>
-            <a:ext cx="5698998" cy="2788920"/>
-          </a:xfrm>
-          <a:prstGeom prst="roundRect">
-            <a:avLst/>
-          </a:prstGeom>
-          <a:solidFill>
-            <a:srgbClr val="E8E3D8"/>
-          </a:solidFill>
-          <a:ln w="12700">
-            <a:solidFill>
-              <a:srgbClr val="D2C9BB"/>
-            </a:solidFill>
-          </a:ln>
-        </p:spPr>
-        <p:style>
-          <a:lnRef idx="1">
-            <a:schemeClr val="accent1"/>
-          </a:lnRef>
-          <a:fillRef idx="3">
-            <a:schemeClr val="accent1"/>
-          </a:fillRef>
-          <a:effectRef idx="2">
-            <a:schemeClr val="accent1"/>
-          </a:effectRef>
-          <a:fontRef idx="minor">
-            <a:schemeClr val="lt1"/>
-          </a:fontRef>
-        </p:style>
-        <p:txBody>
-          <a:bodyPr rtlCol="0" anchor="ctr"/>
-          <a:lstStyle/>
-          <a:p>
-            <a:pPr algn="ctr"/>
-          </a:p>
-        </p:txBody>
-      </p:sp>
-      <p:sp>
-        <p:nvSpPr>
-          <p:cNvPr id="103" name="TextBox 102"/>
-          <p:cNvSpPr txBox="1"/>
-          <p:nvPr/>
-        </p:nvSpPr>
-        <p:spPr>
-          <a:xfrm>
-            <a:off x="6979158" y="31793688"/>
-            <a:ext cx="5424678" cy="384048"/>
-          </a:xfrm>
-          <a:prstGeom prst="rect">
-            <a:avLst/>
-          </a:prstGeom>
-          <a:noFill/>
-        </p:spPr>
-        <p:txBody>
-          <a:bodyPr wrap="square" anchor="t" lIns="0" rIns="0" tIns="18288" bIns="18288">
-            <a:spAutoFit/>
-          </a:bodyPr>
-          <a:lstStyle/>
-          <a:p>
-            <a:pPr algn="ctr">
-              <a:spcAft>
-                <a:spcPts val="400"/>
-              </a:spcAft>
-              <a:defRPr sz="2000" b="1" i="0">
-                <a:solidFill>
-                  <a:srgbClr val="C7563F"/>
-                </a:solidFill>
-                <a:latin typeface="Arial"/>
-              </a:defRPr>
-            </a:pPr>
-            <a:r>
-              <a:t>2. Plan</a:t>
-            </a:r>
-          </a:p>
-        </p:txBody>
-      </p:sp>
-      <p:sp>
-        <p:nvSpPr>
-          <p:cNvPr id="104" name="TextBox 103"/>
-          <p:cNvSpPr txBox="1"/>
-          <p:nvPr/>
-        </p:nvSpPr>
-        <p:spPr>
-          <a:xfrm>
-            <a:off x="7226046" y="32342328"/>
-            <a:ext cx="4930902" cy="548640"/>
-          </a:xfrm>
-          <a:prstGeom prst="rect">
-            <a:avLst/>
-          </a:prstGeom>
-          <a:noFill/>
-        </p:spPr>
-        <p:txBody>
-          <a:bodyPr wrap="square" anchor="t" lIns="0" rIns="0" tIns="18288" bIns="18288">
-            <a:spAutoFit/>
-          </a:bodyPr>
-          <a:lstStyle/>
-          <a:p>
-            <a:pPr algn="ctr">
-              <a:spcAft>
-                <a:spcPts val="400"/>
-              </a:spcAft>
-              <a:defRPr sz="1600" b="0" i="0">
-                <a:solidFill>
-                  <a:srgbClr val="17291F"/>
-                </a:solidFill>
-                <a:latin typeface="Arial"/>
-              </a:defRPr>
-            </a:pPr>
-            <a:r>
-              <a:t>power and sample size</a:t>
-            </a:r>
-          </a:p>
-        </p:txBody>
-      </p:sp>
-      <p:sp>
-        <p:nvSpPr>
-          <p:cNvPr id="105" name="TextBox 104"/>
-          <p:cNvSpPr txBox="1"/>
-          <p:nvPr/>
-        </p:nvSpPr>
-        <p:spPr>
-          <a:xfrm>
-            <a:off x="7226046" y="33000696"/>
-            <a:ext cx="4930902" cy="402336"/>
-          </a:xfrm>
-          <a:prstGeom prst="rect">
-            <a:avLst/>
-          </a:prstGeom>
-          <a:noFill/>
-        </p:spPr>
-        <p:txBody>
-          <a:bodyPr wrap="square" anchor="t" lIns="0" rIns="0" tIns="18288" bIns="18288">
-            <a:spAutoFit/>
-          </a:bodyPr>
-          <a:lstStyle/>
-          <a:p>
-            <a:pPr algn="ctr">
-              <a:spcAft>
-                <a:spcPts val="400"/>
-              </a:spcAft>
-              <a:defRPr sz="1420" b="0" i="0">
-                <a:solidFill>
-                  <a:srgbClr val="10231A"/>
-                </a:solidFill>
-                <a:latin typeface="Courier New"/>
-              </a:defRPr>
-            </a:pPr>
-            <a:r>
-              <a:t>discrim_power(), dprime_sample_size()</a:t>
-            </a:r>
-          </a:p>
-        </p:txBody>
-      </p:sp>
-      <p:sp>
-        <p:nvSpPr>
-          <p:cNvPr id="106" name="TextBox 105"/>
-          <p:cNvSpPr txBox="1"/>
-          <p:nvPr/>
-        </p:nvSpPr>
-        <p:spPr>
-          <a:xfrm>
-            <a:off x="7226046" y="33494472"/>
-            <a:ext cx="4930902" cy="438912"/>
-          </a:xfrm>
-          <a:prstGeom prst="rect">
-            <a:avLst/>
-          </a:prstGeom>
-          <a:noFill/>
-        </p:spPr>
-        <p:txBody>
-          <a:bodyPr wrap="square" anchor="t" lIns="0" rIns="0" tIns="18288" bIns="18288">
-            <a:spAutoFit/>
-          </a:bodyPr>
-          <a:lstStyle/>
-          <a:p>
-            <a:pPr algn="ctr">
-              <a:spcAft>
-                <a:spcPts val="400"/>
-              </a:spcAft>
-              <a:defRPr sz="1380" b="0" i="0">
-                <a:solidFill>
-                  <a:srgbClr val="4D5A52"/>
-                </a:solidFill>
-                <a:latin typeface="Arial"/>
-              </a:defRPr>
-            </a:pPr>
-            <a:r>
-              <a:t>design studies before collecting data</a:t>
-            </a:r>
-          </a:p>
-        </p:txBody>
-      </p:sp>
-      <p:sp>
-        <p:nvSpPr>
-          <p:cNvPr id="107" name="Rounded Rectangle 106"/>
-          <p:cNvSpPr/>
-          <p:nvPr/>
-        </p:nvSpPr>
-        <p:spPr>
-          <a:xfrm>
-            <a:off x="12906756" y="31574232"/>
-            <a:ext cx="5698998" cy="2788920"/>
-          </a:xfrm>
-          <a:prstGeom prst="roundRect">
-            <a:avLst/>
-          </a:prstGeom>
-          <a:solidFill>
-            <a:srgbClr val="E8E3D8"/>
-          </a:solidFill>
-          <a:ln w="12700">
-            <a:solidFill>
-              <a:srgbClr val="D2C9BB"/>
-            </a:solidFill>
-          </a:ln>
-        </p:spPr>
-        <p:style>
-          <a:lnRef idx="1">
-            <a:schemeClr val="accent1"/>
-          </a:lnRef>
-          <a:fillRef idx="3">
-            <a:schemeClr val="accent1"/>
-          </a:fillRef>
-          <a:effectRef idx="2">
-            <a:schemeClr val="accent1"/>
-          </a:effectRef>
-          <a:fontRef idx="minor">
-            <a:schemeClr val="lt1"/>
-          </a:fontRef>
-        </p:style>
-        <p:txBody>
-          <a:bodyPr rtlCol="0" anchor="ctr"/>
-          <a:lstStyle/>
-          <a:p>
-            <a:pPr algn="ctr"/>
-          </a:p>
-        </p:txBody>
-      </p:sp>
-      <p:sp>
-        <p:nvSpPr>
-          <p:cNvPr id="108" name="TextBox 107"/>
-          <p:cNvSpPr txBox="1"/>
-          <p:nvPr/>
-        </p:nvSpPr>
-        <p:spPr>
-          <a:xfrm>
-            <a:off x="13043916" y="31793688"/>
-            <a:ext cx="5424678" cy="384048"/>
-          </a:xfrm>
-          <a:prstGeom prst="rect">
-            <a:avLst/>
-          </a:prstGeom>
-          <a:noFill/>
-        </p:spPr>
-        <p:txBody>
-          <a:bodyPr wrap="square" anchor="t" lIns="0" rIns="0" tIns="18288" bIns="18288">
-            <a:spAutoFit/>
-          </a:bodyPr>
-          <a:lstStyle/>
-          <a:p>
-            <a:pPr algn="ctr">
-              <a:spcAft>
-                <a:spcPts val="400"/>
-              </a:spcAft>
-              <a:defRPr sz="2000" b="1" i="0">
-                <a:solidFill>
-                  <a:srgbClr val="C7563F"/>
-                </a:solidFill>
-                <a:latin typeface="Arial"/>
-              </a:defRPr>
-            </a:pPr>
-            <a:r>
-              <a:t>3. Model</a:t>
-            </a:r>
-          </a:p>
-        </p:txBody>
-      </p:sp>
-      <p:sp>
-        <p:nvSpPr>
-          <p:cNvPr id="109" name="TextBox 108"/>
-          <p:cNvSpPr txBox="1"/>
-          <p:nvPr/>
-        </p:nvSpPr>
-        <p:spPr>
-          <a:xfrm>
-            <a:off x="13290804" y="32342328"/>
-            <a:ext cx="4930902" cy="548640"/>
-          </a:xfrm>
-          <a:prstGeom prst="rect">
-            <a:avLst/>
-          </a:prstGeom>
-          <a:noFill/>
-        </p:spPr>
-        <p:txBody>
-          <a:bodyPr wrap="square" anchor="t" lIns="0" rIns="0" tIns="18288" bIns="18288">
-            <a:spAutoFit/>
-          </a:bodyPr>
-          <a:lstStyle/>
-          <a:p>
-            <a:pPr algn="ctr">
-              <a:spcAft>
-                <a:spcPts val="400"/>
-              </a:spcAft>
-              <a:defRPr sz="1600" b="0" i="0">
-                <a:solidFill>
-                  <a:srgbClr val="17291F"/>
-                </a:solidFill>
-                <a:latin typeface="Arial"/>
-              </a:defRPr>
-            </a:pPr>
-            <a:r>
-              <a:t>overdispersion and criteria</a:t>
-            </a:r>
-          </a:p>
-        </p:txBody>
-      </p:sp>
-      <p:sp>
-        <p:nvSpPr>
-          <p:cNvPr id="110" name="TextBox 109"/>
-          <p:cNvSpPr txBox="1"/>
-          <p:nvPr/>
-        </p:nvSpPr>
-        <p:spPr>
-          <a:xfrm>
-            <a:off x="13290804" y="33000696"/>
-            <a:ext cx="4930902" cy="402336"/>
-          </a:xfrm>
-          <a:prstGeom prst="rect">
-            <a:avLst/>
-          </a:prstGeom>
-          <a:noFill/>
-        </p:spPr>
-        <p:txBody>
-          <a:bodyPr wrap="square" anchor="t" lIns="0" rIns="0" tIns="18288" bIns="18288">
-            <a:spAutoFit/>
-          </a:bodyPr>
-          <a:lstStyle/>
-          <a:p>
-            <a:pPr algn="ctr">
-              <a:spcAft>
-                <a:spcPts val="400"/>
-              </a:spcAft>
-              <a:defRPr sz="1420" b="0" i="0">
-                <a:solidFill>
-                  <a:srgbClr val="10231A"/>
-                </a:solidFill>
-                <a:latin typeface="Courier New"/>
-              </a:defRPr>
-            </a:pPr>
-            <a:r>
-              <a:t>betabin(), samediff(), twoac()</a:t>
-            </a:r>
-          </a:p>
-        </p:txBody>
-      </p:sp>
-      <p:sp>
-        <p:nvSpPr>
-          <p:cNvPr id="111" name="TextBox 110"/>
-          <p:cNvSpPr txBox="1"/>
-          <p:nvPr/>
-        </p:nvSpPr>
-        <p:spPr>
-          <a:xfrm>
-            <a:off x="13290804" y="33494472"/>
-            <a:ext cx="4930902" cy="438912"/>
-          </a:xfrm>
-          <a:prstGeom prst="rect">
-            <a:avLst/>
-          </a:prstGeom>
-          <a:noFill/>
-        </p:spPr>
-        <p:txBody>
-          <a:bodyPr wrap="square" anchor="t" lIns="0" rIns="0" tIns="18288" bIns="18288">
-            <a:spAutoFit/>
-          </a:bodyPr>
-          <a:lstStyle/>
-          <a:p>
-            <a:pPr algn="ctr">
-              <a:spcAft>
-                <a:spcPts val="400"/>
-              </a:spcAft>
-              <a:defRPr sz="1380" b="0" i="0">
-                <a:solidFill>
-                  <a:srgbClr val="4D5A52"/>
-                </a:solidFill>
-                <a:latin typeface="Arial"/>
-              </a:defRPr>
-            </a:pPr>
-            <a:r>
-              <a:t>panel variability + criterion effects</a:t>
-            </a:r>
-          </a:p>
-        </p:txBody>
-      </p:sp>
-      <p:sp>
-        <p:nvSpPr>
-          <p:cNvPr id="112" name="Rounded Rectangle 111"/>
-          <p:cNvSpPr/>
-          <p:nvPr/>
-        </p:nvSpPr>
-        <p:spPr>
-          <a:xfrm>
-            <a:off x="18971514" y="31574232"/>
-            <a:ext cx="5698998" cy="2788920"/>
-          </a:xfrm>
-          <a:prstGeom prst="roundRect">
-            <a:avLst/>
-          </a:prstGeom>
-          <a:solidFill>
-            <a:srgbClr val="E8E3D8"/>
-          </a:solidFill>
-          <a:ln w="12700">
-            <a:solidFill>
-              <a:srgbClr val="D2C9BB"/>
-            </a:solidFill>
-          </a:ln>
-        </p:spPr>
-        <p:style>
-          <a:lnRef idx="1">
-            <a:schemeClr val="accent1"/>
-          </a:lnRef>
-          <a:fillRef idx="3">
-            <a:schemeClr val="accent1"/>
-          </a:fillRef>
-          <a:effectRef idx="2">
-            <a:schemeClr val="accent1"/>
-          </a:effectRef>
-          <a:fontRef idx="minor">
-            <a:schemeClr val="lt1"/>
-          </a:fontRef>
-        </p:style>
-        <p:txBody>
-          <a:bodyPr rtlCol="0" anchor="ctr"/>
-          <a:lstStyle/>
-          <a:p>
-            <a:pPr algn="ctr"/>
-          </a:p>
-        </p:txBody>
-      </p:sp>
-      <p:sp>
-        <p:nvSpPr>
-          <p:cNvPr id="113" name="TextBox 112"/>
-          <p:cNvSpPr txBox="1"/>
-          <p:nvPr/>
-        </p:nvSpPr>
-        <p:spPr>
-          <a:xfrm>
-            <a:off x="19108674" y="31793688"/>
-            <a:ext cx="5424678" cy="384048"/>
-          </a:xfrm>
-          <a:prstGeom prst="rect">
-            <a:avLst/>
-          </a:prstGeom>
-          <a:noFill/>
-        </p:spPr>
-        <p:txBody>
-          <a:bodyPr wrap="square" anchor="t" lIns="0" rIns="0" tIns="18288" bIns="18288">
-            <a:spAutoFit/>
-          </a:bodyPr>
-          <a:lstStyle/>
-          <a:p>
-            <a:pPr algn="ctr">
-              <a:spcAft>
-                <a:spcPts val="400"/>
-              </a:spcAft>
-              <a:defRPr sz="2000" b="1" i="0">
-                <a:solidFill>
-                  <a:srgbClr val="C7563F"/>
-                </a:solidFill>
-                <a:latin typeface="Arial"/>
-              </a:defRPr>
-            </a:pPr>
-            <a:r>
-              <a:t>4. Visualize</a:t>
-            </a:r>
-          </a:p>
-        </p:txBody>
-      </p:sp>
-      <p:sp>
-        <p:nvSpPr>
-          <p:cNvPr id="114" name="TextBox 113"/>
-          <p:cNvSpPr txBox="1"/>
-          <p:nvPr/>
-        </p:nvSpPr>
-        <p:spPr>
-          <a:xfrm>
-            <a:off x="19355562" y="32342328"/>
-            <a:ext cx="4930902" cy="548640"/>
-          </a:xfrm>
-          <a:prstGeom prst="rect">
-            <a:avLst/>
-          </a:prstGeom>
-          <a:noFill/>
-        </p:spPr>
-        <p:txBody>
-          <a:bodyPr wrap="square" anchor="t" lIns="0" rIns="0" tIns="18288" bIns="18288">
-            <a:spAutoFit/>
-          </a:bodyPr>
-          <a:lstStyle/>
-          <a:p>
-            <a:pPr algn="ctr">
-              <a:spcAft>
-                <a:spcPts val="400"/>
-              </a:spcAft>
-              <a:defRPr sz="1600" b="0" i="0">
-                <a:solidFill>
-                  <a:srgbClr val="17291F"/>
-                </a:solidFill>
-                <a:latin typeface="Arial"/>
-              </a:defRPr>
-            </a:pPr>
-            <a:r>
-              <a:t>Plotly psychometric + ROC</a:t>
-            </a:r>
-          </a:p>
-        </p:txBody>
-      </p:sp>
-      <p:sp>
-        <p:nvSpPr>
-          <p:cNvPr id="115" name="TextBox 114"/>
-          <p:cNvSpPr txBox="1"/>
-          <p:nvPr/>
-        </p:nvSpPr>
-        <p:spPr>
-          <a:xfrm>
-            <a:off x="19355562" y="33000696"/>
-            <a:ext cx="4930902" cy="402336"/>
-          </a:xfrm>
-          <a:prstGeom prst="rect">
-            <a:avLst/>
-          </a:prstGeom>
-          <a:noFill/>
-        </p:spPr>
-        <p:txBody>
-          <a:bodyPr wrap="square" anchor="t" lIns="0" rIns="0" tIns="18288" bIns="18288">
-            <a:spAutoFit/>
-          </a:bodyPr>
-          <a:lstStyle/>
-          <a:p>
-            <a:pPr algn="ctr">
-              <a:spcAft>
-                <a:spcPts val="400"/>
-              </a:spcAft>
-              <a:defRPr sz="1420" b="0" i="0">
-                <a:solidFill>
-                  <a:srgbClr val="10231A"/>
-                </a:solidFill>
-                <a:latin typeface="Courier New"/>
-              </a:defRPr>
-            </a:pPr>
-            <a:r>
-              <a:t>plot_psychometric(), plot_roc()</a:t>
-            </a:r>
-          </a:p>
-        </p:txBody>
-      </p:sp>
-      <p:sp>
-        <p:nvSpPr>
-          <p:cNvPr id="116" name="TextBox 115"/>
-          <p:cNvSpPr txBox="1"/>
-          <p:nvPr/>
-        </p:nvSpPr>
-        <p:spPr>
-          <a:xfrm>
-            <a:off x="19355562" y="33494472"/>
-            <a:ext cx="4930902" cy="438912"/>
-          </a:xfrm>
-          <a:prstGeom prst="rect">
-            <a:avLst/>
-          </a:prstGeom>
-          <a:noFill/>
-        </p:spPr>
-        <p:txBody>
-          <a:bodyPr wrap="square" anchor="t" lIns="0" rIns="0" tIns="18288" bIns="18288">
-            <a:spAutoFit/>
-          </a:bodyPr>
-          <a:lstStyle/>
-          <a:p>
-            <a:pPr algn="ctr">
-              <a:spcAft>
-                <a:spcPts val="400"/>
-              </a:spcAft>
-              <a:defRPr sz="1380" b="0" i="0">
-                <a:solidFill>
-                  <a:srgbClr val="4D5A52"/>
-                </a:solidFill>
-                <a:latin typeface="Arial"/>
-              </a:defRPr>
-            </a:pPr>
-            <a:r>
-              <a:t>interactive curves for review</a:t>
-            </a:r>
-          </a:p>
-        </p:txBody>
-      </p:sp>
-      <p:sp>
-        <p:nvSpPr>
-          <p:cNvPr id="117" name="Rectangle 116"/>
+              <a:t>Selected references: sensR package; Macmillan &amp; Creelman, Detection Theory; SciPy; Plotly; golden sensR v1.5.3 fixtures.</a:t>
+            </a:r>
+          </a:p>
+        </p:txBody>
+      </p:sp>
+      <p:sp>
+        <p:nvSpPr>
+          <p:cNvPr id="82" name="Rectangle 81"/>
           <p:cNvSpPr/>
           <p:nvPr/>
         </p:nvSpPr>
@@ -7827,14 +6326,14 @@
       </p:sp>
       <p:sp>
         <p:nvSpPr>
-          <p:cNvPr id="118" name="TextBox 117"/>
+          <p:cNvPr id="83" name="TextBox 82"/>
           <p:cNvSpPr txBox="1"/>
           <p:nvPr/>
         </p:nvSpPr>
         <p:spPr>
           <a:xfrm>
-            <a:off x="777240" y="35058096"/>
-            <a:ext cx="1828800" cy="411480"/>
+            <a:off x="777240" y="35021520"/>
+            <a:ext cx="1828800" cy="457200"/>
           </a:xfrm>
           <a:prstGeom prst="rect">
             <a:avLst/>
@@ -7851,7 +6350,7 @@
               <a:spcAft>
                 <a:spcPts val="400"/>
               </a:spcAft>
-              <a:defRPr sz="2000" b="0" i="0">
+              <a:defRPr sz="2400" b="0" i="0">
                 <a:solidFill>
                   <a:srgbClr val="FFFFFF"/>
                 </a:solidFill>
@@ -7866,14 +6365,14 @@
       </p:sp>
       <p:sp>
         <p:nvSpPr>
-          <p:cNvPr id="119" name="TextBox 118"/>
+          <p:cNvPr id="84" name="TextBox 83"/>
           <p:cNvSpPr txBox="1"/>
           <p:nvPr/>
         </p:nvSpPr>
         <p:spPr>
           <a:xfrm>
-            <a:off x="7406640" y="35076383"/>
-            <a:ext cx="10515600" cy="411480"/>
+            <a:off x="7406640" y="35058096"/>
+            <a:ext cx="10515600" cy="457200"/>
           </a:xfrm>
           <a:prstGeom prst="rect">
             <a:avLst/>
@@ -7890,7 +6389,7 @@
               <a:spcAft>
                 <a:spcPts val="400"/>
               </a:spcAft>
-              <a:defRPr sz="1700" b="0" i="0">
+              <a:defRPr sz="2000" b="0" i="0">
                 <a:solidFill>
                   <a:srgbClr val="FFFFFF"/>
                 </a:solidFill>
@@ -7905,22 +6404,22 @@
       </p:sp>
       <p:pic>
         <p:nvPicPr>
-          <p:cNvPr id="120" name="Picture 119" descr="qr-senspy-github.png"/>
+          <p:cNvPr id="85" name="Picture 84" descr="qr-senspy-github.png"/>
           <p:cNvPicPr>
             <a:picLocks noChangeAspect="1"/>
           </p:cNvPicPr>
           <p:nvPr/>
         </p:nvPicPr>
         <p:blipFill>
-          <a:blip r:embed="rId7"/>
+          <a:blip r:embed="rId5"/>
           <a:stretch>
             <a:fillRect/>
           </a:stretch>
         </p:blipFill>
         <p:spPr>
           <a:xfrm>
-            <a:off x="23829263" y="34893504"/>
-            <a:ext cx="841248" cy="841248"/>
+            <a:off x="23710391" y="34856928"/>
+            <a:ext cx="960120" cy="960120"/>
           </a:xfrm>
           <a:prstGeom prst="rect">
             <a:avLst/>

</xml_diff>

<commit_message>
[codex/senspy-sensometrics-poster · Batch 4/4] Fill cards and cite sensR
</commit_message>
<xml_diff>
--- a/poster/print_artifacts/senspy-sensometrics-2026-poster.pptx
+++ b/poster/print_artifacts/senspy-sensometrics-2026-poster.pptx
@@ -3321,7 +3321,7 @@
               <a:spcAft>
                 <a:spcPts val="400"/>
               </a:spcAft>
-              <a:defRPr sz="2700" b="1" i="0">
+              <a:defRPr sz="2500" b="1" i="0">
                 <a:solidFill>
                   <a:srgbClr val="17291F"/>
                 </a:solidFill>
@@ -3329,7 +3329,7 @@
               </a:defRPr>
             </a:pPr>
             <a:r>
-              <a:t>John M. Ennis | Aigora | Sensometrics 2026</a:t>
+              <a:t>John M. Ennis and Bartosz Smulski | Aigora | Sensometrics 2026</a:t>
             </a:r>
           </a:p>
         </p:txBody>
@@ -3586,8 +3586,8 @@
         </p:nvSpPr>
         <p:spPr>
           <a:xfrm>
-            <a:off x="1307592" y="7955280"/>
-            <a:ext cx="4878324" cy="1188720"/>
+            <a:off x="1307592" y="7918704"/>
+            <a:ext cx="4878324" cy="658368"/>
           </a:xfrm>
           <a:prstGeom prst="rect">
             <a:avLst/>
@@ -3619,7 +3619,46 @@
       </p:sp>
       <p:sp>
         <p:nvSpPr>
-          <p:cNvPr id="15" name="Rounded Rectangle 14"/>
+          <p:cNvPr id="15" name="TextBox 14"/>
+          <p:cNvSpPr txBox="1"/>
+          <p:nvPr/>
+        </p:nvSpPr>
+        <p:spPr>
+          <a:xfrm>
+            <a:off x="1344168" y="8650224"/>
+            <a:ext cx="4805172" cy="484632"/>
+          </a:xfrm>
+          <a:prstGeom prst="rect">
+            <a:avLst/>
+          </a:prstGeom>
+          <a:noFill/>
+        </p:spPr>
+        <p:txBody>
+          <a:bodyPr wrap="square" anchor="t" lIns="45720" rIns="45720" tIns="18288" bIns="18288">
+            <a:spAutoFit/>
+          </a:bodyPr>
+          <a:lstStyle/>
+          <a:p>
+            <a:pPr algn="ctr">
+              <a:spcAft>
+                <a:spcPts val="400"/>
+              </a:spcAft>
+              <a:defRPr sz="1800" b="0" i="0">
+                <a:solidFill>
+                  <a:srgbClr val="4D5A52"/>
+                </a:solidFill>
+                <a:latin typeface="Arial"/>
+              </a:defRPr>
+            </a:pPr>
+            <a:r>
+              <a:t>Golden fixtures keep the Python port tied to the R reference.</a:t>
+            </a:r>
+          </a:p>
+        </p:txBody>
+      </p:sp>
+      <p:sp>
+        <p:nvSpPr>
+          <p:cNvPr id="16" name="Rounded Rectangle 15"/>
           <p:cNvSpPr/>
           <p:nvPr/>
         </p:nvSpPr>
@@ -3664,7 +3703,7 @@
       </p:sp>
       <p:sp>
         <p:nvSpPr>
-          <p:cNvPr id="16" name="TextBox 15"/>
+          <p:cNvPr id="17" name="TextBox 16"/>
           <p:cNvSpPr txBox="1"/>
           <p:nvPr/>
         </p:nvSpPr>
@@ -3703,14 +3742,14 @@
       </p:sp>
       <p:sp>
         <p:nvSpPr>
-          <p:cNvPr id="17" name="TextBox 16"/>
+          <p:cNvPr id="18" name="TextBox 17"/>
           <p:cNvSpPr txBox="1"/>
           <p:nvPr/>
         </p:nvSpPr>
         <p:spPr>
           <a:xfrm>
-            <a:off x="7063740" y="7955280"/>
-            <a:ext cx="4878324" cy="1188720"/>
+            <a:off x="7063740" y="7918704"/>
+            <a:ext cx="4878324" cy="658368"/>
           </a:xfrm>
           <a:prstGeom prst="rect">
             <a:avLst/>
@@ -3742,7 +3781,46 @@
       </p:sp>
       <p:sp>
         <p:nvSpPr>
-          <p:cNvPr id="18" name="TextBox 17"/>
+          <p:cNvPr id="19" name="TextBox 18"/>
+          <p:cNvSpPr txBox="1"/>
+          <p:nvPr/>
+        </p:nvSpPr>
+        <p:spPr>
+          <a:xfrm>
+            <a:off x="7100316" y="8650224"/>
+            <a:ext cx="4805172" cy="484632"/>
+          </a:xfrm>
+          <a:prstGeom prst="rect">
+            <a:avLst/>
+          </a:prstGeom>
+          <a:noFill/>
+        </p:spPr>
+        <p:txBody>
+          <a:bodyPr wrap="square" anchor="t" lIns="45720" rIns="45720" tIns="18288" bIns="18288">
+            <a:spAutoFit/>
+          </a:bodyPr>
+          <a:lstStyle/>
+          <a:p>
+            <a:pPr algn="ctr">
+              <a:spcAft>
+                <a:spcPts val="400"/>
+              </a:spcAft>
+              <a:defRPr sz="1800" b="0" i="0">
+                <a:solidFill>
+                  <a:srgbClr val="4D5A52"/>
+                </a:solidFill>
+                <a:latin typeface="Arial"/>
+              </a:defRPr>
+            </a:pPr>
+            <a:r>
+              <a:t>Designed for notebooks, pipelines, and interactive review.</a:t>
+            </a:r>
+          </a:p>
+        </p:txBody>
+      </p:sp>
+      <p:sp>
+        <p:nvSpPr>
+          <p:cNvPr id="20" name="TextBox 19"/>
           <p:cNvSpPr txBox="1"/>
           <p:nvPr/>
         </p:nvSpPr>
@@ -3781,7 +3859,7 @@
       </p:sp>
       <p:sp>
         <p:nvSpPr>
-          <p:cNvPr id="19" name="Rectangle 18"/>
+          <p:cNvPr id="21" name="Rectangle 20"/>
           <p:cNvSpPr/>
           <p:nvPr/>
         </p:nvSpPr>
@@ -3824,7 +3902,7 @@
       </p:sp>
       <p:sp>
         <p:nvSpPr>
-          <p:cNvPr id="20" name="TextBox 19"/>
+          <p:cNvPr id="22" name="TextBox 21"/>
           <p:cNvSpPr txBox="1"/>
           <p:nvPr/>
         </p:nvSpPr>
@@ -3863,7 +3941,7 @@
       </p:sp>
       <p:sp>
         <p:nvSpPr>
-          <p:cNvPr id="21" name="Rounded Rectangle 20"/>
+          <p:cNvPr id="23" name="Rounded Rectangle 22"/>
           <p:cNvSpPr/>
           <p:nvPr/>
         </p:nvSpPr>
@@ -3908,14 +3986,14 @@
       </p:sp>
       <p:sp>
         <p:nvSpPr>
-          <p:cNvPr id="22" name="TextBox 21"/>
+          <p:cNvPr id="24" name="TextBox 23"/>
           <p:cNvSpPr txBox="1"/>
           <p:nvPr/>
         </p:nvSpPr>
         <p:spPr>
           <a:xfrm>
-            <a:off x="13094208" y="5449824"/>
-            <a:ext cx="5495544" cy="713232"/>
+            <a:off x="13094208" y="5394960"/>
+            <a:ext cx="5495544" cy="658368"/>
           </a:xfrm>
           <a:prstGeom prst="rect">
             <a:avLst/>
@@ -3947,13 +4025,13 @@
       </p:sp>
       <p:sp>
         <p:nvSpPr>
-          <p:cNvPr id="23" name="TextBox 22"/>
+          <p:cNvPr id="25" name="TextBox 24"/>
           <p:cNvSpPr txBox="1"/>
           <p:nvPr/>
         </p:nvSpPr>
         <p:spPr>
           <a:xfrm>
-            <a:off x="13130784" y="6272784"/>
+            <a:off x="13130784" y="6126480"/>
             <a:ext cx="5422392" cy="566928"/>
           </a:xfrm>
           <a:prstGeom prst="rect">
@@ -3986,14 +4064,14 @@
       </p:sp>
       <p:sp>
         <p:nvSpPr>
-          <p:cNvPr id="24" name="TextBox 23"/>
+          <p:cNvPr id="26" name="TextBox 25"/>
           <p:cNvSpPr txBox="1"/>
           <p:nvPr/>
         </p:nvSpPr>
         <p:spPr>
           <a:xfrm>
-            <a:off x="13149072" y="6912864"/>
-            <a:ext cx="5385816" cy="521208"/>
+            <a:off x="13222224" y="6638544"/>
+            <a:ext cx="5239512" cy="384048"/>
           </a:xfrm>
           <a:prstGeom prst="rect">
             <a:avLst/>
@@ -4010,7 +4088,7 @@
               <a:spcAft>
                 <a:spcPts val="400"/>
               </a:spcAft>
-              <a:defRPr sz="1700" b="0" i="0">
+              <a:defRPr sz="1800" b="0" i="0">
                 <a:solidFill>
                   <a:srgbClr val="4D5A52"/>
                 </a:solidFill>
@@ -4025,7 +4103,46 @@
       </p:sp>
       <p:sp>
         <p:nvSpPr>
-          <p:cNvPr id="25" name="Rounded Rectangle 24"/>
+          <p:cNvPr id="27" name="TextBox 26"/>
+          <p:cNvSpPr txBox="1"/>
+          <p:nvPr/>
+        </p:nvSpPr>
+        <p:spPr>
+          <a:xfrm>
+            <a:off x="13240512" y="7022592"/>
+            <a:ext cx="5202936" cy="356616"/>
+          </a:xfrm>
+          <a:prstGeom prst="rect">
+            <a:avLst/>
+          </a:prstGeom>
+          <a:noFill/>
+        </p:spPr>
+        <p:txBody>
+          <a:bodyPr wrap="square" anchor="t" lIns="0" rIns="0" tIns="18288" bIns="18288">
+            <a:spAutoFit/>
+          </a:bodyPr>
+          <a:lstStyle/>
+          <a:p>
+            <a:pPr algn="ctr">
+              <a:spcAft>
+                <a:spcPts val="400"/>
+              </a:spcAft>
+              <a:defRPr sz="1550" b="0" i="0">
+                <a:solidFill>
+                  <a:srgbClr val="4D5A52"/>
+                </a:solidFill>
+                <a:latin typeface="Arial"/>
+              </a:defRPr>
+            </a:pPr>
+            <a:r>
+              <a:t>forced-choice coverage</a:t>
+            </a:r>
+          </a:p>
+        </p:txBody>
+      </p:sp>
+      <p:sp>
+        <p:nvSpPr>
+          <p:cNvPr id="28" name="Rounded Rectangle 27"/>
           <p:cNvSpPr/>
           <p:nvPr/>
         </p:nvSpPr>
@@ -4070,14 +4187,14 @@
       </p:sp>
       <p:sp>
         <p:nvSpPr>
-          <p:cNvPr id="26" name="TextBox 25"/>
+          <p:cNvPr id="29" name="TextBox 28"/>
           <p:cNvSpPr txBox="1"/>
           <p:nvPr/>
         </p:nvSpPr>
         <p:spPr>
           <a:xfrm>
-            <a:off x="19056095" y="5449824"/>
-            <a:ext cx="5495544" cy="713232"/>
+            <a:off x="19056095" y="5394960"/>
+            <a:ext cx="5495544" cy="658368"/>
           </a:xfrm>
           <a:prstGeom prst="rect">
             <a:avLst/>
@@ -4109,13 +4226,13 @@
       </p:sp>
       <p:sp>
         <p:nvSpPr>
-          <p:cNvPr id="27" name="TextBox 26"/>
+          <p:cNvPr id="30" name="TextBox 29"/>
           <p:cNvSpPr txBox="1"/>
           <p:nvPr/>
         </p:nvSpPr>
         <p:spPr>
           <a:xfrm>
-            <a:off x="19092672" y="6272784"/>
+            <a:off x="19092672" y="6126480"/>
             <a:ext cx="5422392" cy="566928"/>
           </a:xfrm>
           <a:prstGeom prst="rect">
@@ -4148,14 +4265,14 @@
       </p:sp>
       <p:sp>
         <p:nvSpPr>
-          <p:cNvPr id="28" name="TextBox 27"/>
+          <p:cNvPr id="31" name="TextBox 30"/>
           <p:cNvSpPr txBox="1"/>
           <p:nvPr/>
         </p:nvSpPr>
         <p:spPr>
           <a:xfrm>
-            <a:off x="19110960" y="6912864"/>
-            <a:ext cx="5385816" cy="521208"/>
+            <a:off x="19184111" y="6638544"/>
+            <a:ext cx="5239512" cy="384048"/>
           </a:xfrm>
           <a:prstGeom prst="rect">
             <a:avLst/>
@@ -4172,7 +4289,7 @@
               <a:spcAft>
                 <a:spcPts val="400"/>
               </a:spcAft>
-              <a:defRPr sz="1700" b="0" i="0">
+              <a:defRPr sz="1800" b="0" i="0">
                 <a:solidFill>
                   <a:srgbClr val="4D5A52"/>
                 </a:solidFill>
@@ -4187,7 +4304,46 @@
       </p:sp>
       <p:sp>
         <p:nvSpPr>
-          <p:cNvPr id="29" name="Rounded Rectangle 28"/>
+          <p:cNvPr id="32" name="TextBox 31"/>
+          <p:cNvSpPr txBox="1"/>
+          <p:nvPr/>
+        </p:nvSpPr>
+        <p:spPr>
+          <a:xfrm>
+            <a:off x="19202399" y="7022592"/>
+            <a:ext cx="5202936" cy="356616"/>
+          </a:xfrm>
+          <a:prstGeom prst="rect">
+            <a:avLst/>
+          </a:prstGeom>
+          <a:noFill/>
+        </p:spPr>
+        <p:txBody>
+          <a:bodyPr wrap="square" anchor="t" lIns="0" rIns="0" tIns="18288" bIns="18288">
+            <a:spAutoFit/>
+          </a:bodyPr>
+          <a:lstStyle/>
+          <a:p>
+            <a:pPr algn="ctr">
+              <a:spcAft>
+                <a:spcPts val="400"/>
+              </a:spcAft>
+              <a:defRPr sz="1550" b="0" i="0">
+                <a:solidFill>
+                  <a:srgbClr val="4D5A52"/>
+                </a:solidFill>
+                <a:latin typeface="Arial"/>
+              </a:defRPr>
+            </a:pPr>
+            <a:r>
+              <a:t>parity + boundary cases</a:t>
+            </a:r>
+          </a:p>
+        </p:txBody>
+      </p:sp>
+      <p:sp>
+        <p:nvSpPr>
+          <p:cNvPr id="33" name="Rounded Rectangle 32"/>
           <p:cNvSpPr/>
           <p:nvPr/>
         </p:nvSpPr>
@@ -4232,14 +4388,14 @@
       </p:sp>
       <p:sp>
         <p:nvSpPr>
-          <p:cNvPr id="30" name="TextBox 29"/>
+          <p:cNvPr id="34" name="TextBox 33"/>
           <p:cNvSpPr txBox="1"/>
           <p:nvPr/>
         </p:nvSpPr>
         <p:spPr>
           <a:xfrm>
-            <a:off x="13094208" y="7946136"/>
-            <a:ext cx="5495544" cy="713232"/>
+            <a:off x="13094208" y="7891271"/>
+            <a:ext cx="5495544" cy="658368"/>
           </a:xfrm>
           <a:prstGeom prst="rect">
             <a:avLst/>
@@ -4271,13 +4427,13 @@
       </p:sp>
       <p:sp>
         <p:nvSpPr>
-          <p:cNvPr id="31" name="TextBox 30"/>
+          <p:cNvPr id="35" name="TextBox 34"/>
           <p:cNvSpPr txBox="1"/>
           <p:nvPr/>
         </p:nvSpPr>
         <p:spPr>
           <a:xfrm>
-            <a:off x="13130784" y="8769096"/>
+            <a:off x="13130784" y="8622792"/>
             <a:ext cx="5422392" cy="566928"/>
           </a:xfrm>
           <a:prstGeom prst="rect">
@@ -4310,14 +4466,14 @@
       </p:sp>
       <p:sp>
         <p:nvSpPr>
-          <p:cNvPr id="32" name="TextBox 31"/>
+          <p:cNvPr id="36" name="TextBox 35"/>
           <p:cNvSpPr txBox="1"/>
           <p:nvPr/>
         </p:nvSpPr>
         <p:spPr>
           <a:xfrm>
-            <a:off x="13149072" y="9409176"/>
-            <a:ext cx="5385816" cy="521208"/>
+            <a:off x="13222224" y="9134856"/>
+            <a:ext cx="5239512" cy="384048"/>
           </a:xfrm>
           <a:prstGeom prst="rect">
             <a:avLst/>
@@ -4334,7 +4490,7 @@
               <a:spcAft>
                 <a:spcPts val="400"/>
               </a:spcAft>
-              <a:defRPr sz="1700" b="0" i="0">
+              <a:defRPr sz="1800" b="0" i="0">
                 <a:solidFill>
                   <a:srgbClr val="4D5A52"/>
                 </a:solidFill>
@@ -4342,6 +4498,45 @@
               </a:defRPr>
             </a:pPr>
             <a:r>
+              <a:t>CRAN reference</a:t>
+            </a:r>
+          </a:p>
+        </p:txBody>
+      </p:sp>
+      <p:sp>
+        <p:nvSpPr>
+          <p:cNvPr id="37" name="TextBox 36"/>
+          <p:cNvSpPr txBox="1"/>
+          <p:nvPr/>
+        </p:nvSpPr>
+        <p:spPr>
+          <a:xfrm>
+            <a:off x="13240512" y="9518904"/>
+            <a:ext cx="5202936" cy="356616"/>
+          </a:xfrm>
+          <a:prstGeom prst="rect">
+            <a:avLst/>
+          </a:prstGeom>
+          <a:noFill/>
+        </p:spPr>
+        <p:txBody>
+          <a:bodyPr wrap="square" anchor="t" lIns="0" rIns="0" tIns="18288" bIns="18288">
+            <a:spAutoFit/>
+          </a:bodyPr>
+          <a:lstStyle/>
+          <a:p>
+            <a:pPr algn="ctr">
+              <a:spcAft>
+                <a:spcPts val="400"/>
+              </a:spcAft>
+              <a:defRPr sz="1550" b="0" i="0">
+                <a:solidFill>
+                  <a:srgbClr val="4D5A52"/>
+                </a:solidFill>
+                <a:latin typeface="Arial"/>
+              </a:defRPr>
+            </a:pPr>
+            <a:r>
               <a:t>golden parity data</a:t>
             </a:r>
           </a:p>
@@ -4349,7 +4544,7 @@
       </p:sp>
       <p:sp>
         <p:nvSpPr>
-          <p:cNvPr id="33" name="Rounded Rectangle 32"/>
+          <p:cNvPr id="38" name="Rounded Rectangle 37"/>
           <p:cNvSpPr/>
           <p:nvPr/>
         </p:nvSpPr>
@@ -4394,14 +4589,14 @@
       </p:sp>
       <p:sp>
         <p:nvSpPr>
-          <p:cNvPr id="34" name="TextBox 33"/>
+          <p:cNvPr id="39" name="TextBox 38"/>
           <p:cNvSpPr txBox="1"/>
           <p:nvPr/>
         </p:nvSpPr>
         <p:spPr>
           <a:xfrm>
-            <a:off x="19056095" y="7946136"/>
-            <a:ext cx="5495544" cy="713232"/>
+            <a:off x="19056095" y="7891271"/>
+            <a:ext cx="5495544" cy="658368"/>
           </a:xfrm>
           <a:prstGeom prst="rect">
             <a:avLst/>
@@ -4433,13 +4628,13 @@
       </p:sp>
       <p:sp>
         <p:nvSpPr>
-          <p:cNvPr id="35" name="TextBox 34"/>
+          <p:cNvPr id="40" name="TextBox 39"/>
           <p:cNvSpPr txBox="1"/>
           <p:nvPr/>
         </p:nvSpPr>
         <p:spPr>
           <a:xfrm>
-            <a:off x="19092672" y="8769096"/>
+            <a:off x="19092672" y="8622792"/>
             <a:ext cx="5422392" cy="566928"/>
           </a:xfrm>
           <a:prstGeom prst="rect">
@@ -4472,14 +4667,14 @@
       </p:sp>
       <p:sp>
         <p:nvSpPr>
-          <p:cNvPr id="36" name="TextBox 35"/>
+          <p:cNvPr id="41" name="TextBox 40"/>
           <p:cNvSpPr txBox="1"/>
           <p:nvPr/>
         </p:nvSpPr>
         <p:spPr>
           <a:xfrm>
-            <a:off x="19110960" y="9409176"/>
-            <a:ext cx="5385816" cy="521208"/>
+            <a:off x="19184111" y="9134856"/>
+            <a:ext cx="5239512" cy="384048"/>
           </a:xfrm>
           <a:prstGeom prst="rect">
             <a:avLst/>
@@ -4496,7 +4691,7 @@
               <a:spcAft>
                 <a:spcPts val="400"/>
               </a:spcAft>
-              <a:defRPr sz="1700" b="0" i="0">
+              <a:defRPr sz="1800" b="0" i="0">
                 <a:solidFill>
                   <a:srgbClr val="4D5A52"/>
                 </a:solidFill>
@@ -4511,7 +4706,46 @@
       </p:sp>
       <p:sp>
         <p:nvSpPr>
-          <p:cNvPr id="37" name="TextBox 36"/>
+          <p:cNvPr id="42" name="TextBox 41"/>
+          <p:cNvSpPr txBox="1"/>
+          <p:nvPr/>
+        </p:nvSpPr>
+        <p:spPr>
+          <a:xfrm>
+            <a:off x="19202399" y="9518904"/>
+            <a:ext cx="5202936" cy="356616"/>
+          </a:xfrm>
+          <a:prstGeom prst="rect">
+            <a:avLst/>
+          </a:prstGeom>
+          <a:noFill/>
+        </p:spPr>
+        <p:txBody>
+          <a:bodyPr wrap="square" anchor="t" lIns="0" rIns="0" tIns="18288" bIns="18288">
+            <a:spAutoFit/>
+          </a:bodyPr>
+          <a:lstStyle/>
+          <a:p>
+            <a:pPr algn="ctr">
+              <a:spcAft>
+                <a:spcPts val="400"/>
+              </a:spcAft>
+              <a:defRPr sz="1550" b="0" i="0">
+                <a:solidFill>
+                  <a:srgbClr val="4D5A52"/>
+                </a:solidFill>
+                <a:latin typeface="Arial"/>
+              </a:defRPr>
+            </a:pPr>
+            <a:r>
+              <a:t>audit-ready outputs</a:t>
+            </a:r>
+          </a:p>
+        </p:txBody>
+      </p:sp>
+      <p:sp>
+        <p:nvSpPr>
+          <p:cNvPr id="43" name="TextBox 42"/>
           <p:cNvSpPr txBox="1"/>
           <p:nvPr/>
         </p:nvSpPr>
@@ -4550,7 +4784,7 @@
       </p:sp>
       <p:sp>
         <p:nvSpPr>
-          <p:cNvPr id="38" name="Rectangle 37"/>
+          <p:cNvPr id="44" name="Rectangle 43"/>
           <p:cNvSpPr/>
           <p:nvPr/>
         </p:nvSpPr>
@@ -4593,7 +4827,7 @@
       </p:sp>
       <p:sp>
         <p:nvSpPr>
-          <p:cNvPr id="39" name="TextBox 38"/>
+          <p:cNvPr id="45" name="TextBox 44"/>
           <p:cNvSpPr txBox="1"/>
           <p:nvPr/>
         </p:nvSpPr>
@@ -4632,7 +4866,7 @@
       </p:sp>
       <p:pic>
         <p:nvPicPr>
-          <p:cNvPr id="40" name="Picture 39" descr="protocol_coverage.png"/>
+          <p:cNvPr id="46" name="Picture 45" descr="protocol_coverage.png"/>
           <p:cNvPicPr>
             <a:picLocks noChangeAspect="1"/>
           </p:cNvPicPr>
@@ -4656,7 +4890,7 @@
       </p:pic>
       <p:sp>
         <p:nvSpPr>
-          <p:cNvPr id="41" name="TextBox 40"/>
+          <p:cNvPr id="47" name="TextBox 46"/>
           <p:cNvSpPr txBox="1"/>
           <p:nvPr/>
         </p:nvSpPr>
@@ -4695,7 +4929,7 @@
       </p:sp>
       <p:sp>
         <p:nvSpPr>
-          <p:cNvPr id="42" name="Rectangle 41"/>
+          <p:cNvPr id="48" name="Rectangle 47"/>
           <p:cNvSpPr/>
           <p:nvPr/>
         </p:nvSpPr>
@@ -4738,7 +4972,7 @@
       </p:sp>
       <p:sp>
         <p:nvSpPr>
-          <p:cNvPr id="43" name="TextBox 42"/>
+          <p:cNvPr id="49" name="TextBox 48"/>
           <p:cNvSpPr txBox="1"/>
           <p:nvPr/>
         </p:nvSpPr>
@@ -4777,7 +5011,7 @@
       </p:sp>
       <p:pic>
         <p:nvPicPr>
-          <p:cNvPr id="44" name="Picture 43" descr="psychometric_curves.png"/>
+          <p:cNvPr id="50" name="Picture 49" descr="psychometric_curves.png"/>
           <p:cNvPicPr>
             <a:picLocks noChangeAspect="1"/>
           </p:cNvPicPr>
@@ -4801,7 +5035,7 @@
       </p:pic>
       <p:sp>
         <p:nvSpPr>
-          <p:cNvPr id="45" name="TextBox 44"/>
+          <p:cNvPr id="51" name="TextBox 50"/>
           <p:cNvSpPr txBox="1"/>
           <p:nvPr/>
         </p:nvSpPr>
@@ -4840,7 +5074,7 @@
       </p:sp>
       <p:sp>
         <p:nvSpPr>
-          <p:cNvPr id="46" name="Rectangle 45"/>
+          <p:cNvPr id="52" name="Rectangle 51"/>
           <p:cNvSpPr/>
           <p:nvPr/>
         </p:nvSpPr>
@@ -4883,7 +5117,7 @@
       </p:sp>
       <p:sp>
         <p:nvSpPr>
-          <p:cNvPr id="47" name="TextBox 46"/>
+          <p:cNvPr id="53" name="TextBox 52"/>
           <p:cNvSpPr txBox="1"/>
           <p:nvPr/>
         </p:nvSpPr>
@@ -4922,7 +5156,7 @@
       </p:sp>
       <p:pic>
         <p:nvPicPr>
-          <p:cNvPr id="48" name="Picture 47" descr="test_inventory.png"/>
+          <p:cNvPr id="54" name="Picture 53" descr="test_inventory.png"/>
           <p:cNvPicPr>
             <a:picLocks noChangeAspect="1"/>
           </p:cNvPicPr>
@@ -4946,7 +5180,7 @@
       </p:pic>
       <p:sp>
         <p:nvSpPr>
-          <p:cNvPr id="49" name="TextBox 48"/>
+          <p:cNvPr id="55" name="TextBox 54"/>
           <p:cNvSpPr txBox="1"/>
           <p:nvPr/>
         </p:nvSpPr>
@@ -4985,7 +5219,7 @@
       </p:sp>
       <p:sp>
         <p:nvSpPr>
-          <p:cNvPr id="50" name="Rectangle 49"/>
+          <p:cNvPr id="56" name="Rectangle 55"/>
           <p:cNvSpPr/>
           <p:nvPr/>
         </p:nvSpPr>
@@ -5028,7 +5262,7 @@
       </p:sp>
       <p:sp>
         <p:nvSpPr>
-          <p:cNvPr id="51" name="TextBox 50"/>
+          <p:cNvPr id="57" name="TextBox 56"/>
           <p:cNvSpPr txBox="1"/>
           <p:nvPr/>
         </p:nvSpPr>
@@ -5067,7 +5301,7 @@
       </p:sp>
       <p:sp>
         <p:nvSpPr>
-          <p:cNvPr id="52" name="Rounded Rectangle 51"/>
+          <p:cNvPr id="58" name="Rounded Rectangle 57"/>
           <p:cNvSpPr/>
           <p:nvPr/>
         </p:nvSpPr>
@@ -5112,14 +5346,14 @@
       </p:sp>
       <p:sp>
         <p:nvSpPr>
-          <p:cNvPr id="53" name="TextBox 52"/>
+          <p:cNvPr id="59" name="TextBox 58"/>
           <p:cNvSpPr txBox="1"/>
           <p:nvPr/>
         </p:nvSpPr>
         <p:spPr>
           <a:xfrm>
-            <a:off x="13094208" y="20537424"/>
-            <a:ext cx="3553967" cy="713232"/>
+            <a:off x="13094208" y="20482560"/>
+            <a:ext cx="3553967" cy="658368"/>
           </a:xfrm>
           <a:prstGeom prst="rect">
             <a:avLst/>
@@ -5151,13 +5385,13 @@
       </p:sp>
       <p:sp>
         <p:nvSpPr>
-          <p:cNvPr id="54" name="TextBox 53"/>
+          <p:cNvPr id="60" name="TextBox 59"/>
           <p:cNvSpPr txBox="1"/>
           <p:nvPr/>
         </p:nvSpPr>
         <p:spPr>
           <a:xfrm>
-            <a:off x="13130784" y="21360384"/>
+            <a:off x="13130784" y="21214080"/>
             <a:ext cx="3480815" cy="566928"/>
           </a:xfrm>
           <a:prstGeom prst="rect">
@@ -5190,14 +5424,14 @@
       </p:sp>
       <p:sp>
         <p:nvSpPr>
-          <p:cNvPr id="55" name="TextBox 54"/>
+          <p:cNvPr id="61" name="TextBox 60"/>
           <p:cNvSpPr txBox="1"/>
           <p:nvPr/>
         </p:nvSpPr>
         <p:spPr>
           <a:xfrm>
-            <a:off x="13149072" y="22000464"/>
-            <a:ext cx="3444239" cy="749808"/>
+            <a:off x="13222224" y="21726144"/>
+            <a:ext cx="3297935" cy="384048"/>
           </a:xfrm>
           <a:prstGeom prst="rect">
             <a:avLst/>
@@ -5214,7 +5448,7 @@
               <a:spcAft>
                 <a:spcPts val="400"/>
               </a:spcAft>
-              <a:defRPr sz="1700" b="0" i="0">
+              <a:defRPr sz="1800" b="0" i="0">
                 <a:solidFill>
                   <a:srgbClr val="4D5A52"/>
                 </a:solidFill>
@@ -5229,7 +5463,46 @@
       </p:sp>
       <p:sp>
         <p:nvSpPr>
-          <p:cNvPr id="56" name="Rounded Rectangle 55"/>
+          <p:cNvPr id="62" name="TextBox 61"/>
+          <p:cNvSpPr txBox="1"/>
+          <p:nvPr/>
+        </p:nvSpPr>
+        <p:spPr>
+          <a:xfrm>
+            <a:off x="13240512" y="22110192"/>
+            <a:ext cx="3261359" cy="585216"/>
+          </a:xfrm>
+          <a:prstGeom prst="rect">
+            <a:avLst/>
+          </a:prstGeom>
+          <a:noFill/>
+        </p:spPr>
+        <p:txBody>
+          <a:bodyPr wrap="square" anchor="t" lIns="0" rIns="0" tIns="18288" bIns="18288">
+            <a:spAutoFit/>
+          </a:bodyPr>
+          <a:lstStyle/>
+          <a:p>
+            <a:pPr algn="ctr">
+              <a:spcAft>
+                <a:spcPts val="400"/>
+              </a:spcAft>
+              <a:defRPr sz="1550" b="0" i="0">
+                <a:solidFill>
+                  <a:srgbClr val="4D5A52"/>
+                </a:solidFill>
+                <a:latin typeface="Arial"/>
+              </a:defRPr>
+            </a:pPr>
+            <a:r>
+              <a:t>panel variability</a:t>
+            </a:r>
+          </a:p>
+        </p:txBody>
+      </p:sp>
+      <p:sp>
+        <p:nvSpPr>
+          <p:cNvPr id="63" name="Rounded Rectangle 62"/>
           <p:cNvSpPr/>
           <p:nvPr/>
         </p:nvSpPr>
@@ -5274,14 +5547,14 @@
       </p:sp>
       <p:sp>
         <p:nvSpPr>
-          <p:cNvPr id="57" name="TextBox 56"/>
+          <p:cNvPr id="64" name="TextBox 63"/>
           <p:cNvSpPr txBox="1"/>
           <p:nvPr/>
         </p:nvSpPr>
         <p:spPr>
           <a:xfrm>
-            <a:off x="17045939" y="20537424"/>
-            <a:ext cx="3553967" cy="713232"/>
+            <a:off x="17045939" y="20482560"/>
+            <a:ext cx="3553967" cy="658368"/>
           </a:xfrm>
           <a:prstGeom prst="rect">
             <a:avLst/>
@@ -5313,13 +5586,13 @@
       </p:sp>
       <p:sp>
         <p:nvSpPr>
-          <p:cNvPr id="58" name="TextBox 57"/>
+          <p:cNvPr id="65" name="TextBox 64"/>
           <p:cNvSpPr txBox="1"/>
           <p:nvPr/>
         </p:nvSpPr>
         <p:spPr>
           <a:xfrm>
-            <a:off x="17082516" y="21360384"/>
+            <a:off x="17082516" y="21214080"/>
             <a:ext cx="3480815" cy="566928"/>
           </a:xfrm>
           <a:prstGeom prst="rect">
@@ -5352,14 +5625,14 @@
       </p:sp>
       <p:sp>
         <p:nvSpPr>
-          <p:cNvPr id="59" name="TextBox 58"/>
+          <p:cNvPr id="66" name="TextBox 65"/>
           <p:cNvSpPr txBox="1"/>
           <p:nvPr/>
         </p:nvSpPr>
         <p:spPr>
           <a:xfrm>
-            <a:off x="17100803" y="22000464"/>
-            <a:ext cx="3444239" cy="749808"/>
+            <a:off x="17173955" y="21726144"/>
+            <a:ext cx="3297935" cy="384048"/>
           </a:xfrm>
           <a:prstGeom prst="rect">
             <a:avLst/>
@@ -5376,7 +5649,7 @@
               <a:spcAft>
                 <a:spcPts val="400"/>
               </a:spcAft>
-              <a:defRPr sz="1700" b="0" i="0">
+              <a:defRPr sz="1800" b="0" i="0">
                 <a:solidFill>
                   <a:srgbClr val="4D5A52"/>
                 </a:solidFill>
@@ -5391,7 +5664,46 @@
       </p:sp>
       <p:sp>
         <p:nvSpPr>
-          <p:cNvPr id="60" name="Rounded Rectangle 59"/>
+          <p:cNvPr id="67" name="TextBox 66"/>
+          <p:cNvSpPr txBox="1"/>
+          <p:nvPr/>
+        </p:nvSpPr>
+        <p:spPr>
+          <a:xfrm>
+            <a:off x="17192243" y="22110192"/>
+            <a:ext cx="3261359" cy="585216"/>
+          </a:xfrm>
+          <a:prstGeom prst="rect">
+            <a:avLst/>
+          </a:prstGeom>
+          <a:noFill/>
+        </p:spPr>
+        <p:txBody>
+          <a:bodyPr wrap="square" anchor="t" lIns="0" rIns="0" tIns="18288" bIns="18288">
+            <a:spAutoFit/>
+          </a:bodyPr>
+          <a:lstStyle/>
+          <a:p>
+            <a:pPr algn="ctr">
+              <a:spcAft>
+                <a:spcPts val="400"/>
+              </a:spcAft>
+              <a:defRPr sz="1550" b="0" i="0">
+                <a:solidFill>
+                  <a:srgbClr val="4D5A52"/>
+                </a:solidFill>
+                <a:latin typeface="Arial"/>
+              </a:defRPr>
+            </a:pPr>
+            <a:r>
+              <a:t>criterion effects</a:t>
+            </a:r>
+          </a:p>
+        </p:txBody>
+      </p:sp>
+      <p:sp>
+        <p:nvSpPr>
+          <p:cNvPr id="68" name="Rounded Rectangle 67"/>
           <p:cNvSpPr/>
           <p:nvPr/>
         </p:nvSpPr>
@@ -5436,14 +5748,14 @@
       </p:sp>
       <p:sp>
         <p:nvSpPr>
-          <p:cNvPr id="61" name="TextBox 60"/>
+          <p:cNvPr id="69" name="TextBox 68"/>
           <p:cNvSpPr txBox="1"/>
           <p:nvPr/>
         </p:nvSpPr>
         <p:spPr>
           <a:xfrm>
-            <a:off x="20997671" y="20537424"/>
-            <a:ext cx="3553967" cy="713232"/>
+            <a:off x="20997671" y="20482560"/>
+            <a:ext cx="3553967" cy="658368"/>
           </a:xfrm>
           <a:prstGeom prst="rect">
             <a:avLst/>
@@ -5475,13 +5787,13 @@
       </p:sp>
       <p:sp>
         <p:nvSpPr>
-          <p:cNvPr id="62" name="TextBox 61"/>
+          <p:cNvPr id="70" name="TextBox 69"/>
           <p:cNvSpPr txBox="1"/>
           <p:nvPr/>
         </p:nvSpPr>
         <p:spPr>
           <a:xfrm>
-            <a:off x="21034248" y="21360384"/>
+            <a:off x="21034248" y="21214080"/>
             <a:ext cx="3480815" cy="566928"/>
           </a:xfrm>
           <a:prstGeom prst="rect">
@@ -5514,14 +5826,14 @@
       </p:sp>
       <p:sp>
         <p:nvSpPr>
-          <p:cNvPr id="63" name="TextBox 62"/>
+          <p:cNvPr id="71" name="TextBox 70"/>
           <p:cNvSpPr txBox="1"/>
           <p:nvPr/>
         </p:nvSpPr>
         <p:spPr>
           <a:xfrm>
-            <a:off x="21052536" y="22000464"/>
-            <a:ext cx="3444239" cy="749808"/>
+            <a:off x="21125688" y="21726144"/>
+            <a:ext cx="3297935" cy="384048"/>
           </a:xfrm>
           <a:prstGeom prst="rect">
             <a:avLst/>
@@ -5538,7 +5850,7 @@
               <a:spcAft>
                 <a:spcPts val="400"/>
               </a:spcAft>
-              <a:defRPr sz="1700" b="0" i="0">
+              <a:defRPr sz="1800" b="0" i="0">
                 <a:solidFill>
                   <a:srgbClr val="4D5A52"/>
                 </a:solidFill>
@@ -5553,7 +5865,46 @@
       </p:sp>
       <p:sp>
         <p:nvSpPr>
-          <p:cNvPr id="64" name="Rounded Rectangle 63"/>
+          <p:cNvPr id="72" name="TextBox 71"/>
+          <p:cNvSpPr txBox="1"/>
+          <p:nvPr/>
+        </p:nvSpPr>
+        <p:spPr>
+          <a:xfrm>
+            <a:off x="21143976" y="22110192"/>
+            <a:ext cx="3261359" cy="585216"/>
+          </a:xfrm>
+          <a:prstGeom prst="rect">
+            <a:avLst/>
+          </a:prstGeom>
+          <a:noFill/>
+        </p:spPr>
+        <p:txBody>
+          <a:bodyPr wrap="square" anchor="t" lIns="0" rIns="0" tIns="18288" bIns="18288">
+            <a:spAutoFit/>
+          </a:bodyPr>
+          <a:lstStyle/>
+          <a:p>
+            <a:pPr algn="ctr">
+              <a:spcAft>
+                <a:spcPts val="400"/>
+              </a:spcAft>
+              <a:defRPr sz="1550" b="0" i="0">
+                <a:solidFill>
+                  <a:srgbClr val="4D5A52"/>
+                </a:solidFill>
+                <a:latin typeface="Arial"/>
+              </a:defRPr>
+            </a:pPr>
+            <a:r>
+              <a:t>decision curves</a:t>
+            </a:r>
+          </a:p>
+        </p:txBody>
+      </p:sp>
+      <p:sp>
+        <p:nvSpPr>
+          <p:cNvPr id="73" name="Rounded Rectangle 72"/>
           <p:cNvSpPr/>
           <p:nvPr/>
         </p:nvSpPr>
@@ -5598,7 +5949,7 @@
       </p:sp>
       <p:sp>
         <p:nvSpPr>
-          <p:cNvPr id="65" name="TextBox 64"/>
+          <p:cNvPr id="74" name="TextBox 73"/>
           <p:cNvSpPr txBox="1"/>
           <p:nvPr/>
         </p:nvSpPr>
@@ -5637,7 +5988,7 @@
       </p:sp>
       <p:sp>
         <p:nvSpPr>
-          <p:cNvPr id="66" name="TextBox 65"/>
+          <p:cNvPr id="75" name="TextBox 74"/>
           <p:cNvSpPr txBox="1"/>
           <p:nvPr/>
         </p:nvSpPr>
@@ -5676,7 +6027,7 @@
       </p:sp>
       <p:sp>
         <p:nvSpPr>
-          <p:cNvPr id="67" name="TextBox 66"/>
+          <p:cNvPr id="76" name="TextBox 75"/>
           <p:cNvSpPr txBox="1"/>
           <p:nvPr/>
         </p:nvSpPr>
@@ -5715,7 +6066,7 @@
       </p:sp>
       <p:sp>
         <p:nvSpPr>
-          <p:cNvPr id="68" name="Rectangle 67"/>
+          <p:cNvPr id="77" name="Rectangle 76"/>
           <p:cNvSpPr/>
           <p:nvPr/>
         </p:nvSpPr>
@@ -5758,7 +6109,7 @@
       </p:sp>
       <p:sp>
         <p:nvSpPr>
-          <p:cNvPr id="69" name="TextBox 68"/>
+          <p:cNvPr id="78" name="TextBox 77"/>
           <p:cNvSpPr txBox="1"/>
           <p:nvPr/>
         </p:nvSpPr>
@@ -5797,7 +6148,7 @@
       </p:sp>
       <p:sp>
         <p:nvSpPr>
-          <p:cNvPr id="70" name="TextBox 69"/>
+          <p:cNvPr id="79" name="TextBox 78"/>
           <p:cNvSpPr txBox="1"/>
           <p:nvPr/>
         </p:nvSpPr>
@@ -5836,7 +6187,7 @@
       </p:sp>
       <p:sp>
         <p:nvSpPr>
-          <p:cNvPr id="71" name="TextBox 70"/>
+          <p:cNvPr id="80" name="TextBox 79"/>
           <p:cNvSpPr txBox="1"/>
           <p:nvPr/>
         </p:nvSpPr>
@@ -5875,7 +6226,7 @@
       </p:sp>
       <p:sp>
         <p:nvSpPr>
-          <p:cNvPr id="72" name="Rounded Rectangle 71"/>
+          <p:cNvPr id="81" name="Rounded Rectangle 80"/>
           <p:cNvSpPr/>
           <p:nvPr/>
         </p:nvSpPr>
@@ -5920,7 +6271,7 @@
       </p:sp>
       <p:sp>
         <p:nvSpPr>
-          <p:cNvPr id="73" name="TextBox 72"/>
+          <p:cNvPr id="82" name="TextBox 81"/>
           <p:cNvSpPr txBox="1"/>
           <p:nvPr/>
         </p:nvSpPr>
@@ -5959,14 +6310,14 @@
       </p:sp>
       <p:sp>
         <p:nvSpPr>
-          <p:cNvPr id="74" name="TextBox 73"/>
+          <p:cNvPr id="83" name="TextBox 82"/>
           <p:cNvSpPr txBox="1"/>
           <p:nvPr/>
         </p:nvSpPr>
         <p:spPr>
           <a:xfrm>
-            <a:off x="1161288" y="31528511"/>
-            <a:ext cx="6952488" cy="1837943"/>
+            <a:off x="1161288" y="31491935"/>
+            <a:ext cx="6952488" cy="868680"/>
           </a:xfrm>
           <a:prstGeom prst="rect">
             <a:avLst/>
@@ -5998,7 +6349,46 @@
       </p:sp>
       <p:sp>
         <p:nvSpPr>
-          <p:cNvPr id="75" name="Rounded Rectangle 74"/>
+          <p:cNvPr id="84" name="TextBox 83"/>
+          <p:cNvSpPr txBox="1"/>
+          <p:nvPr/>
+        </p:nvSpPr>
+        <p:spPr>
+          <a:xfrm>
+            <a:off x="1252728" y="32479487"/>
+            <a:ext cx="6769608" cy="832104"/>
+          </a:xfrm>
+          <a:prstGeom prst="rect">
+            <a:avLst/>
+          </a:prstGeom>
+          <a:noFill/>
+        </p:spPr>
+        <p:txBody>
+          <a:bodyPr wrap="square" anchor="t" lIns="0" rIns="0" tIns="18288" bIns="18288">
+            <a:spAutoFit/>
+          </a:bodyPr>
+          <a:lstStyle/>
+          <a:p>
+            <a:pPr algn="ctr">
+              <a:spcAft>
+                <a:spcPts val="400"/>
+              </a:spcAft>
+              <a:defRPr sz="1800" b="0" i="0">
+                <a:solidFill>
+                  <a:srgbClr val="4D5A52"/>
+                </a:solidFill>
+                <a:latin typeface="Arial"/>
+              </a:defRPr>
+            </a:pPr>
+            <a:r>
+              <a:t>Same statistical contract; modern workflow surface.</a:t>
+            </a:r>
+          </a:p>
+        </p:txBody>
+      </p:sp>
+      <p:sp>
+        <p:nvSpPr>
+          <p:cNvPr id="85" name="Rounded Rectangle 84"/>
           <p:cNvSpPr/>
           <p:nvPr/>
         </p:nvSpPr>
@@ -6043,7 +6433,7 @@
       </p:sp>
       <p:sp>
         <p:nvSpPr>
-          <p:cNvPr id="76" name="TextBox 75"/>
+          <p:cNvPr id="86" name="TextBox 85"/>
           <p:cNvSpPr txBox="1"/>
           <p:nvPr/>
         </p:nvSpPr>
@@ -6082,14 +6472,14 @@
       </p:sp>
       <p:sp>
         <p:nvSpPr>
-          <p:cNvPr id="77" name="TextBox 76"/>
+          <p:cNvPr id="87" name="TextBox 86"/>
           <p:cNvSpPr txBox="1"/>
           <p:nvPr/>
         </p:nvSpPr>
         <p:spPr>
           <a:xfrm>
-            <a:off x="9247632" y="31528511"/>
-            <a:ext cx="6952488" cy="1837943"/>
+            <a:off x="9247632" y="31491935"/>
+            <a:ext cx="6952488" cy="868680"/>
           </a:xfrm>
           <a:prstGeom prst="rect">
             <a:avLst/>
@@ -6121,7 +6511,46 @@
       </p:sp>
       <p:sp>
         <p:nvSpPr>
-          <p:cNvPr id="78" name="Rounded Rectangle 77"/>
+          <p:cNvPr id="88" name="TextBox 87"/>
+          <p:cNvSpPr txBox="1"/>
+          <p:nvPr/>
+        </p:nvSpPr>
+        <p:spPr>
+          <a:xfrm>
+            <a:off x="9339072" y="32479487"/>
+            <a:ext cx="6769608" cy="832104"/>
+          </a:xfrm>
+          <a:prstGeom prst="rect">
+            <a:avLst/>
+          </a:prstGeom>
+          <a:noFill/>
+        </p:spPr>
+        <p:txBody>
+          <a:bodyPr wrap="square" anchor="t" lIns="0" rIns="0" tIns="18288" bIns="18288">
+            <a:spAutoFit/>
+          </a:bodyPr>
+          <a:lstStyle/>
+          <a:p>
+            <a:pPr algn="ctr">
+              <a:spcAft>
+                <a:spcPts val="400"/>
+              </a:spcAft>
+              <a:defRPr sz="1800" b="0" i="0">
+                <a:solidFill>
+                  <a:srgbClr val="4D5A52"/>
+                </a:solidFill>
+                <a:latin typeface="Arial"/>
+              </a:defRPr>
+            </a:pPr>
+            <a:r>
+              <a:t>Protocol differences stay explicit and comparable.</a:t>
+            </a:r>
+          </a:p>
+        </p:txBody>
+      </p:sp>
+      <p:sp>
+        <p:nvSpPr>
+          <p:cNvPr id="89" name="Rounded Rectangle 88"/>
           <p:cNvSpPr/>
           <p:nvPr/>
         </p:nvSpPr>
@@ -6166,7 +6595,7 @@
       </p:sp>
       <p:sp>
         <p:nvSpPr>
-          <p:cNvPr id="79" name="TextBox 78"/>
+          <p:cNvPr id="90" name="TextBox 89"/>
           <p:cNvSpPr txBox="1"/>
           <p:nvPr/>
         </p:nvSpPr>
@@ -6205,14 +6634,14 @@
       </p:sp>
       <p:sp>
         <p:nvSpPr>
-          <p:cNvPr id="80" name="TextBox 79"/>
+          <p:cNvPr id="91" name="TextBox 90"/>
           <p:cNvSpPr txBox="1"/>
           <p:nvPr/>
         </p:nvSpPr>
         <p:spPr>
           <a:xfrm>
-            <a:off x="17333976" y="31528511"/>
-            <a:ext cx="6952488" cy="1837943"/>
+            <a:off x="17333976" y="31491935"/>
+            <a:ext cx="6952488" cy="868680"/>
           </a:xfrm>
           <a:prstGeom prst="rect">
             <a:avLst/>
@@ -6244,14 +6673,14 @@
       </p:sp>
       <p:sp>
         <p:nvSpPr>
-          <p:cNvPr id="81" name="TextBox 80"/>
+          <p:cNvPr id="92" name="TextBox 91"/>
           <p:cNvSpPr txBox="1"/>
           <p:nvPr/>
         </p:nvSpPr>
         <p:spPr>
           <a:xfrm>
-            <a:off x="2240280" y="33878520"/>
-            <a:ext cx="20967192" cy="548640"/>
+            <a:off x="17425416" y="32479487"/>
+            <a:ext cx="6769608" cy="832104"/>
           </a:xfrm>
           <a:prstGeom prst="rect">
             <a:avLst/>
@@ -6259,7 +6688,7 @@
           <a:noFill/>
         </p:spPr>
         <p:txBody>
-          <a:bodyPr wrap="square" anchor="t" lIns="45720" rIns="45720" tIns="18288" bIns="18288">
+          <a:bodyPr wrap="square" anchor="t" lIns="0" rIns="0" tIns="18288" bIns="18288">
             <a:spAutoFit/>
           </a:bodyPr>
           <a:lstStyle/>
@@ -6276,14 +6705,53 @@
               </a:defRPr>
             </a:pPr>
             <a:r>
-              <a:t>Selected references: sensR package; Macmillan &amp; Creelman, Detection Theory; SciPy; Plotly; golden sensR v1.5.3 fixtures.</a:t>
-            </a:r>
-          </a:p>
-        </p:txBody>
-      </p:sp>
-      <p:sp>
-        <p:nvSpPr>
-          <p:cNvPr id="82" name="Rectangle 81"/>
+              <a:t>Results travel as objects, not loose console output.</a:t>
+            </a:r>
+          </a:p>
+        </p:txBody>
+      </p:sp>
+      <p:sp>
+        <p:nvSpPr>
+          <p:cNvPr id="93" name="TextBox 92"/>
+          <p:cNvSpPr txBox="1"/>
+          <p:nvPr/>
+        </p:nvSpPr>
+        <p:spPr>
+          <a:xfrm>
+            <a:off x="2240280" y="33713928"/>
+            <a:ext cx="20967192" cy="749808"/>
+          </a:xfrm>
+          <a:prstGeom prst="rect">
+            <a:avLst/>
+          </a:prstGeom>
+          <a:noFill/>
+        </p:spPr>
+        <p:txBody>
+          <a:bodyPr wrap="square" anchor="t" lIns="45720" rIns="45720" tIns="18288" bIns="18288">
+            <a:spAutoFit/>
+          </a:bodyPr>
+          <a:lstStyle/>
+          <a:p>
+            <a:pPr algn="ctr">
+              <a:spcAft>
+                <a:spcPts val="400"/>
+              </a:spcAft>
+              <a:defRPr sz="1600" b="0" i="0">
+                <a:solidFill>
+                  <a:srgbClr val="4D5A52"/>
+                </a:solidFill>
+                <a:latin typeface="Arial"/>
+              </a:defRPr>
+            </a:pPr>
+            <a:r>
+              <a:t>References: sensR package, CRAN v1.5-3, doi:10.32614/CRAN.package.sensR; Brockhoff &amp; Christensen (2010), doi:10.1016/j.foodqual.2009.04.003; Macmillan &amp; Creelman; SciPy; Plotly.</a:t>
+            </a:r>
+          </a:p>
+        </p:txBody>
+      </p:sp>
+      <p:sp>
+        <p:nvSpPr>
+          <p:cNvPr id="94" name="Rectangle 93"/>
           <p:cNvSpPr/>
           <p:nvPr/>
         </p:nvSpPr>
@@ -6326,7 +6794,7 @@
       </p:sp>
       <p:sp>
         <p:nvSpPr>
-          <p:cNvPr id="83" name="TextBox 82"/>
+          <p:cNvPr id="95" name="TextBox 94"/>
           <p:cNvSpPr txBox="1"/>
           <p:nvPr/>
         </p:nvSpPr>
@@ -6365,7 +6833,7 @@
       </p:sp>
       <p:sp>
         <p:nvSpPr>
-          <p:cNvPr id="84" name="TextBox 83"/>
+          <p:cNvPr id="96" name="TextBox 95"/>
           <p:cNvSpPr txBox="1"/>
           <p:nvPr/>
         </p:nvSpPr>
@@ -6404,7 +6872,7 @@
       </p:sp>
       <p:pic>
         <p:nvPicPr>
-          <p:cNvPr id="85" name="Picture 84" descr="qr-senspy-github.png"/>
+          <p:cNvPr id="97" name="Picture 96" descr="qr-senspy-github.png"/>
           <p:cNvPicPr>
             <a:picLocks noChangeAspect="1"/>
           </p:cNvPicPr>

</xml_diff>

<commit_message>
Add Sensometrics logo to poster
</commit_message>
<xml_diff>
--- a/poster/print_artifacts/senspy-sensometrics-2026-poster.pptx
+++ b/poster/print_artifacts/senspy-sensometrics-2026-poster.pptx
@@ -3334,45 +3334,30 @@
           </a:p>
         </p:txBody>
       </p:sp>
-      <p:sp>
-        <p:nvSpPr>
-          <p:cNvPr id="8" name="TextBox 7"/>
-          <p:cNvSpPr txBox="1"/>
-          <p:nvPr/>
-        </p:nvSpPr>
-        <p:spPr>
-          <a:xfrm>
-            <a:off x="18105120" y="530352"/>
-            <a:ext cx="5852160" cy="502920"/>
-          </a:xfrm>
-          <a:prstGeom prst="rect">
-            <a:avLst/>
-          </a:prstGeom>
-          <a:noFill/>
-        </p:spPr>
-        <p:txBody>
-          <a:bodyPr wrap="square" anchor="t" lIns="45720" rIns="45720" tIns="18288" bIns="18288">
-            <a:spAutoFit/>
-          </a:bodyPr>
-          <a:lstStyle/>
-          <a:p>
-            <a:pPr algn="r">
-              <a:spcAft>
-                <a:spcPts val="400"/>
-              </a:spcAft>
-              <a:defRPr sz="1800" b="0" i="0">
-                <a:solidFill>
-                  <a:srgbClr val="526057"/>
-                </a:solidFill>
-                <a:latin typeface="Arial"/>
-              </a:defRPr>
-            </a:pPr>
-            <a:r>
-              <a:t>Python-native Thurstonian sensory discrimination</a:t>
-            </a:r>
-          </a:p>
-        </p:txBody>
-      </p:sp>
+      <p:pic>
+        <p:nvPicPr>
+          <p:cNvPr id="8" name="Picture 7" descr="sensometrics-2026-logo.png"/>
+          <p:cNvPicPr>
+            <a:picLocks noChangeAspect="1"/>
+          </p:cNvPicPr>
+          <p:nvPr/>
+        </p:nvPicPr>
+        <p:blipFill>
+          <a:blip r:embed="rId2"/>
+          <a:stretch>
+            <a:fillRect/>
+          </a:stretch>
+        </p:blipFill>
+        <p:spPr>
+          <a:xfrm>
+            <a:off x="19340506" y="201168"/>
+            <a:ext cx="5073027" cy="1581912"/>
+          </a:xfrm>
+          <a:prstGeom prst="rect">
+            <a:avLst/>
+          </a:prstGeom>
+        </p:spPr>
+      </p:pic>
       <p:sp>
         <p:nvSpPr>
           <p:cNvPr id="9" name="Rectangle 8"/>
@@ -4873,7 +4858,7 @@
           <p:nvPr/>
         </p:nvPicPr>
         <p:blipFill>
-          <a:blip r:embed="rId2"/>
+          <a:blip r:embed="rId3"/>
           <a:stretch>
             <a:fillRect/>
           </a:stretch>
@@ -5018,7 +5003,7 @@
           <p:nvPr/>
         </p:nvPicPr>
         <p:blipFill>
-          <a:blip r:embed="rId3"/>
+          <a:blip r:embed="rId4"/>
           <a:stretch>
             <a:fillRect/>
           </a:stretch>
@@ -5163,7 +5148,7 @@
           <p:nvPr/>
         </p:nvPicPr>
         <p:blipFill>
-          <a:blip r:embed="rId4"/>
+          <a:blip r:embed="rId5"/>
           <a:stretch>
             <a:fillRect/>
           </a:stretch>
@@ -6879,7 +6864,7 @@
           <p:nvPr/>
         </p:nvPicPr>
         <p:blipFill>
-          <a:blip r:embed="rId5"/>
+          <a:blip r:embed="rId6"/>
           <a:stretch>
             <a:fillRect/>
           </a:stretch>

</xml_diff>

<commit_message>
Polish poster layout spacing
</commit_message>
<xml_diff>
--- a/poster/print_artifacts/senspy-sensometrics-2026-poster.pptx
+++ b/poster/print_artifacts/senspy-sensometrics-2026-poster.pptx
@@ -3350,8 +3350,8 @@
         </p:blipFill>
         <p:spPr>
           <a:xfrm>
-            <a:off x="778186" y="201168"/>
-            <a:ext cx="5073027" cy="1581912"/>
+            <a:off x="960120" y="321367"/>
+            <a:ext cx="4800600" cy="1496961"/>
           </a:xfrm>
           <a:prstGeom prst="rect">
             <a:avLst/>
@@ -3811,7 +3811,7 @@
         </p:nvSpPr>
         <p:spPr>
           <a:xfrm>
-            <a:off x="1097280" y="9646920"/>
+            <a:off x="1097280" y="9811512"/>
             <a:ext cx="11055096" cy="731520"/>
           </a:xfrm>
           <a:prstGeom prst="rect">
@@ -4865,8 +4865,8 @@
         </p:blipFill>
         <p:spPr>
           <a:xfrm>
-            <a:off x="2520866" y="12051792"/>
-            <a:ext cx="8207923" cy="5440680"/>
+            <a:off x="2412405" y="12051792"/>
+            <a:ext cx="8424845" cy="5440680"/>
           </a:xfrm>
           <a:prstGeom prst="rect">
             <a:avLst/>
@@ -5155,8 +5155,8 @@
         </p:blipFill>
         <p:spPr>
           <a:xfrm>
-            <a:off x="1407302" y="20281392"/>
-            <a:ext cx="10435051" cy="5394960"/>
+            <a:off x="1359347" y="20281392"/>
+            <a:ext cx="10530962" cy="5394960"/>
           </a:xfrm>
           <a:prstGeom prst="rect">
             <a:avLst/>

</xml_diff>

<commit_message>
Use BAT poster header logo treatment
</commit_message>
<xml_diff>
--- a/poster/print_artifacts/senspy-sensometrics-2026-poster.pptx
+++ b/poster/print_artifacts/senspy-sensometrics-2026-poster.pptx
@@ -3146,7 +3146,7 @@
             <a:avLst/>
           </a:prstGeom>
           <a:solidFill>
-            <a:srgbClr val="E8E3D8"/>
+            <a:srgbClr val="F7F6F2"/>
           </a:solidFill>
           <a:ln>
             <a:noFill/>
@@ -3225,8 +3225,8 @@
         </p:nvSpPr>
         <p:spPr>
           <a:xfrm>
-            <a:off x="777240" y="320040"/>
-            <a:ext cx="23893272" cy="1463040"/>
+            <a:off x="777240" y="384048"/>
+            <a:ext cx="17373600" cy="914400"/>
           </a:xfrm>
           <a:prstGeom prst="rect">
             <a:avLst/>
@@ -3239,11 +3239,11 @@
           </a:bodyPr>
           <a:lstStyle/>
           <a:p>
-            <a:pPr algn="ctr">
+            <a:pPr algn="l">
               <a:spcAft>
                 <a:spcPts val="400"/>
               </a:spcAft>
-              <a:defRPr sz="9400" b="0" i="0">
+              <a:defRPr sz="5800" b="0" i="0">
                 <a:solidFill>
                   <a:srgbClr val="10231A"/>
                 </a:solidFill>
@@ -3251,7 +3251,7 @@
               </a:defRPr>
             </a:pPr>
             <a:r>
-              <a:t>sensPy</a:t>
+              <a:t>Introducing sensPy</a:t>
             </a:r>
           </a:p>
         </p:txBody>
@@ -3264,8 +3264,8 @@
         </p:nvSpPr>
         <p:spPr>
           <a:xfrm>
-            <a:off x="777240" y="1874519"/>
-            <a:ext cx="23893272" cy="749808"/>
+            <a:off x="777240" y="1417320"/>
+            <a:ext cx="17556480" cy="1152144"/>
           </a:xfrm>
           <a:prstGeom prst="rect">
             <a:avLst/>
@@ -3278,19 +3278,35 @@
           </a:bodyPr>
           <a:lstStyle/>
           <a:p>
-            <a:pPr algn="ctr">
+            <a:pPr algn="l">
               <a:spcAft>
                 <a:spcPts val="400"/>
               </a:spcAft>
-              <a:defRPr sz="3700" b="0" i="0">
+              <a:defRPr sz="3000" b="0" i="0">
                 <a:solidFill>
                   <a:srgbClr val="C7563F"/>
                 </a:solidFill>
-                <a:latin typeface="Arial"/>
+                <a:latin typeface="Georgia"/>
               </a:defRPr>
             </a:pPr>
             <a:r>
-              <a:t>Bringing the gold standard of sensR to the Python sensory ecosystem</a:t>
+              <a:t>Enabling the gold standard analyses of sensR</a:t>
+            </a:r>
+          </a:p>
+          <a:p>
+            <a:pPr algn="l">
+              <a:spcAft>
+                <a:spcPts val="400"/>
+              </a:spcAft>
+              <a:defRPr sz="3000" b="0" i="0">
+                <a:solidFill>
+                  <a:srgbClr val="C7563F"/>
+                </a:solidFill>
+                <a:latin typeface="Georgia"/>
+              </a:defRPr>
+            </a:pPr>
+            <a:r>
+              <a:t>for sensometricians using Python</a:t>
             </a:r>
           </a:p>
         </p:txBody>
@@ -3303,8 +3319,8 @@
         </p:nvSpPr>
         <p:spPr>
           <a:xfrm>
-            <a:off x="777240" y="2971800"/>
-            <a:ext cx="23893272" cy="457200"/>
+            <a:off x="795528" y="2670048"/>
+            <a:ext cx="16916400" cy="292608"/>
           </a:xfrm>
           <a:prstGeom prst="rect">
             <a:avLst/>
@@ -3317,11 +3333,50 @@
           </a:bodyPr>
           <a:lstStyle/>
           <a:p>
-            <a:pPr algn="ctr">
+            <a:pPr algn="l">
               <a:spcAft>
                 <a:spcPts val="400"/>
               </a:spcAft>
-              <a:defRPr sz="2500" b="1" i="0">
+              <a:defRPr sz="1600" b="0" i="0">
+                <a:solidFill>
+                  <a:srgbClr val="526057"/>
+                </a:solidFill>
+                <a:latin typeface="Arial"/>
+              </a:defRPr>
+            </a:pPr>
+            <a:r>
+              <a:t>SciPy-native signal detection tools with sensR parity, typed results, and interactive visualizations</a:t>
+            </a:r>
+          </a:p>
+        </p:txBody>
+      </p:sp>
+      <p:sp>
+        <p:nvSpPr>
+          <p:cNvPr id="8" name="TextBox 7"/>
+          <p:cNvSpPr txBox="1"/>
+          <p:nvPr/>
+        </p:nvSpPr>
+        <p:spPr>
+          <a:xfrm>
+            <a:off x="795528" y="2999232"/>
+            <a:ext cx="16916400" cy="301752"/>
+          </a:xfrm>
+          <a:prstGeom prst="rect">
+            <a:avLst/>
+          </a:prstGeom>
+          <a:noFill/>
+        </p:spPr>
+        <p:txBody>
+          <a:bodyPr wrap="square" anchor="t" lIns="0" rIns="0" tIns="18288" bIns="18288">
+            <a:spAutoFit/>
+          </a:bodyPr>
+          <a:lstStyle/>
+          <a:p>
+            <a:pPr algn="l">
+              <a:spcAft>
+                <a:spcPts val="400"/>
+              </a:spcAft>
+              <a:defRPr sz="1700" b="1" i="0">
                 <a:solidFill>
                   <a:srgbClr val="17291F"/>
                 </a:solidFill>
@@ -3329,14 +3384,53 @@
               </a:defRPr>
             </a:pPr>
             <a:r>
-              <a:t>John M. Ennis and Bartosz Smulski | Aigora | Sensometrics 2026</a:t>
+              <a:t>John M. Ennis¹  |  Bartosz Smulski²</a:t>
+            </a:r>
+          </a:p>
+        </p:txBody>
+      </p:sp>
+      <p:sp>
+        <p:nvSpPr>
+          <p:cNvPr id="9" name="TextBox 8"/>
+          <p:cNvSpPr txBox="1"/>
+          <p:nvPr/>
+        </p:nvSpPr>
+        <p:spPr>
+          <a:xfrm>
+            <a:off x="795528" y="3346704"/>
+            <a:ext cx="16916400" cy="274320"/>
+          </a:xfrm>
+          <a:prstGeom prst="rect">
+            <a:avLst/>
+          </a:prstGeom>
+          <a:noFill/>
+        </p:spPr>
+        <p:txBody>
+          <a:bodyPr wrap="square" anchor="t" lIns="0" rIns="0" tIns="18288" bIns="18288">
+            <a:spAutoFit/>
+          </a:bodyPr>
+          <a:lstStyle/>
+          <a:p>
+            <a:pPr algn="l">
+              <a:spcAft>
+                <a:spcPts val="400"/>
+              </a:spcAft>
+              <a:defRPr sz="1250" b="0" i="0">
+                <a:solidFill>
+                  <a:srgbClr val="405249"/>
+                </a:solidFill>
+                <a:latin typeface="Arial"/>
+              </a:defRPr>
+            </a:pPr>
+            <a:r>
+              <a:t>¹ Aigora, Richmond, United States   |   ² Aigora, Warsaw, Poland</a:t>
             </a:r>
           </a:p>
         </p:txBody>
       </p:sp>
       <p:pic>
         <p:nvPicPr>
-          <p:cNvPr id="8" name="Picture 7" descr="sensometrics-2026-logo.png"/>
+          <p:cNvPr id="10" name="Picture 9" descr="sensometrics-2026-valencia-badge.png"/>
           <p:cNvPicPr>
             <a:picLocks noChangeAspect="1"/>
           </p:cNvPicPr>
@@ -3350,17 +3444,80 @@
         </p:blipFill>
         <p:spPr>
           <a:xfrm>
-            <a:off x="960120" y="321367"/>
-            <a:ext cx="4800600" cy="1496961"/>
+            <a:off x="18888278" y="411480"/>
+            <a:ext cx="5428842" cy="1783080"/>
           </a:xfrm>
           <a:prstGeom prst="rect">
             <a:avLst/>
           </a:prstGeom>
         </p:spPr>
       </p:pic>
-      <p:sp>
-        <p:nvSpPr>
-          <p:cNvPr id="9" name="Rectangle 8"/>
+      <p:pic>
+        <p:nvPicPr>
+          <p:cNvPr id="11" name="Picture 10" descr="aigora-logo-deep-forest.png"/>
+          <p:cNvPicPr>
+            <a:picLocks noChangeAspect="1"/>
+          </p:cNvPicPr>
+          <p:nvPr/>
+        </p:nvPicPr>
+        <p:blipFill>
+          <a:blip r:embed="rId3"/>
+          <a:stretch>
+            <a:fillRect/>
+          </a:stretch>
+        </p:blipFill>
+        <p:spPr>
+          <a:xfrm>
+            <a:off x="19495008" y="2468880"/>
+            <a:ext cx="1115568" cy="1115568"/>
+          </a:xfrm>
+          <a:prstGeom prst="rect">
+            <a:avLst/>
+          </a:prstGeom>
+        </p:spPr>
+      </p:pic>
+      <p:sp>
+        <p:nvSpPr>
+          <p:cNvPr id="12" name="TextBox 11"/>
+          <p:cNvSpPr txBox="1"/>
+          <p:nvPr/>
+        </p:nvSpPr>
+        <p:spPr>
+          <a:xfrm>
+            <a:off x="20820888" y="2359152"/>
+            <a:ext cx="3310128" cy="1225296"/>
+          </a:xfrm>
+          <a:prstGeom prst="rect">
+            <a:avLst/>
+          </a:prstGeom>
+          <a:noFill/>
+        </p:spPr>
+        <p:txBody>
+          <a:bodyPr wrap="square" anchor="t" lIns="0" rIns="0" tIns="18288" bIns="18288">
+            <a:spAutoFit/>
+          </a:bodyPr>
+          <a:lstStyle/>
+          <a:p>
+            <a:pPr algn="l">
+              <a:spcAft>
+                <a:spcPts val="400"/>
+              </a:spcAft>
+              <a:defRPr sz="5000" b="0" i="0">
+                <a:solidFill>
+                  <a:srgbClr val="10231A"/>
+                </a:solidFill>
+                <a:latin typeface="Georgia"/>
+              </a:defRPr>
+            </a:pPr>
+            <a:r>
+              <a:t>aigora</a:t>
+            </a:r>
+          </a:p>
+        </p:txBody>
+      </p:sp>
+      <p:sp>
+        <p:nvSpPr>
+          <p:cNvPr id="13" name="Rectangle 12"/>
           <p:cNvSpPr/>
           <p:nvPr/>
         </p:nvSpPr>
@@ -3403,7 +3560,7 @@
       </p:sp>
       <p:sp>
         <p:nvSpPr>
-          <p:cNvPr id="10" name="TextBox 9"/>
+          <p:cNvPr id="14" name="TextBox 13"/>
           <p:cNvSpPr txBox="1"/>
           <p:nvPr/>
         </p:nvSpPr>
@@ -3442,7 +3599,7 @@
       </p:sp>
       <p:sp>
         <p:nvSpPr>
-          <p:cNvPr id="11" name="TextBox 10"/>
+          <p:cNvPr id="15" name="TextBox 14"/>
           <p:cNvSpPr txBox="1"/>
           <p:nvPr/>
         </p:nvSpPr>
@@ -3481,7 +3638,7 @@
       </p:sp>
       <p:sp>
         <p:nvSpPr>
-          <p:cNvPr id="12" name="Rounded Rectangle 11"/>
+          <p:cNvPr id="16" name="Rounded Rectangle 15"/>
           <p:cNvSpPr/>
           <p:nvPr/>
         </p:nvSpPr>
@@ -3526,7 +3683,7 @@
       </p:sp>
       <p:sp>
         <p:nvSpPr>
-          <p:cNvPr id="13" name="TextBox 12"/>
+          <p:cNvPr id="17" name="TextBox 16"/>
           <p:cNvSpPr txBox="1"/>
           <p:nvPr/>
         </p:nvSpPr>
@@ -3565,7 +3722,7 @@
       </p:sp>
       <p:sp>
         <p:nvSpPr>
-          <p:cNvPr id="14" name="TextBox 13"/>
+          <p:cNvPr id="18" name="TextBox 17"/>
           <p:cNvSpPr txBox="1"/>
           <p:nvPr/>
         </p:nvSpPr>
@@ -3604,7 +3761,7 @@
       </p:sp>
       <p:sp>
         <p:nvSpPr>
-          <p:cNvPr id="15" name="TextBox 14"/>
+          <p:cNvPr id="19" name="TextBox 18"/>
           <p:cNvSpPr txBox="1"/>
           <p:nvPr/>
         </p:nvSpPr>
@@ -3643,7 +3800,7 @@
       </p:sp>
       <p:sp>
         <p:nvSpPr>
-          <p:cNvPr id="16" name="Rounded Rectangle 15"/>
+          <p:cNvPr id="20" name="Rounded Rectangle 19"/>
           <p:cNvSpPr/>
           <p:nvPr/>
         </p:nvSpPr>
@@ -3688,7 +3845,7 @@
       </p:sp>
       <p:sp>
         <p:nvSpPr>
-          <p:cNvPr id="17" name="TextBox 16"/>
+          <p:cNvPr id="21" name="TextBox 20"/>
           <p:cNvSpPr txBox="1"/>
           <p:nvPr/>
         </p:nvSpPr>
@@ -3727,7 +3884,7 @@
       </p:sp>
       <p:sp>
         <p:nvSpPr>
-          <p:cNvPr id="18" name="TextBox 17"/>
+          <p:cNvPr id="22" name="TextBox 21"/>
           <p:cNvSpPr txBox="1"/>
           <p:nvPr/>
         </p:nvSpPr>
@@ -3766,7 +3923,7 @@
       </p:sp>
       <p:sp>
         <p:nvSpPr>
-          <p:cNvPr id="19" name="TextBox 18"/>
+          <p:cNvPr id="23" name="TextBox 22"/>
           <p:cNvSpPr txBox="1"/>
           <p:nvPr/>
         </p:nvSpPr>
@@ -3805,7 +3962,7 @@
       </p:sp>
       <p:sp>
         <p:nvSpPr>
-          <p:cNvPr id="20" name="TextBox 19"/>
+          <p:cNvPr id="24" name="TextBox 23"/>
           <p:cNvSpPr txBox="1"/>
           <p:nvPr/>
         </p:nvSpPr>
@@ -3844,7 +4001,7 @@
       </p:sp>
       <p:sp>
         <p:nvSpPr>
-          <p:cNvPr id="21" name="Rectangle 20"/>
+          <p:cNvPr id="25" name="Rectangle 24"/>
           <p:cNvSpPr/>
           <p:nvPr/>
         </p:nvSpPr>
@@ -3887,7 +4044,7 @@
       </p:sp>
       <p:sp>
         <p:nvSpPr>
-          <p:cNvPr id="22" name="TextBox 21"/>
+          <p:cNvPr id="26" name="TextBox 25"/>
           <p:cNvSpPr txBox="1"/>
           <p:nvPr/>
         </p:nvSpPr>
@@ -3926,7 +4083,7 @@
       </p:sp>
       <p:sp>
         <p:nvSpPr>
-          <p:cNvPr id="23" name="Rounded Rectangle 22"/>
+          <p:cNvPr id="27" name="Rounded Rectangle 26"/>
           <p:cNvSpPr/>
           <p:nvPr/>
         </p:nvSpPr>
@@ -3971,7 +4128,7 @@
       </p:sp>
       <p:sp>
         <p:nvSpPr>
-          <p:cNvPr id="24" name="TextBox 23"/>
+          <p:cNvPr id="28" name="TextBox 27"/>
           <p:cNvSpPr txBox="1"/>
           <p:nvPr/>
         </p:nvSpPr>
@@ -4010,7 +4167,7 @@
       </p:sp>
       <p:sp>
         <p:nvSpPr>
-          <p:cNvPr id="25" name="TextBox 24"/>
+          <p:cNvPr id="29" name="TextBox 28"/>
           <p:cNvSpPr txBox="1"/>
           <p:nvPr/>
         </p:nvSpPr>
@@ -4049,7 +4206,7 @@
       </p:sp>
       <p:sp>
         <p:nvSpPr>
-          <p:cNvPr id="26" name="TextBox 25"/>
+          <p:cNvPr id="30" name="TextBox 29"/>
           <p:cNvSpPr txBox="1"/>
           <p:nvPr/>
         </p:nvSpPr>
@@ -4088,7 +4245,7 @@
       </p:sp>
       <p:sp>
         <p:nvSpPr>
-          <p:cNvPr id="27" name="TextBox 26"/>
+          <p:cNvPr id="31" name="TextBox 30"/>
           <p:cNvSpPr txBox="1"/>
           <p:nvPr/>
         </p:nvSpPr>
@@ -4127,7 +4284,7 @@
       </p:sp>
       <p:sp>
         <p:nvSpPr>
-          <p:cNvPr id="28" name="Rounded Rectangle 27"/>
+          <p:cNvPr id="32" name="Rounded Rectangle 31"/>
           <p:cNvSpPr/>
           <p:nvPr/>
         </p:nvSpPr>
@@ -4172,7 +4329,7 @@
       </p:sp>
       <p:sp>
         <p:nvSpPr>
-          <p:cNvPr id="29" name="TextBox 28"/>
+          <p:cNvPr id="33" name="TextBox 32"/>
           <p:cNvSpPr txBox="1"/>
           <p:nvPr/>
         </p:nvSpPr>
@@ -4211,7 +4368,7 @@
       </p:sp>
       <p:sp>
         <p:nvSpPr>
-          <p:cNvPr id="30" name="TextBox 29"/>
+          <p:cNvPr id="34" name="TextBox 33"/>
           <p:cNvSpPr txBox="1"/>
           <p:nvPr/>
         </p:nvSpPr>
@@ -4250,7 +4407,7 @@
       </p:sp>
       <p:sp>
         <p:nvSpPr>
-          <p:cNvPr id="31" name="TextBox 30"/>
+          <p:cNvPr id="35" name="TextBox 34"/>
           <p:cNvSpPr txBox="1"/>
           <p:nvPr/>
         </p:nvSpPr>
@@ -4289,7 +4446,7 @@
       </p:sp>
       <p:sp>
         <p:nvSpPr>
-          <p:cNvPr id="32" name="TextBox 31"/>
+          <p:cNvPr id="36" name="TextBox 35"/>
           <p:cNvSpPr txBox="1"/>
           <p:nvPr/>
         </p:nvSpPr>
@@ -4328,7 +4485,7 @@
       </p:sp>
       <p:sp>
         <p:nvSpPr>
-          <p:cNvPr id="33" name="Rounded Rectangle 32"/>
+          <p:cNvPr id="37" name="Rounded Rectangle 36"/>
           <p:cNvSpPr/>
           <p:nvPr/>
         </p:nvSpPr>
@@ -4373,7 +4530,7 @@
       </p:sp>
       <p:sp>
         <p:nvSpPr>
-          <p:cNvPr id="34" name="TextBox 33"/>
+          <p:cNvPr id="38" name="TextBox 37"/>
           <p:cNvSpPr txBox="1"/>
           <p:nvPr/>
         </p:nvSpPr>
@@ -4412,7 +4569,7 @@
       </p:sp>
       <p:sp>
         <p:nvSpPr>
-          <p:cNvPr id="35" name="TextBox 34"/>
+          <p:cNvPr id="39" name="TextBox 38"/>
           <p:cNvSpPr txBox="1"/>
           <p:nvPr/>
         </p:nvSpPr>
@@ -4451,7 +4608,7 @@
       </p:sp>
       <p:sp>
         <p:nvSpPr>
-          <p:cNvPr id="36" name="TextBox 35"/>
+          <p:cNvPr id="40" name="TextBox 39"/>
           <p:cNvSpPr txBox="1"/>
           <p:nvPr/>
         </p:nvSpPr>
@@ -4490,7 +4647,7 @@
       </p:sp>
       <p:sp>
         <p:nvSpPr>
-          <p:cNvPr id="37" name="TextBox 36"/>
+          <p:cNvPr id="41" name="TextBox 40"/>
           <p:cNvSpPr txBox="1"/>
           <p:nvPr/>
         </p:nvSpPr>
@@ -4529,7 +4686,7 @@
       </p:sp>
       <p:sp>
         <p:nvSpPr>
-          <p:cNvPr id="38" name="Rounded Rectangle 37"/>
+          <p:cNvPr id="42" name="Rounded Rectangle 41"/>
           <p:cNvSpPr/>
           <p:nvPr/>
         </p:nvSpPr>
@@ -4574,7 +4731,7 @@
       </p:sp>
       <p:sp>
         <p:nvSpPr>
-          <p:cNvPr id="39" name="TextBox 38"/>
+          <p:cNvPr id="43" name="TextBox 42"/>
           <p:cNvSpPr txBox="1"/>
           <p:nvPr/>
         </p:nvSpPr>
@@ -4613,7 +4770,7 @@
       </p:sp>
       <p:sp>
         <p:nvSpPr>
-          <p:cNvPr id="40" name="TextBox 39"/>
+          <p:cNvPr id="44" name="TextBox 43"/>
           <p:cNvSpPr txBox="1"/>
           <p:nvPr/>
         </p:nvSpPr>
@@ -4652,7 +4809,7 @@
       </p:sp>
       <p:sp>
         <p:nvSpPr>
-          <p:cNvPr id="41" name="TextBox 40"/>
+          <p:cNvPr id="45" name="TextBox 44"/>
           <p:cNvSpPr txBox="1"/>
           <p:nvPr/>
         </p:nvSpPr>
@@ -4691,7 +4848,7 @@
       </p:sp>
       <p:sp>
         <p:nvSpPr>
-          <p:cNvPr id="42" name="TextBox 41"/>
+          <p:cNvPr id="46" name="TextBox 45"/>
           <p:cNvSpPr txBox="1"/>
           <p:nvPr/>
         </p:nvSpPr>
@@ -4730,7 +4887,7 @@
       </p:sp>
       <p:sp>
         <p:nvSpPr>
-          <p:cNvPr id="43" name="TextBox 42"/>
+          <p:cNvPr id="47" name="TextBox 46"/>
           <p:cNvSpPr txBox="1"/>
           <p:nvPr/>
         </p:nvSpPr>
@@ -4769,7 +4926,7 @@
       </p:sp>
       <p:sp>
         <p:nvSpPr>
-          <p:cNvPr id="44" name="Rectangle 43"/>
+          <p:cNvPr id="48" name="Rectangle 47"/>
           <p:cNvSpPr/>
           <p:nvPr/>
         </p:nvSpPr>
@@ -4812,7 +4969,7 @@
       </p:sp>
       <p:sp>
         <p:nvSpPr>
-          <p:cNvPr id="45" name="TextBox 44"/>
+          <p:cNvPr id="49" name="TextBox 48"/>
           <p:cNvSpPr txBox="1"/>
           <p:nvPr/>
         </p:nvSpPr>
@@ -4851,14 +5008,14 @@
       </p:sp>
       <p:pic>
         <p:nvPicPr>
-          <p:cNvPr id="46" name="Picture 45" descr="protocol_coverage.png"/>
+          <p:cNvPr id="50" name="Picture 49" descr="protocol_coverage.png"/>
           <p:cNvPicPr>
             <a:picLocks noChangeAspect="1"/>
           </p:cNvPicPr>
           <p:nvPr/>
         </p:nvPicPr>
         <p:blipFill>
-          <a:blip r:embed="rId3"/>
+          <a:blip r:embed="rId4"/>
           <a:stretch>
             <a:fillRect/>
           </a:stretch>
@@ -4875,7 +5032,7 @@
       </p:pic>
       <p:sp>
         <p:nvSpPr>
-          <p:cNvPr id="47" name="TextBox 46"/>
+          <p:cNvPr id="51" name="TextBox 50"/>
           <p:cNvSpPr txBox="1"/>
           <p:nvPr/>
         </p:nvSpPr>
@@ -4914,7 +5071,7 @@
       </p:sp>
       <p:sp>
         <p:nvSpPr>
-          <p:cNvPr id="48" name="Rectangle 47"/>
+          <p:cNvPr id="52" name="Rectangle 51"/>
           <p:cNvSpPr/>
           <p:nvPr/>
         </p:nvSpPr>
@@ -4957,7 +5114,7 @@
       </p:sp>
       <p:sp>
         <p:nvSpPr>
-          <p:cNvPr id="49" name="TextBox 48"/>
+          <p:cNvPr id="53" name="TextBox 52"/>
           <p:cNvSpPr txBox="1"/>
           <p:nvPr/>
         </p:nvSpPr>
@@ -4996,14 +5153,14 @@
       </p:sp>
       <p:pic>
         <p:nvPicPr>
-          <p:cNvPr id="50" name="Picture 49" descr="psychometric_curves.png"/>
+          <p:cNvPr id="54" name="Picture 53" descr="psychometric_curves.png"/>
           <p:cNvPicPr>
             <a:picLocks noChangeAspect="1"/>
           </p:cNvPicPr>
           <p:nvPr/>
         </p:nvPicPr>
         <p:blipFill>
-          <a:blip r:embed="rId4"/>
+          <a:blip r:embed="rId5"/>
           <a:stretch>
             <a:fillRect/>
           </a:stretch>
@@ -5020,7 +5177,7 @@
       </p:pic>
       <p:sp>
         <p:nvSpPr>
-          <p:cNvPr id="51" name="TextBox 50"/>
+          <p:cNvPr id="55" name="TextBox 54"/>
           <p:cNvSpPr txBox="1"/>
           <p:nvPr/>
         </p:nvSpPr>
@@ -5059,7 +5216,7 @@
       </p:sp>
       <p:sp>
         <p:nvSpPr>
-          <p:cNvPr id="52" name="Rectangle 51"/>
+          <p:cNvPr id="56" name="Rectangle 55"/>
           <p:cNvSpPr/>
           <p:nvPr/>
         </p:nvSpPr>
@@ -5102,7 +5259,7 @@
       </p:sp>
       <p:sp>
         <p:nvSpPr>
-          <p:cNvPr id="53" name="TextBox 52"/>
+          <p:cNvPr id="57" name="TextBox 56"/>
           <p:cNvSpPr txBox="1"/>
           <p:nvPr/>
         </p:nvSpPr>
@@ -5141,14 +5298,14 @@
       </p:sp>
       <p:pic>
         <p:nvPicPr>
-          <p:cNvPr id="54" name="Picture 53" descr="test_inventory.png"/>
+          <p:cNvPr id="58" name="Picture 57" descr="test_inventory.png"/>
           <p:cNvPicPr>
             <a:picLocks noChangeAspect="1"/>
           </p:cNvPicPr>
           <p:nvPr/>
         </p:nvPicPr>
         <p:blipFill>
-          <a:blip r:embed="rId5"/>
+          <a:blip r:embed="rId6"/>
           <a:stretch>
             <a:fillRect/>
           </a:stretch>
@@ -5165,7 +5322,7 @@
       </p:pic>
       <p:sp>
         <p:nvSpPr>
-          <p:cNvPr id="55" name="TextBox 54"/>
+          <p:cNvPr id="59" name="TextBox 58"/>
           <p:cNvSpPr txBox="1"/>
           <p:nvPr/>
         </p:nvSpPr>
@@ -5204,7 +5361,7 @@
       </p:sp>
       <p:sp>
         <p:nvSpPr>
-          <p:cNvPr id="56" name="Rectangle 55"/>
+          <p:cNvPr id="60" name="Rectangle 59"/>
           <p:cNvSpPr/>
           <p:nvPr/>
         </p:nvSpPr>
@@ -5247,7 +5404,7 @@
       </p:sp>
       <p:sp>
         <p:nvSpPr>
-          <p:cNvPr id="57" name="TextBox 56"/>
+          <p:cNvPr id="61" name="TextBox 60"/>
           <p:cNvSpPr txBox="1"/>
           <p:nvPr/>
         </p:nvSpPr>
@@ -5286,7 +5443,7 @@
       </p:sp>
       <p:sp>
         <p:nvSpPr>
-          <p:cNvPr id="58" name="Rounded Rectangle 57"/>
+          <p:cNvPr id="62" name="Rounded Rectangle 61"/>
           <p:cNvSpPr/>
           <p:nvPr/>
         </p:nvSpPr>
@@ -5331,7 +5488,7 @@
       </p:sp>
       <p:sp>
         <p:nvSpPr>
-          <p:cNvPr id="59" name="TextBox 58"/>
+          <p:cNvPr id="63" name="TextBox 62"/>
           <p:cNvSpPr txBox="1"/>
           <p:nvPr/>
         </p:nvSpPr>
@@ -5370,7 +5527,7 @@
       </p:sp>
       <p:sp>
         <p:nvSpPr>
-          <p:cNvPr id="60" name="TextBox 59"/>
+          <p:cNvPr id="64" name="TextBox 63"/>
           <p:cNvSpPr txBox="1"/>
           <p:nvPr/>
         </p:nvSpPr>
@@ -5409,7 +5566,7 @@
       </p:sp>
       <p:sp>
         <p:nvSpPr>
-          <p:cNvPr id="61" name="TextBox 60"/>
+          <p:cNvPr id="65" name="TextBox 64"/>
           <p:cNvSpPr txBox="1"/>
           <p:nvPr/>
         </p:nvSpPr>
@@ -5448,7 +5605,7 @@
       </p:sp>
       <p:sp>
         <p:nvSpPr>
-          <p:cNvPr id="62" name="TextBox 61"/>
+          <p:cNvPr id="66" name="TextBox 65"/>
           <p:cNvSpPr txBox="1"/>
           <p:nvPr/>
         </p:nvSpPr>
@@ -5487,7 +5644,7 @@
       </p:sp>
       <p:sp>
         <p:nvSpPr>
-          <p:cNvPr id="63" name="Rounded Rectangle 62"/>
+          <p:cNvPr id="67" name="Rounded Rectangle 66"/>
           <p:cNvSpPr/>
           <p:nvPr/>
         </p:nvSpPr>
@@ -5532,7 +5689,7 @@
       </p:sp>
       <p:sp>
         <p:nvSpPr>
-          <p:cNvPr id="64" name="TextBox 63"/>
+          <p:cNvPr id="68" name="TextBox 67"/>
           <p:cNvSpPr txBox="1"/>
           <p:nvPr/>
         </p:nvSpPr>
@@ -5571,7 +5728,7 @@
       </p:sp>
       <p:sp>
         <p:nvSpPr>
-          <p:cNvPr id="65" name="TextBox 64"/>
+          <p:cNvPr id="69" name="TextBox 68"/>
           <p:cNvSpPr txBox="1"/>
           <p:nvPr/>
         </p:nvSpPr>
@@ -5610,7 +5767,7 @@
       </p:sp>
       <p:sp>
         <p:nvSpPr>
-          <p:cNvPr id="66" name="TextBox 65"/>
+          <p:cNvPr id="70" name="TextBox 69"/>
           <p:cNvSpPr txBox="1"/>
           <p:nvPr/>
         </p:nvSpPr>
@@ -5649,7 +5806,7 @@
       </p:sp>
       <p:sp>
         <p:nvSpPr>
-          <p:cNvPr id="67" name="TextBox 66"/>
+          <p:cNvPr id="71" name="TextBox 70"/>
           <p:cNvSpPr txBox="1"/>
           <p:nvPr/>
         </p:nvSpPr>
@@ -5688,7 +5845,7 @@
       </p:sp>
       <p:sp>
         <p:nvSpPr>
-          <p:cNvPr id="68" name="Rounded Rectangle 67"/>
+          <p:cNvPr id="72" name="Rounded Rectangle 71"/>
           <p:cNvSpPr/>
           <p:nvPr/>
         </p:nvSpPr>
@@ -5733,7 +5890,7 @@
       </p:sp>
       <p:sp>
         <p:nvSpPr>
-          <p:cNvPr id="69" name="TextBox 68"/>
+          <p:cNvPr id="73" name="TextBox 72"/>
           <p:cNvSpPr txBox="1"/>
           <p:nvPr/>
         </p:nvSpPr>
@@ -5772,7 +5929,7 @@
       </p:sp>
       <p:sp>
         <p:nvSpPr>
-          <p:cNvPr id="70" name="TextBox 69"/>
+          <p:cNvPr id="74" name="TextBox 73"/>
           <p:cNvSpPr txBox="1"/>
           <p:nvPr/>
         </p:nvSpPr>
@@ -5811,7 +5968,7 @@
       </p:sp>
       <p:sp>
         <p:nvSpPr>
-          <p:cNvPr id="71" name="TextBox 70"/>
+          <p:cNvPr id="75" name="TextBox 74"/>
           <p:cNvSpPr txBox="1"/>
           <p:nvPr/>
         </p:nvSpPr>
@@ -5850,7 +6007,7 @@
       </p:sp>
       <p:sp>
         <p:nvSpPr>
-          <p:cNvPr id="72" name="TextBox 71"/>
+          <p:cNvPr id="76" name="TextBox 75"/>
           <p:cNvSpPr txBox="1"/>
           <p:nvPr/>
         </p:nvSpPr>
@@ -5889,7 +6046,7 @@
       </p:sp>
       <p:sp>
         <p:nvSpPr>
-          <p:cNvPr id="73" name="Rounded Rectangle 72"/>
+          <p:cNvPr id="77" name="Rounded Rectangle 76"/>
           <p:cNvSpPr/>
           <p:nvPr/>
         </p:nvSpPr>
@@ -5934,7 +6091,7 @@
       </p:sp>
       <p:sp>
         <p:nvSpPr>
-          <p:cNvPr id="74" name="TextBox 73"/>
+          <p:cNvPr id="78" name="TextBox 77"/>
           <p:cNvSpPr txBox="1"/>
           <p:nvPr/>
         </p:nvSpPr>
@@ -5973,7 +6130,7 @@
       </p:sp>
       <p:sp>
         <p:nvSpPr>
-          <p:cNvPr id="75" name="TextBox 74"/>
+          <p:cNvPr id="79" name="TextBox 78"/>
           <p:cNvSpPr txBox="1"/>
           <p:nvPr/>
         </p:nvSpPr>
@@ -6012,7 +6169,7 @@
       </p:sp>
       <p:sp>
         <p:nvSpPr>
-          <p:cNvPr id="76" name="TextBox 75"/>
+          <p:cNvPr id="80" name="TextBox 79"/>
           <p:cNvSpPr txBox="1"/>
           <p:nvPr/>
         </p:nvSpPr>
@@ -6051,7 +6208,7 @@
       </p:sp>
       <p:sp>
         <p:nvSpPr>
-          <p:cNvPr id="77" name="Rectangle 76"/>
+          <p:cNvPr id="81" name="Rectangle 80"/>
           <p:cNvSpPr/>
           <p:nvPr/>
         </p:nvSpPr>
@@ -6094,7 +6251,7 @@
       </p:sp>
       <p:sp>
         <p:nvSpPr>
-          <p:cNvPr id="78" name="TextBox 77"/>
+          <p:cNvPr id="82" name="TextBox 81"/>
           <p:cNvSpPr txBox="1"/>
           <p:nvPr/>
         </p:nvSpPr>
@@ -6133,7 +6290,7 @@
       </p:sp>
       <p:sp>
         <p:nvSpPr>
-          <p:cNvPr id="79" name="TextBox 78"/>
+          <p:cNvPr id="83" name="TextBox 82"/>
           <p:cNvSpPr txBox="1"/>
           <p:nvPr/>
         </p:nvSpPr>
@@ -6172,7 +6329,7 @@
       </p:sp>
       <p:sp>
         <p:nvSpPr>
-          <p:cNvPr id="80" name="TextBox 79"/>
+          <p:cNvPr id="84" name="TextBox 83"/>
           <p:cNvSpPr txBox="1"/>
           <p:nvPr/>
         </p:nvSpPr>
@@ -6211,7 +6368,7 @@
       </p:sp>
       <p:sp>
         <p:nvSpPr>
-          <p:cNvPr id="81" name="Rounded Rectangle 80"/>
+          <p:cNvPr id="85" name="Rounded Rectangle 84"/>
           <p:cNvSpPr/>
           <p:nvPr/>
         </p:nvSpPr>
@@ -6256,7 +6413,7 @@
       </p:sp>
       <p:sp>
         <p:nvSpPr>
-          <p:cNvPr id="82" name="TextBox 81"/>
+          <p:cNvPr id="86" name="TextBox 85"/>
           <p:cNvSpPr txBox="1"/>
           <p:nvPr/>
         </p:nvSpPr>
@@ -6295,7 +6452,7 @@
       </p:sp>
       <p:sp>
         <p:nvSpPr>
-          <p:cNvPr id="83" name="TextBox 82"/>
+          <p:cNvPr id="87" name="TextBox 86"/>
           <p:cNvSpPr txBox="1"/>
           <p:nvPr/>
         </p:nvSpPr>
@@ -6334,7 +6491,7 @@
       </p:sp>
       <p:sp>
         <p:nvSpPr>
-          <p:cNvPr id="84" name="TextBox 83"/>
+          <p:cNvPr id="88" name="TextBox 87"/>
           <p:cNvSpPr txBox="1"/>
           <p:nvPr/>
         </p:nvSpPr>
@@ -6373,7 +6530,7 @@
       </p:sp>
       <p:sp>
         <p:nvSpPr>
-          <p:cNvPr id="85" name="Rounded Rectangle 84"/>
+          <p:cNvPr id="89" name="Rounded Rectangle 88"/>
           <p:cNvSpPr/>
           <p:nvPr/>
         </p:nvSpPr>
@@ -6418,7 +6575,7 @@
       </p:sp>
       <p:sp>
         <p:nvSpPr>
-          <p:cNvPr id="86" name="TextBox 85"/>
+          <p:cNvPr id="90" name="TextBox 89"/>
           <p:cNvSpPr txBox="1"/>
           <p:nvPr/>
         </p:nvSpPr>
@@ -6457,7 +6614,7 @@
       </p:sp>
       <p:sp>
         <p:nvSpPr>
-          <p:cNvPr id="87" name="TextBox 86"/>
+          <p:cNvPr id="91" name="TextBox 90"/>
           <p:cNvSpPr txBox="1"/>
           <p:nvPr/>
         </p:nvSpPr>
@@ -6496,7 +6653,7 @@
       </p:sp>
       <p:sp>
         <p:nvSpPr>
-          <p:cNvPr id="88" name="TextBox 87"/>
+          <p:cNvPr id="92" name="TextBox 91"/>
           <p:cNvSpPr txBox="1"/>
           <p:nvPr/>
         </p:nvSpPr>
@@ -6535,7 +6692,7 @@
       </p:sp>
       <p:sp>
         <p:nvSpPr>
-          <p:cNvPr id="89" name="Rounded Rectangle 88"/>
+          <p:cNvPr id="93" name="Rounded Rectangle 92"/>
           <p:cNvSpPr/>
           <p:nvPr/>
         </p:nvSpPr>
@@ -6580,7 +6737,7 @@
       </p:sp>
       <p:sp>
         <p:nvSpPr>
-          <p:cNvPr id="90" name="TextBox 89"/>
+          <p:cNvPr id="94" name="TextBox 93"/>
           <p:cNvSpPr txBox="1"/>
           <p:nvPr/>
         </p:nvSpPr>
@@ -6619,7 +6776,7 @@
       </p:sp>
       <p:sp>
         <p:nvSpPr>
-          <p:cNvPr id="91" name="TextBox 90"/>
+          <p:cNvPr id="95" name="TextBox 94"/>
           <p:cNvSpPr txBox="1"/>
           <p:nvPr/>
         </p:nvSpPr>
@@ -6658,7 +6815,7 @@
       </p:sp>
       <p:sp>
         <p:nvSpPr>
-          <p:cNvPr id="92" name="TextBox 91"/>
+          <p:cNvPr id="96" name="TextBox 95"/>
           <p:cNvSpPr txBox="1"/>
           <p:nvPr/>
         </p:nvSpPr>
@@ -6697,7 +6854,7 @@
       </p:sp>
       <p:sp>
         <p:nvSpPr>
-          <p:cNvPr id="93" name="TextBox 92"/>
+          <p:cNvPr id="97" name="TextBox 96"/>
           <p:cNvSpPr txBox="1"/>
           <p:nvPr/>
         </p:nvSpPr>
@@ -6736,7 +6893,7 @@
       </p:sp>
       <p:sp>
         <p:nvSpPr>
-          <p:cNvPr id="94" name="Rectangle 93"/>
+          <p:cNvPr id="98" name="Rectangle 97"/>
           <p:cNvSpPr/>
           <p:nvPr/>
         </p:nvSpPr>
@@ -6779,7 +6936,7 @@
       </p:sp>
       <p:sp>
         <p:nvSpPr>
-          <p:cNvPr id="95" name="TextBox 94"/>
+          <p:cNvPr id="99" name="TextBox 98"/>
           <p:cNvSpPr txBox="1"/>
           <p:nvPr/>
         </p:nvSpPr>
@@ -6818,7 +6975,7 @@
       </p:sp>
       <p:sp>
         <p:nvSpPr>
-          <p:cNvPr id="96" name="TextBox 95"/>
+          <p:cNvPr id="100" name="TextBox 99"/>
           <p:cNvSpPr txBox="1"/>
           <p:nvPr/>
         </p:nvSpPr>
@@ -6857,14 +7014,14 @@
       </p:sp>
       <p:pic>
         <p:nvPicPr>
-          <p:cNvPr id="97" name="Picture 96" descr="qr-senspy-github.png"/>
+          <p:cNvPr id="101" name="Picture 100" descr="qr-senspy-github.png"/>
           <p:cNvPicPr>
             <a:picLocks noChangeAspect="1"/>
           </p:cNvPicPr>
           <p:nvPr/>
         </p:nvPicPr>
         <p:blipFill>
-          <a:blip r:embed="rId6"/>
+          <a:blip r:embed="rId7"/>
           <a:stretch>
             <a:fillRect/>
           </a:stretch>

</xml_diff>